<commit_message>
docs: reflect the AWS adapters and Terraform in report, README and deck
</commit_message>
<xml_diff>
--- a/presentation/KGCR_Review2.pptx
+++ b/presentation/KGCR_Review2.pptx
@@ -120,39 +120,39 @@
   <p:extLst>
     <p:ext uri="{521415D9-36F7-43E2-AB2F-B90AF26B5E84}">
       <p14:sectionLst xmlns:p14="http://schemas.microsoft.com/office/powerpoint/2010/main">
-        <p14:section name="Opening" id="{bbdea99c-92c4-8e00-bd8b-a2501fccb21c}">
+        <p14:section name="Opening" id="{38f68f7c-ca1e-5cca-4cef-c1a2d916d693}">
           <p14:sldIdLst>
             <p14:sldId id="256"/>
           </p14:sldIdLst>
         </p14:section>
-        <p14:section name="Problem and gap" id="{134936ee-143c-e530-9fc5-b3e988882223}">
+        <p14:section name="Problem and gap" id="{a118412a-d2a8-3094-f8aa-8cac65076aea}">
           <p14:sldIdLst>
             <p14:sldId id="257"/>
             <p14:sldId id="258"/>
           </p14:sldIdLst>
         </p14:section>
-        <p14:section name="Plan" id="{7e90aba1-5515-0081-8e94-05fe65a8a23b}">
+        <p14:section name="Plan" id="{614ceca6-7e2d-c711-6d37-8293f0558824}">
           <p14:sldIdLst>
             <p14:sldId id="259"/>
           </p14:sldIdLst>
         </p14:section>
-        <p14:section name="Architecture" id="{0ac56e99-1b51-4e85-93c9-6a553b115519}">
+        <p14:section name="Architecture" id="{94130cb5-2917-fbcf-bd19-dee9529fe5f5}">
           <p14:sldIdLst>
             <p14:sldId id="260"/>
             <p14:sldId id="261"/>
           </p14:sldIdLst>
         </p14:section>
-        <p14:section name="Data" id="{5b4f2f34-1cf8-a738-0d4c-c488ff541435}">
+        <p14:section name="Data" id="{551167ad-9426-0327-4974-a23d2397fda1}">
           <p14:sldIdLst>
             <p14:sldId id="262"/>
           </p14:sldIdLst>
         </p14:section>
-        <p14:section name="Implementation" id="{0d1b2186-3a32-aa2c-cead-7644bc9b223e}">
+        <p14:section name="Implementation" id="{f97d46ab-30c7-b2f4-3ce3-358569d3748d}">
           <p14:sldIdLst>
             <p14:sldId id="263"/>
           </p14:sldIdLst>
         </p14:section>
-        <p14:section name="Results" id="{4590d3e1-cb3e-e5cb-7127-f75055ff649b}">
+        <p14:section name="Results" id="{83bbef86-5d45-9e4c-28de-e23861f85efe}">
           <p14:sldIdLst>
             <p14:sldId id="264"/>
             <p14:sldId id="265"/>
@@ -160,12 +160,12 @@
             <p14:sldId id="267"/>
           </p14:sldIdLst>
         </p14:section>
-        <p14:section name="Cloud" id="{cf2f0400-bf5e-4021-ca9c-66e91972a14b}">
+        <p14:section name="Cloud" id="{02a1aa1e-0083-1f39-0ebc-cfb7ba58f1ba}">
           <p14:sldIdLst>
             <p14:sldId id="268"/>
           </p14:sldIdLst>
         </p14:section>
-        <p14:section name="Close" id="{135c87ec-1fc5-4fbe-c617-eac8ef407541}">
+        <p14:section name="Close" id="{30a5988a-90a8-fcc6-3f86-93bdbc5d9ee7}">
           <p14:sldIdLst>
             <p14:sldId id="269"/>
           </p14:sldIdLst>
@@ -4363,7 +4363,7 @@
                   <a:schemeClr val="tx1"/>
                 </a:solidFill>
               </a:rPr>
-              <a:t>S3 run bucket: local artifact store</a:t>
+              <a:t>S3 run bucket: local directory by default</a:t>
             </a:r>
             <a:endParaRPr lang="en-US" sz="1400" dirty="0"/>
           </a:p>
@@ -4381,7 +4381,7 @@
                   <a:schemeClr val="tx1"/>
                 </a:solidFill>
               </a:rPr>
-              <a:t>SNS: logged notification</a:t>
+              <a:t>SNS: logged notification by default</a:t>
             </a:r>
             <a:endParaRPr lang="en-US" sz="1400" dirty="0"/>
           </a:p>
@@ -4598,6 +4598,42 @@
                 </a:solidFill>
               </a:rPr>
               <a:t>AWS Budgets alarms at 5, 15 and 30 USD</a:t>
+            </a:r>
+            <a:endParaRPr lang="en-US" sz="1400" dirty="0"/>
+          </a:p>
+          <a:p>
+            <a:pPr marL="342900" indent="-342900">
+              <a:spcAft>
+                <a:spcPts val="800"/>
+              </a:spcAft>
+              <a:buSzPct val="100000"/>
+              <a:buChar char="•"/>
+            </a:pPr>
+            <a:r>
+              <a:rPr lang="en-US" sz="1400" dirty="0">
+                <a:solidFill>
+                  <a:schemeClr val="tx1"/>
+                </a:solidFill>
+              </a:rPr>
+              <a:t>S3 run bucket and SNS topic, adapters tested on mocked AWS</a:t>
+            </a:r>
+            <a:endParaRPr lang="en-US" sz="1400" dirty="0"/>
+          </a:p>
+          <a:p>
+            <a:pPr marL="342900" indent="-342900">
+              <a:spcAft>
+                <a:spcPts val="800"/>
+              </a:spcAft>
+              <a:buSzPct val="100000"/>
+              <a:buChar char="•"/>
+            </a:pPr>
+            <a:r>
+              <a:rPr lang="en-US" sz="1400" dirty="0">
+                <a:solidFill>
+                  <a:schemeClr val="tx1"/>
+                </a:solidFill>
+              </a:rPr>
+              <a:t>Least-privilege publish policy</a:t>
             </a:r>
             <a:endParaRPr lang="en-US" sz="1400" dirty="0"/>
           </a:p>
@@ -4973,7 +5009,7 @@
                   <a:schemeClr val="accent6"/>
                 </a:solidFill>
               </a:rPr>
-              <a:t>Next: run the sycophancy gate live, review and verify L1, wire S3 and SNS behind the existing interfaces.</a:t>
+              <a:t>Next: run the sycophancy gate live, review and verify L1, validate and apply the Terraform in a sandbox.</a:t>
             </a:r>
             <a:endParaRPr lang="en-US" sz="1800" dirty="0"/>
           </a:p>
@@ -7401,7 +7437,7 @@
                   <a:schemeClr val="tx1"/>
                 </a:solidFill>
               </a:rPr>
-              <a:t>Today: IAM and Budgets exist as Terraform; S3, SNS and Config have local stand-ins.</a:t>
+              <a:t>Today: IAM, Budgets, the run bucket and topic exist as Terraform, unapplied; harvest is a local stand-in.</a:t>
             </a:r>
             <a:endParaRPr lang="en-US" sz="1400" dirty="0"/>
           </a:p>
@@ -9165,7 +9201,7 @@
                   <a:schemeClr val="tx1"/>
                 </a:solidFill>
               </a:rPr>
-              <a:t>151 tests; ruff, ruff format, mypy (strict) and pytest all pass with PYTHONHASHSEED=0.</a:t>
+              <a:t>155 tests; ruff, ruff format, mypy (strict) and pytest all pass with PYTHONHASHSEED=0.</a:t>
             </a:r>
             <a:endParaRPr lang="en-US" sz="1500" dirty="0"/>
           </a:p>

</xml_diff>

<commit_message>
docs(presentation): verbatim demo output and gate status read from the report
Slide 12 quotes real CLI lines, with elisions marked and the LLM: disabled
marker kept. Its explanation line is labelled as an excerpt. Slides 8, 10
and 14 take the sycophancy gate state from results/advisor_report.json, so
a rebuild after the live run shows the actual outcome.
</commit_message>
<xml_diff>
--- a/presentation/KGCR_Review2.pptx
+++ b/presentation/KGCR_Review2.pptx
@@ -120,39 +120,39 @@
   <p:extLst>
     <p:ext uri="{521415D9-36F7-43E2-AB2F-B90AF26B5E84}">
       <p14:sectionLst xmlns:p14="http://schemas.microsoft.com/office/powerpoint/2010/main">
-        <p14:section name="Opening" id="{38f68f7c-ca1e-5cca-4cef-c1a2d916d693}">
+        <p14:section name="Opening" id="{ed87f44c-174f-8838-d3f8-034ae25b33e9}">
           <p14:sldIdLst>
             <p14:sldId id="256"/>
           </p14:sldIdLst>
         </p14:section>
-        <p14:section name="Problem and gap" id="{a118412a-d2a8-3094-f8aa-8cac65076aea}">
+        <p14:section name="Problem and gap" id="{cd5c4ceb-3c31-96e3-9a89-b5b0489c8aa1}">
           <p14:sldIdLst>
             <p14:sldId id="257"/>
             <p14:sldId id="258"/>
           </p14:sldIdLst>
         </p14:section>
-        <p14:section name="Plan" id="{614ceca6-7e2d-c711-6d37-8293f0558824}">
+        <p14:section name="Plan" id="{ab42d79f-ef11-8a18-7c2f-afaf637b0c21}">
           <p14:sldIdLst>
             <p14:sldId id="259"/>
           </p14:sldIdLst>
         </p14:section>
-        <p14:section name="Architecture" id="{94130cb5-2917-fbcf-bd19-dee9529fe5f5}">
+        <p14:section name="Architecture" id="{5203a884-b850-d873-cb43-e7d64dfdd3cf}">
           <p14:sldIdLst>
             <p14:sldId id="260"/>
             <p14:sldId id="261"/>
           </p14:sldIdLst>
         </p14:section>
-        <p14:section name="Data" id="{551167ad-9426-0327-4974-a23d2397fda1}">
+        <p14:section name="Data" id="{5ee50052-ed14-ba94-5aaf-aa6af7b700e9}">
           <p14:sldIdLst>
             <p14:sldId id="262"/>
           </p14:sldIdLst>
         </p14:section>
-        <p14:section name="Implementation" id="{f97d46ab-30c7-b2f4-3ce3-358569d3748d}">
+        <p14:section name="Implementation" id="{eef610e6-2c66-0fb8-9091-b161156eca0a}">
           <p14:sldIdLst>
             <p14:sldId id="263"/>
           </p14:sldIdLst>
         </p14:section>
-        <p14:section name="Results" id="{83bbef86-5d45-9e4c-28de-e23861f85efe}">
+        <p14:section name="Results" id="{9acae94e-acea-eb13-0835-0d85adce1a38}">
           <p14:sldIdLst>
             <p14:sldId id="264"/>
             <p14:sldId id="265"/>
@@ -160,12 +160,12 @@
             <p14:sldId id="267"/>
           </p14:sldIdLst>
         </p14:section>
-        <p14:section name="Cloud" id="{02a1aa1e-0083-1f39-0ebc-cfb7ba58f1ba}">
+        <p14:section name="Cloud" id="{0b1bbb07-c57d-fe19-2d95-0e8805abd743}">
           <p14:sldIdLst>
             <p14:sldId id="268"/>
           </p14:sldIdLst>
         </p14:section>
-        <p14:section name="Close" id="{30a5988a-90a8-fcc6-3f86-93bdbc5d9ee7}">
+        <p14:section name="Close" id="{47310f79-8226-bc47-0af5-b1f863aeee5b}">
           <p14:sldIdLst>
             <p14:sldId id="269"/>
           </p14:sldIdLst>
@@ -3906,8 +3906,8 @@
         </p:nvSpPr>
         <p:spPr>
           <a:xfrm>
-            <a:off x="548640" y="1371600"/>
-            <a:ext cx="11064240" cy="2377440"/>
+            <a:off x="548640" y="1280160"/>
+            <a:ext cx="11064240" cy="2514600"/>
           </a:xfrm>
           <a:prstGeom prst="rect">
             <a:avLst/>
@@ -3918,14 +3918,14 @@
           <a:ln/>
         </p:spPr>
         <p:txBody>
-          <a:bodyPr wrap="square" lIns="177800" tIns="177800" rIns="177800" bIns="177800" rtlCol="0" anchor="ctr"/>
+          <a:bodyPr wrap="square" lIns="152400" tIns="152400" rIns="152400" bIns="152400" rtlCol="0" anchor="ctr"/>
           <a:lstStyle/>
           <a:p>
             <a:pPr indent="0" marL="0">
               <a:buNone/>
             </a:pPr>
             <a:r>
-              <a:rPr lang="en-US" sz="1400" dirty="0">
+              <a:rPr lang="en-US" sz="1300" dirty="0">
                 <a:solidFill>
                   <a:schemeClr val="bg1"/>
                 </a:solidFill>
@@ -3933,16 +3933,16 @@
                 <a:ea typeface="Courier New" pitchFamily="34" charset="-122"/>
                 <a:cs typeface="Courier New" pitchFamily="34" charset="-120"/>
               </a:rPr>
-              <a:t>[1/6] harvest   estate fd6f7a9427c6ffa4, held-out split, 17 resources</a:t>
-            </a:r>
-            <a:endParaRPr lang="en-US" sz="1400" dirty="0"/>
+              <a:t>[1/6] harvest   local stand-in for AWS Config (no AWS call)</a:t>
+            </a:r>
+            <a:endParaRPr lang="en-US" sz="1300" dirty="0"/>
           </a:p>
           <a:p>
             <a:pPr indent="0" marL="0">
               <a:buNone/>
             </a:pPr>
             <a:r>
-              <a:rPr lang="en-US" sz="1400" dirty="0">
+              <a:rPr lang="en-US" sz="1300" dirty="0">
                 <a:solidFill>
                   <a:schemeClr val="bg1"/>
                 </a:solidFill>
@@ -3950,16 +3950,16 @@
                 <a:ea typeface="Courier New" pitchFamily="34" charset="-122"/>
                 <a:cs typeface="Courier New" pitchFamily="34" charset="-120"/>
               </a:rPr>
-              <a:t>      injected for the demo: unencrypted_database (DF-2)</a:t>
-            </a:r>
-            <a:endParaRPr lang="en-US" sz="1400" dirty="0"/>
+              <a:t>      estate fd6f7a9427c6ffa4, held-out split, 17 resources</a:t>
+            </a:r>
+            <a:endParaRPr lang="en-US" sz="1300" dirty="0"/>
           </a:p>
           <a:p>
             <a:pPr indent="0" marL="0">
               <a:buNone/>
             </a:pPr>
             <a:r>
-              <a:rPr lang="en-US" sz="1400" dirty="0">
+              <a:rPr lang="en-US" sz="1300" dirty="0">
                 <a:solidFill>
                   <a:schemeClr val="bg1"/>
                 </a:solidFill>
@@ -3967,16 +3967,16 @@
                 <a:ea typeface="Courier New" pitchFamily="34" charset="-122"/>
                 <a:cs typeface="Courier New" pitchFamily="34" charset="-120"/>
               </a:rPr>
-              <a:t>[3/6] intent    archetype=payments_api ... (iam_shape: confirm with user)</a:t>
-            </a:r>
-            <a:endParaRPr lang="en-US" sz="1400" dirty="0"/>
+              <a:t>      injected for the demo: unencrypted_database (DF-2)</a:t>
+            </a:r>
+            <a:endParaRPr lang="en-US" sz="1300" dirty="0"/>
           </a:p>
           <a:p>
             <a:pPr indent="0" marL="0">
               <a:buNone/>
             </a:pPr>
             <a:r>
-              <a:rPr lang="en-US" sz="1400" dirty="0">
+              <a:rPr lang="en-US" sz="1300" dirty="0">
                 <a:solidFill>
                   <a:schemeClr val="bg1"/>
                 </a:solidFill>
@@ -3984,16 +3984,16 @@
                 <a:ea typeface="Courier New" pitchFamily="34" charset="-122"/>
                 <a:cs typeface="Courier New" pitchFamily="34" charset="-120"/>
               </a:rPr>
-              <a:t>[4/6] recommend recommended, not in estate: storage_encrypted=True</a:t>
-            </a:r>
-            <a:endParaRPr lang="en-US" sz="1400" dirty="0"/>
+              <a:t>[3/6] intent    archetype=payments_api, az_spread=three_az, ...</a:t>
+            </a:r>
+            <a:endParaRPr lang="en-US" sz="1300" dirty="0"/>
           </a:p>
           <a:p>
             <a:pPr indent="0" marL="0">
               <a:buNone/>
             </a:pPr>
             <a:r>
-              <a:rPr lang="en-US" sz="1400" dirty="0">
+              <a:rPr lang="en-US" sz="1300" dirty="0">
                 <a:solidFill>
                   <a:schemeClr val="bg1"/>
                 </a:solidFill>
@@ -4001,16 +4001,16 @@
                 <a:ea typeface="Courier New" pitchFamily="34" charset="-122"/>
                 <a:cs typeface="Courier New" pitchFamily="34" charset="-120"/>
               </a:rPr>
-              <a:t>[5/6] advise    loop CONVERGED (CLEAN) after 2 pass(es)</a:t>
-            </a:r>
-            <a:endParaRPr lang="en-US" sz="1400" dirty="0"/>
+              <a:t>      low confidence, confirm with the user: iam_shape</a:t>
+            </a:r>
+            <a:endParaRPr lang="en-US" sz="1300" dirty="0"/>
           </a:p>
           <a:p>
             <a:pPr indent="0" marL="0">
               <a:buNone/>
             </a:pPr>
             <a:r>
-              <a:rPr lang="en-US" sz="1400" dirty="0">
+              <a:rPr lang="en-US" sz="1300" dirty="0">
                 <a:solidFill>
                   <a:schemeClr val="bg1"/>
                 </a:solidFill>
@@ -4018,16 +4018,16 @@
                 <a:ea typeface="Courier New" pitchFamily="34" charset="-122"/>
                 <a:cs typeface="Courier New" pitchFamily="34" charset="-120"/>
               </a:rPr>
-              <a:t>      [CRITICAL] kg://control/pci-dss-v4/3.5.1 on aws_db_instance.cardholder</a:t>
-            </a:r>
-            <a:endParaRPr lang="en-US" sz="1400" dirty="0"/>
+              <a:t>[4/6] recommend ...</a:t>
+            </a:r>
+            <a:endParaRPr lang="en-US" sz="1300" dirty="0"/>
           </a:p>
           <a:p>
             <a:pPr indent="0" marL="0">
               <a:buNone/>
             </a:pPr>
             <a:r>
-              <a:rPr lang="en-US" sz="1400" dirty="0">
+              <a:rPr lang="en-US" sz="1300" dirty="0">
                 <a:solidFill>
                   <a:schemeClr val="bg1"/>
                 </a:solidFill>
@@ -4035,9 +4035,43 @@
                 <a:ea typeface="Courier New" pitchFamily="34" charset="-122"/>
                 <a:cs typeface="Courier New" pitchFamily="34" charset="-120"/>
               </a:rPr>
-              <a:t>[6/6] explain   fix tested: align with compliant template -&gt; RESOLVED</a:t>
-            </a:r>
-            <a:endParaRPr lang="en-US" sz="1400" dirty="0"/>
+              <a:t>      recommended, not in estate: ('aws_db_instance', 'storage_encrypted', 'True')</a:t>
+            </a:r>
+            <a:endParaRPr lang="en-US" sz="1300" dirty="0"/>
+          </a:p>
+          <a:p>
+            <a:pPr indent="0" marL="0">
+              <a:buNone/>
+            </a:pPr>
+            <a:r>
+              <a:rPr lang="en-US" sz="1300" dirty="0">
+                <a:solidFill>
+                  <a:schemeClr val="bg1"/>
+                </a:solidFill>
+                <a:latin typeface="Courier New" pitchFamily="34" charset="0"/>
+                <a:ea typeface="Courier New" pitchFamily="34" charset="-122"/>
+                <a:cs typeface="Courier New" pitchFamily="34" charset="-120"/>
+              </a:rPr>
+              <a:t>[5/6] advise    LLM: disabled; loop CONVERGED (CLEAN) after 2 pass(es)</a:t>
+            </a:r>
+            <a:endParaRPr lang="en-US" sz="1300" dirty="0"/>
+          </a:p>
+          <a:p>
+            <a:pPr indent="0" marL="0">
+              <a:buNone/>
+            </a:pPr>
+            <a:r>
+              <a:rPr lang="en-US" sz="1300" dirty="0">
+                <a:solidFill>
+                  <a:schemeClr val="bg1"/>
+                </a:solidFill>
+                <a:latin typeface="Courier New" pitchFamily="34" charset="0"/>
+                <a:ea typeface="Courier New" pitchFamily="34" charset="-122"/>
+                <a:cs typeface="Courier New" pitchFamily="34" charset="-120"/>
+              </a:rPr>
+              <a:t>      [CRITICAL] kg://control/pci-dss-v4/3.5.1 on aws_db_instance.cardholder (rule)</a:t>
+            </a:r>
+            <a:endParaRPr lang="en-US" sz="1300" dirty="0"/>
           </a:p>
         </p:txBody>
       </p:sp>
@@ -4049,8 +4083,85 @@
         </p:nvSpPr>
         <p:spPr>
           <a:xfrm>
-            <a:off x="548640" y="4069080"/>
-            <a:ext cx="11064240" cy="1554480"/>
+            <a:off x="548640" y="3931920"/>
+            <a:ext cx="11064240" cy="320040"/>
+          </a:xfrm>
+          <a:prstGeom prst="rect">
+            <a:avLst/>
+          </a:prstGeom>
+          <a:noFill/>
+          <a:ln/>
+        </p:spPr>
+        <p:txBody>
+          <a:bodyPr wrap="square" lIns="0" tIns="0" rIns="0" bIns="0" rtlCol="0" anchor="ctr"/>
+          <a:lstStyle/>
+          <a:p>
+            <a:pPr indent="0" marL="0">
+              <a:buNone/>
+            </a:pPr>
+            <a:r>
+              <a:rPr lang="en-US" sz="1200" i="1" dirty="0">
+                <a:solidFill>
+                  <a:schemeClr val="accent3"/>
+                </a:solidFill>
+              </a:rPr>
+              <a:t>From the stored auditor explanation (explanation_auditor.md):</a:t>
+            </a:r>
+            <a:endParaRPr lang="en-US" sz="1200" dirty="0"/>
+          </a:p>
+        </p:txBody>
+      </p:sp>
+      <p:sp>
+        <p:nvSpPr>
+          <p:cNvPr id="5" name="Text 3"/>
+          <p:cNvSpPr txBox="1"/>
+          <p:nvPr/>
+        </p:nvSpPr>
+        <p:spPr>
+          <a:xfrm>
+            <a:off x="548640" y="4279392"/>
+            <a:ext cx="11064240" cy="685800"/>
+          </a:xfrm>
+          <a:prstGeom prst="rect">
+            <a:avLst/>
+          </a:prstGeom>
+          <a:solidFill>
+            <a:schemeClr val="bg2"/>
+          </a:solidFill>
+          <a:ln/>
+        </p:spPr>
+        <p:txBody>
+          <a:bodyPr wrap="square" lIns="152400" tIns="152400" rIns="152400" bIns="152400" rtlCol="0" anchor="ctr"/>
+          <a:lstStyle/>
+          <a:p>
+            <a:pPr indent="0" marL="0">
+              <a:buNone/>
+            </a:pPr>
+            <a:r>
+              <a:rPr lang="en-US" sz="1300" dirty="0">
+                <a:solidFill>
+                  <a:schemeClr val="tx1"/>
+                </a:solidFill>
+                <a:latin typeface="Courier New" pitchFamily="34" charset="0"/>
+                <a:ea typeface="Courier New" pitchFamily="34" charset="-122"/>
+                <a:cs typeface="Courier New" pitchFamily="34" charset="-120"/>
+              </a:rPr>
+              <a:t>Remediation tested: align aws_db_instance.cardholder with the compliant template. Outcome: RESOLVED; single-resource rules pass after the change.</a:t>
+            </a:r>
+            <a:endParaRPr lang="en-US" sz="1300" dirty="0"/>
+          </a:p>
+        </p:txBody>
+      </p:sp>
+      <p:sp>
+        <p:nvSpPr>
+          <p:cNvPr id="6" name="Text 4"/>
+          <p:cNvSpPr txBox="1"/>
+          <p:nvPr/>
+        </p:nvSpPr>
+        <p:spPr>
+          <a:xfrm>
+            <a:off x="548640" y="5120640"/>
+            <a:ext cx="11064240" cy="1097280"/>
           </a:xfrm>
           <a:prstGeom prst="rect">
             <a:avLst/>
@@ -4075,7 +4186,7 @@
                   <a:schemeClr val="tx1"/>
                 </a:solidFill>
               </a:rPr>
-              <a:t>The recommender and the advisor reach the same conclusion independently, from different inputs.</a:t>
+              <a:t>The recommender and the advisor flag the same setting independently, from different inputs.</a:t>
             </a:r>
             <a:endParaRPr lang="en-US" sz="1500" dirty="0"/>
           </a:p>
@@ -4093,25 +4204,7 @@
                   <a:schemeClr val="tx1"/>
                 </a:solidFill>
               </a:rPr>
-              <a:t>The patcher repairs the spec and the second pass is clean, so the loop converges.</a:t>
-            </a:r>
-            <a:endParaRPr lang="en-US" sz="1500" dirty="0"/>
-          </a:p>
-          <a:p>
-            <a:pPr marL="342900" indent="-342900">
-              <a:spcAft>
-                <a:spcPts val="600"/>
-              </a:spcAft>
-              <a:buSzPct val="100000"/>
-              <a:buChar char="•"/>
-            </a:pPr>
-            <a:r>
-              <a:rPr lang="en-US" sz="1500" dirty="0">
-                <a:solidFill>
-                  <a:schemeClr val="tx1"/>
-                </a:solidFill>
-              </a:rPr>
-              <a:t>A DF-7 run converges with no findings under the rule floor, and says so in its scope note.</a:t>
+              <a:t>Without the LLM, a DF-7 run finds nothing; its stored explanation says so in a scope note.</a:t>
             </a:r>
             <a:endParaRPr lang="en-US" sz="1500" dirty="0"/>
           </a:p>
@@ -4995,7 +5088,7 @@
                   <a:schemeClr val="accent6"/>
                 </a:solidFill>
               </a:rPr>
-              <a:t>Limits: synthetic corpus; draft L1 awaiting review; LLM gate not run; no cost model.</a:t>
+              <a:t>Limits: synthetic corpus; draft L1 awaiting review; sycophancy gate not run yet; no cost model.</a:t>
             </a:r>
             <a:endParaRPr lang="en-US" sz="1800" dirty="0"/>
           </a:p>

</xml_diff>

<commit_message>
docs(report): contribution matrix as built; refresh deck, README and dataset docx
Co-Authored-By: Claude Sonnet 5.5 <noreply@anthropic.com>
</commit_message>
<xml_diff>
--- a/presentation/KGCR_Review2.pptx
+++ b/presentation/KGCR_Review2.pptx
@@ -4,6 +4,9 @@
   <p:sldMasterIdLst>
     <p:sldMasterId id="2147483648" r:id="rId1"/>
   </p:sldMasterIdLst>
+  <p:notesMasterIdLst>
+    <p:notesMasterId r:id="rId16"/>
+  </p:notesMasterIdLst>
   <p:sldIdLst>
     <p:sldId id="256" r:id="rId2"/>
     <p:sldId id="257" r:id="rId3"/>
@@ -20,9 +23,6 @@
     <p:sldId id="268" r:id="rId14"/>
     <p:sldId id="269" r:id="rId15"/>
   </p:sldIdLst>
-  <p:notesMasterIdLst>
-    <p:notesMasterId r:id="rId16"/>
-  </p:notesMasterIdLst>
   <p:sldSz cx="12192000" cy="6858000"/>
   <p:notesSz cx="6858000" cy="12192000"/>
   <p:defaultTextStyle>
@@ -120,39 +120,39 @@
   <p:extLst>
     <p:ext uri="{521415D9-36F7-43E2-AB2F-B90AF26B5E84}">
       <p14:sectionLst xmlns:p14="http://schemas.microsoft.com/office/powerpoint/2010/main">
-        <p14:section name="Opening" id="{ed87f44c-174f-8838-d3f8-034ae25b33e9}">
+        <p14:section name="Opening" id="{ED87F44C-174F-8838-D3F8-034AE25B33E9}">
           <p14:sldIdLst>
             <p14:sldId id="256"/>
           </p14:sldIdLst>
         </p14:section>
-        <p14:section name="Problem and gap" id="{cd5c4ceb-3c31-96e3-9a89-b5b0489c8aa1}">
+        <p14:section name="Problem and gap" id="{CD5C4CEB-3C31-96E3-9A89-B5B0489C8AA1}">
           <p14:sldIdLst>
             <p14:sldId id="257"/>
             <p14:sldId id="258"/>
           </p14:sldIdLst>
         </p14:section>
-        <p14:section name="Plan" id="{ab42d79f-ef11-8a18-7c2f-afaf637b0c21}">
+        <p14:section name="Plan" id="{AB42D79F-EF11-8A18-7C2F-AFAF637B0C21}">
           <p14:sldIdLst>
             <p14:sldId id="259"/>
           </p14:sldIdLst>
         </p14:section>
-        <p14:section name="Architecture" id="{5203a884-b850-d873-cb43-e7d64dfdd3cf}">
+        <p14:section name="Architecture" id="{5203A884-B850-D873-CB43-E7D64DFDD3CF}">
           <p14:sldIdLst>
             <p14:sldId id="260"/>
             <p14:sldId id="261"/>
           </p14:sldIdLst>
         </p14:section>
-        <p14:section name="Data" id="{5ee50052-ed14-ba94-5aaf-aa6af7b700e9}">
+        <p14:section name="Data" id="{5EE50052-ED14-BA94-5AAF-AA6AF7B700E9}">
           <p14:sldIdLst>
             <p14:sldId id="262"/>
           </p14:sldIdLst>
         </p14:section>
-        <p14:section name="Implementation" id="{eef610e6-2c66-0fb8-9091-b161156eca0a}">
+        <p14:section name="Implementation" id="{EEF610E6-2C66-0FB8-9091-B161156ECA0A}">
           <p14:sldIdLst>
             <p14:sldId id="263"/>
           </p14:sldIdLst>
         </p14:section>
-        <p14:section name="Results" id="{9acae94e-acea-eb13-0835-0d85adce1a38}">
+        <p14:section name="Results" id="{9ACAE94E-ACEA-EB13-0835-0D85ADCE1A38}">
           <p14:sldIdLst>
             <p14:sldId id="264"/>
             <p14:sldId id="265"/>
@@ -160,12 +160,12 @@
             <p14:sldId id="267"/>
           </p14:sldIdLst>
         </p14:section>
-        <p14:section name="Cloud" id="{0b1bbb07-c57d-fe19-2d95-0e8805abd743}">
+        <p14:section name="Cloud" id="{0B1BBB07-C57D-FE19-2D95-0E8805ABD743}">
           <p14:sldIdLst>
             <p14:sldId id="268"/>
           </p14:sldIdLst>
         </p14:section>
-        <p14:section name="Close" id="{47310f79-8226-bc47-0af5-b1f863aeee5b}">
+        <p14:section name="Close" id="{47310F79-8226-BC47-0AF5-B1F863AEEE5B}">
           <p14:sldIdLst>
             <p14:sldId id="269"/>
           </p14:sldIdLst>
@@ -180,9 +180,11 @@
 </file>
 
 <file path=ppt/charts/chart1.xml><?xml version="1.0" encoding="utf-8"?>
-<c:chartSpace xmlns:c="http://schemas.openxmlformats.org/drawingml/2006/chart" xmlns:a="http://schemas.openxmlformats.org/drawingml/2006/main" xmlns:r="http://schemas.openxmlformats.org/officeDocument/2006/relationships">
+<c:chartSpace xmlns:c="http://schemas.openxmlformats.org/drawingml/2006/chart" xmlns:a="http://schemas.openxmlformats.org/drawingml/2006/main" xmlns:r="http://schemas.openxmlformats.org/officeDocument/2006/relationships" xmlns:c16r2="http://schemas.microsoft.com/office/drawing/2015/06/chart">
   <c:date1904 val="0"/>
+  <c:lang val="en-US"/>
   <c:roundedCorners val="1"/>
+  <c:style val="2"/>
   <c:chart>
     <c:title>
       <c:tx>
@@ -210,7 +212,6 @@
           </a:p>
         </c:rich>
       </c:tx>
-      <c:layout/>
       <c:overlay val="0"/>
     </c:title>
     <c:autoTitleDeleted val="0"/>
@@ -243,18 +244,26 @@
           <c:invertIfNegative val="0"/>
           <c:dLbls>
             <c:numFmt formatCode="0.000" sourceLinked="0"/>
+            <c:spPr>
+              <a:noFill/>
+              <a:ln>
+                <a:noFill/>
+              </a:ln>
+              <a:effectLst/>
+            </c:spPr>
             <c:txPr>
               <a:bodyPr/>
               <a:lstStyle/>
               <a:p>
                 <a:pPr>
-                  <a:defRPr b="0" i="0" strike="noStrike" sz="1200" u="none">
+                  <a:defRPr sz="1200" b="0" i="0" u="none" strike="noStrike">
                     <a:solidFill>
                       <a:srgbClr val="1B2A2F"/>
                     </a:solidFill>
                     <a:latin typeface="+mn-lt"/>
                   </a:defRPr>
                 </a:pPr>
+                <a:endParaRPr lang="en-US"/>
               </a:p>
             </c:txPr>
             <c:showLegendKey val="0"/>
@@ -264,28 +273,31 @@
             <c:showPercent val="0"/>
             <c:showBubbleSize val="0"/>
             <c:showLeaderLines val="0"/>
+            <c:extLst>
+              <c:ext xmlns:c15="http://schemas.microsoft.com/office/drawing/2012/chart" uri="{CE6537A1-D6FC-4f65-9D91-7224C49458BB}">
+                <c15:showLeaderLines val="0"/>
+              </c:ext>
+            </c:extLst>
           </c:dLbls>
           <c:cat>
-            <c:multiLvlStrRef>
+            <c:strRef>
               <c:f>Sheet1!$A$2:$A$5</c:f>
-              <c:multiLvlStrCache>
+              <c:strCache>
                 <c:ptCount val="4"/>
-                <c:lvl>
-                  <c:pt idx="0">
-                    <c:v>Popularity</c:v>
-                  </c:pt>
-                  <c:pt idx="1">
-                    <c:v>Per-archetype</c:v>
-                  </c:pt>
-                  <c:pt idx="2">
-                    <c:v>Model, true intent</c:v>
-                  </c:pt>
-                  <c:pt idx="3">
-                    <c:v>Model, reconstructed intent</c:v>
-                  </c:pt>
-                </c:lvl>
-              </c:multiLvlStrCache>
-            </c:multiLvlStrRef>
+                <c:pt idx="0">
+                  <c:v>Popularity</c:v>
+                </c:pt>
+                <c:pt idx="1">
+                  <c:v>Per-archetype</c:v>
+                </c:pt>
+                <c:pt idx="2">
+                  <c:v>Model, true intent</c:v>
+                </c:pt>
+                <c:pt idx="3">
+                  <c:v>Model, reconstructed intent</c:v>
+                </c:pt>
+              </c:strCache>
+            </c:strRef>
           </c:cat>
           <c:val>
             <c:numRef>
@@ -297,47 +309,34 @@
                   <c:v>0</c:v>
                 </c:pt>
                 <c:pt idx="1">
-                  <c:v>0.2083</c:v>
+                  <c:v>0.20830000000000001</c:v>
                 </c:pt>
                 <c:pt idx="2">
-                  <c:v>0.9583</c:v>
+                  <c:v>0.95830000000000004</c:v>
                 </c:pt>
                 <c:pt idx="3">
-                  <c:v>0.9583</c:v>
+                  <c:v>0.95830000000000004</c:v>
                 </c:pt>
               </c:numCache>
             </c:numRef>
           </c:val>
+          <c:extLst>
+            <c:ext xmlns:c16="http://schemas.microsoft.com/office/drawing/2014/chart" uri="{C3380CC4-5D6E-409C-BE32-E72D297353CC}">
+              <c16:uniqueId val="{00000000-0F76-40A1-948F-82CFE5C7A957}"/>
+            </c:ext>
+          </c:extLst>
         </c:ser>
         <c:dLbls>
-          <c:numFmt formatCode="0.000" sourceLinked="0"/>
-          <c:txPr>
-            <a:bodyPr/>
-            <a:lstStyle/>
-            <a:p>
-              <a:pPr>
-                <a:defRPr b="0" i="0" strike="noStrike" sz="1200" u="none">
-                  <a:solidFill>
-                    <a:srgbClr val="1B2A2F"/>
-                  </a:solidFill>
-                  <a:latin typeface="+mn-lt"/>
-                </a:defRPr>
-              </a:pPr>
-            </a:p>
-          </c:txPr>
           <c:showLegendKey val="0"/>
           <c:showVal val="1"/>
           <c:showCatName val="0"/>
           <c:showSerName val="0"/>
           <c:showPercent val="0"/>
           <c:showBubbleSize val="0"/>
-          <c:showLeaderLines val="0"/>
         </c:dLbls>
         <c:gapWidth val="150"/>
-        <c:overlap val="0"/>
         <c:axId val="2094734554"/>
         <c:axId val="2094734552"/>
-        <c:axId val="2094734556"/>
       </c:barChart>
       <c:catAx>
         <c:axId val="2094734554"/>
@@ -378,13 +377,14 @@
         <c:crosses val="autoZero"/>
         <c:auto val="1"/>
         <c:lblAlgn val="ctr"/>
+        <c:lblOffset val="100"/>
         <c:noMultiLvlLbl val="1"/>
       </c:catAx>
       <c:valAx>
         <c:axId val="2094734552"/>
         <c:scaling>
           <c:orientation val="minMax"/>
-          <c:max val="1.15"/>
+          <c:max val="1.1499999999999999"/>
           <c:min val="0"/>
         </c:scaling>
         <c:delete val="1"/>
@@ -393,30 +393,6 @@
         <c:majorTickMark val="out"/>
         <c:minorTickMark val="none"/>
         <c:tickLblPos val="low"/>
-        <c:spPr>
-          <a:ln w="12700" cap="flat">
-            <a:solidFill>
-              <a:srgbClr val="888888"/>
-            </a:solidFill>
-            <a:prstDash val="solid"/>
-            <a:round/>
-          </a:ln>
-        </c:spPr>
-        <c:txPr>
-          <a:bodyPr/>
-          <a:lstStyle/>
-          <a:p>
-            <a:pPr>
-              <a:defRPr sz="1100" b="0" i="0" u="none" strike="noStrike">
-                <a:solidFill>
-                  <a:srgbClr val="5B6B70"/>
-                </a:solidFill>
-                <a:latin typeface="+mn-lt"/>
-              </a:defRPr>
-            </a:pPr>
-            <a:endParaRPr lang="en-US"/>
-          </a:p>
-        </c:txPr>
         <c:crossAx val="2094734554"/>
         <c:crosses val="autoZero"/>
         <c:crossBetween val="between"/>
@@ -431,6 +407,7 @@
     </c:plotArea>
     <c:plotVisOnly val="1"/>
     <c:dispBlanksAs val="span"/>
+    <c:showDLblsOverMax val="1"/>
   </c:chart>
   <c:spPr>
     <a:noFill/>
@@ -446,9 +423,11 @@
 </file>
 
 <file path=ppt/charts/chart2.xml><?xml version="1.0" encoding="utf-8"?>
-<c:chartSpace xmlns:c="http://schemas.openxmlformats.org/drawingml/2006/chart" xmlns:a="http://schemas.openxmlformats.org/drawingml/2006/main" xmlns:r="http://schemas.openxmlformats.org/officeDocument/2006/relationships">
+<c:chartSpace xmlns:c="http://schemas.openxmlformats.org/drawingml/2006/chart" xmlns:a="http://schemas.openxmlformats.org/drawingml/2006/main" xmlns:r="http://schemas.openxmlformats.org/officeDocument/2006/relationships" xmlns:c16r2="http://schemas.microsoft.com/office/drawing/2015/06/chart">
   <c:date1904 val="0"/>
+  <c:lang val="en-US"/>
   <c:roundedCorners val="1"/>
+  <c:style val="2"/>
   <c:chart>
     <c:title>
       <c:tx>
@@ -476,7 +455,6 @@
           </a:p>
         </c:rich>
       </c:tx>
-      <c:layout/>
       <c:overlay val="0"/>
     </c:title>
     <c:autoTitleDeleted val="0"/>
@@ -509,18 +487,26 @@
           <c:invertIfNegative val="0"/>
           <c:dLbls>
             <c:numFmt formatCode="0.000" sourceLinked="0"/>
+            <c:spPr>
+              <a:noFill/>
+              <a:ln>
+                <a:noFill/>
+              </a:ln>
+              <a:effectLst/>
+            </c:spPr>
             <c:txPr>
               <a:bodyPr/>
               <a:lstStyle/>
               <a:p>
                 <a:pPr>
-                  <a:defRPr b="0" i="0" strike="noStrike" sz="1200" u="none">
+                  <a:defRPr sz="1200" b="0" i="0" u="none" strike="noStrike">
                     <a:solidFill>
                       <a:srgbClr val="1B2A2F"/>
                     </a:solidFill>
                     <a:latin typeface="+mn-lt"/>
                   </a:defRPr>
                 </a:pPr>
+                <a:endParaRPr lang="en-US"/>
               </a:p>
             </c:txPr>
             <c:showLegendKey val="0"/>
@@ -530,37 +516,40 @@
             <c:showPercent val="0"/>
             <c:showBubbleSize val="0"/>
             <c:showLeaderLines val="0"/>
+            <c:extLst>
+              <c:ext xmlns:c15="http://schemas.microsoft.com/office/drawing/2012/chart" uri="{CE6537A1-D6FC-4f65-9D91-7224C49458BB}">
+                <c15:showLeaderLines val="0"/>
+              </c:ext>
+            </c:extLst>
           </c:dLbls>
           <c:cat>
-            <c:multiLvlStrRef>
+            <c:strRef>
               <c:f>Sheet1!$A$2:$A$8</c:f>
-              <c:multiLvlStrCache>
+              <c:strCache>
                 <c:ptCount val="7"/>
-                <c:lvl>
-                  <c:pt idx="0">
-                    <c:v>archetype</c:v>
-                  </c:pt>
-                  <c:pt idx="1">
-                    <c:v>az spread</c:v>
-                  </c:pt>
-                  <c:pt idx="2">
-                    <c:v>iam shape</c:v>
-                  </c:pt>
-                  <c:pt idx="3">
-                    <c:v>logging</c:v>
-                  </c:pt>
-                  <c:pt idx="4">
-                    <c:v>network layout</c:v>
-                  </c:pt>
-                  <c:pt idx="5">
-                    <c:v>scale</c:v>
-                  </c:pt>
-                  <c:pt idx="6">
-                    <c:v>tagging</c:v>
-                  </c:pt>
-                </c:lvl>
-              </c:multiLvlStrCache>
-            </c:multiLvlStrRef>
+                <c:pt idx="0">
+                  <c:v>archetype</c:v>
+                </c:pt>
+                <c:pt idx="1">
+                  <c:v>az spread</c:v>
+                </c:pt>
+                <c:pt idx="2">
+                  <c:v>iam shape</c:v>
+                </c:pt>
+                <c:pt idx="3">
+                  <c:v>logging</c:v>
+                </c:pt>
+                <c:pt idx="4">
+                  <c:v>network layout</c:v>
+                </c:pt>
+                <c:pt idx="5">
+                  <c:v>scale</c:v>
+                </c:pt>
+                <c:pt idx="6">
+                  <c:v>tagging</c:v>
+                </c:pt>
+              </c:strCache>
+            </c:strRef>
           </c:cat>
           <c:val>
             <c:numRef>
@@ -575,7 +564,7 @@
                   <c:v>1</c:v>
                 </c:pt>
                 <c:pt idx="2">
-                  <c:v>0.4166666666666667</c:v>
+                  <c:v>0.41666666666666669</c:v>
                 </c:pt>
                 <c:pt idx="3">
                   <c:v>1</c:v>
@@ -584,7 +573,7 @@
                   <c:v>1</c:v>
                 </c:pt>
                 <c:pt idx="5">
-                  <c:v>0.8333333333333334</c:v>
+                  <c:v>0.83333333333333337</c:v>
                 </c:pt>
                 <c:pt idx="6">
                   <c:v>0.875</c:v>
@@ -592,36 +581,23 @@
               </c:numCache>
             </c:numRef>
           </c:val>
+          <c:extLst>
+            <c:ext xmlns:c16="http://schemas.microsoft.com/office/drawing/2014/chart" uri="{C3380CC4-5D6E-409C-BE32-E72D297353CC}">
+              <c16:uniqueId val="{00000000-2A28-47BA-B901-3E27F2D20838}"/>
+            </c:ext>
+          </c:extLst>
         </c:ser>
         <c:dLbls>
-          <c:numFmt formatCode="0.000" sourceLinked="0"/>
-          <c:txPr>
-            <a:bodyPr/>
-            <a:lstStyle/>
-            <a:p>
-              <a:pPr>
-                <a:defRPr b="0" i="0" strike="noStrike" sz="1200" u="none">
-                  <a:solidFill>
-                    <a:srgbClr val="1B2A2F"/>
-                  </a:solidFill>
-                  <a:latin typeface="+mn-lt"/>
-                </a:defRPr>
-              </a:pPr>
-            </a:p>
-          </c:txPr>
           <c:showLegendKey val="0"/>
           <c:showVal val="1"/>
           <c:showCatName val="0"/>
           <c:showSerName val="0"/>
           <c:showPercent val="0"/>
           <c:showBubbleSize val="0"/>
-          <c:showLeaderLines val="0"/>
         </c:dLbls>
         <c:gapWidth val="150"/>
-        <c:overlap val="0"/>
         <c:axId val="2094734554"/>
         <c:axId val="2094734552"/>
-        <c:axId val="2094734556"/>
       </c:barChart>
       <c:catAx>
         <c:axId val="2094734554"/>
@@ -662,13 +638,14 @@
         <c:crosses val="autoZero"/>
         <c:auto val="1"/>
         <c:lblAlgn val="ctr"/>
+        <c:lblOffset val="100"/>
         <c:noMultiLvlLbl val="1"/>
       </c:catAx>
       <c:valAx>
         <c:axId val="2094734552"/>
         <c:scaling>
           <c:orientation val="minMax"/>
-          <c:max val="1.15"/>
+          <c:max val="1.1499999999999999"/>
           <c:min val="0"/>
         </c:scaling>
         <c:delete val="1"/>
@@ -677,30 +654,6 @@
         <c:majorTickMark val="out"/>
         <c:minorTickMark val="none"/>
         <c:tickLblPos val="low"/>
-        <c:spPr>
-          <a:ln w="12700" cap="flat">
-            <a:solidFill>
-              <a:srgbClr val="888888"/>
-            </a:solidFill>
-            <a:prstDash val="solid"/>
-            <a:round/>
-          </a:ln>
-        </c:spPr>
-        <c:txPr>
-          <a:bodyPr/>
-          <a:lstStyle/>
-          <a:p>
-            <a:pPr>
-              <a:defRPr sz="1100" b="0" i="0" u="none" strike="noStrike">
-                <a:solidFill>
-                  <a:srgbClr val="5B6B70"/>
-                </a:solidFill>
-                <a:latin typeface="+mn-lt"/>
-              </a:defRPr>
-            </a:pPr>
-            <a:endParaRPr lang="en-US"/>
-          </a:p>
-        </c:txPr>
         <c:crossAx val="2094734554"/>
         <c:crosses val="autoZero"/>
         <c:crossBetween val="between"/>
@@ -715,6 +668,7 @@
     </c:plotArea>
     <c:plotVisOnly val="1"/>
     <c:dispBlanksAs val="span"/>
+    <c:showDLblsOverMax val="1"/>
   </c:chart>
   <c:spPr>
     <a:noFill/>
@@ -751,234 +705,10 @@
           <a:chExt cx="0" cy="0"/>
         </a:xfrm>
       </p:grpSpPr>
-      <p:sp>
-        <p:nvSpPr>
-          <p:cNvPr id="2" name="Header Placeholder 1"/>
-          <p:cNvSpPr>
-            <a:spLocks noGrp="1"/>
-          </p:cNvSpPr>
-          <p:nvPr>
-            <p:ph type="hdr" sz="quarter"/>
-          </p:nvPr>
-        </p:nvSpPr>
-        <p:spPr>
-          <a:xfrm>
-            <a:off x="0" y="0"/>
-            <a:ext cx="2971800" cy="458788"/>
-          </a:xfrm>
-          <a:prstGeom prst="rect">
-            <a:avLst/>
-          </a:prstGeom>
-        </p:spPr>
-        <p:txBody>
-          <a:bodyPr vert="horz" lIns="91440" tIns="45720" rIns="91440" bIns="45720" rtlCol="0"/>
-          <a:lstStyle>
-            <a:lvl1pPr algn="l">
-              <a:defRPr sz="1200"/>
-            </a:lvl1pPr>
-          </a:lstStyle>
-          <a:p>
-            <a:endParaRPr lang="en-US"/>
-          </a:p>
-        </p:txBody>
-      </p:sp>
-      <p:sp>
-        <p:nvSpPr>
-          <p:cNvPr id="3" name="Date Placeholder 2"/>
-          <p:cNvSpPr>
-            <a:spLocks noGrp="1"/>
-          </p:cNvSpPr>
-          <p:nvPr>
-            <p:ph type="dt" idx="1"/>
-          </p:nvPr>
-        </p:nvSpPr>
-        <p:spPr>
-          <a:xfrm>
-            <a:off x="3884613" y="0"/>
-            <a:ext cx="2971800" cy="458788"/>
-          </a:xfrm>
-          <a:prstGeom prst="rect">
-            <a:avLst/>
-          </a:prstGeom>
-        </p:spPr>
-        <p:txBody>
-          <a:bodyPr vert="horz" lIns="91440" tIns="45720" rIns="91440" bIns="45720" rtlCol="0"/>
-          <a:lstStyle>
-            <a:lvl1pPr algn="r">
-              <a:defRPr sz="1200"/>
-            </a:lvl1pPr>
-          </a:lstStyle>
-          <a:p>
-            <a:fld id="{5282F153-3F37-0F45-9E97-73ACFA13230C}" type="datetimeFigureOut">
-              <a:rPr lang="en-US"/>
-              <a:t>7/23/19</a:t>
-            </a:fld>
-            <a:endParaRPr lang="en-US"/>
-          </a:p>
-        </p:txBody>
-      </p:sp>
-      <p:sp>
-        <p:nvSpPr>
-          <p:cNvPr id="4" name="Slide Image Placeholder 3"/>
-          <p:cNvSpPr>
-            <a:spLocks noGrp="1" noRot="1" noChangeAspect="1"/>
-          </p:cNvSpPr>
-          <p:nvPr>
-            <p:ph type="sldImg" idx="2"/>
-          </p:nvPr>
-        </p:nvSpPr>
-        <p:spPr>
-          <a:xfrm>
-            <a:off x="685800" y="1143000"/>
-            <a:ext cx="5486400" cy="3086100"/>
-          </a:xfrm>
-          <a:prstGeom prst="rect">
-            <a:avLst/>
-          </a:prstGeom>
-          <a:noFill/>
-          <a:ln w="12700">
-            <a:solidFill>
-              <a:prstClr val="black"/>
-            </a:solidFill>
-          </a:ln>
-        </p:spPr>
-        <p:txBody>
-          <a:bodyPr vert="horz" lIns="91440" tIns="45720" rIns="91440" bIns="45720" rtlCol="0" anchor="ctr"/>
-          <a:lstStyle/>
-          <a:p>
-            <a:endParaRPr lang="en-US"/>
-          </a:p>
-        </p:txBody>
-      </p:sp>
-      <p:sp>
-        <p:nvSpPr>
-          <p:cNvPr id="5" name="Notes Placeholder 4"/>
-          <p:cNvSpPr>
-            <a:spLocks noGrp="1"/>
-          </p:cNvSpPr>
-          <p:nvPr>
-            <p:ph type="body" sz="quarter" idx="3"/>
-          </p:nvPr>
-        </p:nvSpPr>
-        <p:spPr>
-          <a:xfrm>
-            <a:off x="685800" y="4400550"/>
-            <a:ext cx="5486400" cy="3600450"/>
-          </a:xfrm>
-          <a:prstGeom prst="rect">
-            <a:avLst/>
-          </a:prstGeom>
-        </p:spPr>
-        <p:txBody>
-          <a:bodyPr vert="horz" lIns="91440" tIns="45720" rIns="91440" bIns="45720" rtlCol="0"/>
-          <a:lstStyle/>
-          <a:p>
-            <a:pPr lvl="0"/>
-            <a:r>
-              <a:rPr lang="en-US"/>
-              <a:t>Click to edit Master text styles</a:t>
-            </a:r>
-          </a:p>
-          <a:p>
-            <a:pPr lvl="1"/>
-            <a:r>
-              <a:rPr lang="en-US"/>
-              <a:t>Second level</a:t>
-            </a:r>
-          </a:p>
-          <a:p>
-            <a:pPr lvl="2"/>
-            <a:r>
-              <a:rPr lang="en-US"/>
-              <a:t>Third level</a:t>
-            </a:r>
-          </a:p>
-          <a:p>
-            <a:pPr lvl="3"/>
-            <a:r>
-              <a:rPr lang="en-US"/>
-              <a:t>Fourth level</a:t>
-            </a:r>
-          </a:p>
-          <a:p>
-            <a:pPr lvl="4"/>
-            <a:r>
-              <a:rPr lang="en-US"/>
-              <a:t>Fifth level</a:t>
-            </a:r>
-          </a:p>
-        </p:txBody>
-      </p:sp>
-      <p:sp>
-        <p:nvSpPr>
-          <p:cNvPr id="6" name="Footer Placeholder 5"/>
-          <p:cNvSpPr>
-            <a:spLocks noGrp="1"/>
-          </p:cNvSpPr>
-          <p:nvPr>
-            <p:ph type="ftr" sz="quarter" idx="4"/>
-          </p:nvPr>
-        </p:nvSpPr>
-        <p:spPr>
-          <a:xfrm>
-            <a:off x="0" y="8685213"/>
-            <a:ext cx="2971800" cy="458787"/>
-          </a:xfrm>
-          <a:prstGeom prst="rect">
-            <a:avLst/>
-          </a:prstGeom>
-        </p:spPr>
-        <p:txBody>
-          <a:bodyPr vert="horz" lIns="91440" tIns="45720" rIns="91440" bIns="45720" rtlCol="0" anchor="b"/>
-          <a:lstStyle>
-            <a:lvl1pPr algn="l">
-              <a:defRPr sz="1200"/>
-            </a:lvl1pPr>
-          </a:lstStyle>
-          <a:p>
-            <a:endParaRPr lang="en-US"/>
-          </a:p>
-        </p:txBody>
-      </p:sp>
-      <p:sp>
-        <p:nvSpPr>
-          <p:cNvPr id="7" name="Slide Number Placeholder 6"/>
-          <p:cNvSpPr>
-            <a:spLocks noGrp="1"/>
-          </p:cNvSpPr>
-          <p:nvPr>
-            <p:ph type="sldNum" sz="quarter" idx="5"/>
-          </p:nvPr>
-        </p:nvSpPr>
-        <p:spPr>
-          <a:xfrm>
-            <a:off x="3884613" y="8685213"/>
-            <a:ext cx="2971800" cy="458787"/>
-          </a:xfrm>
-          <a:prstGeom prst="rect">
-            <a:avLst/>
-          </a:prstGeom>
-        </p:spPr>
-        <p:txBody>
-          <a:bodyPr vert="horz" lIns="91440" tIns="45720" rIns="91440" bIns="45720" rtlCol="0" anchor="b"/>
-          <a:lstStyle>
-            <a:lvl1pPr algn="r">
-              <a:defRPr sz="1200"/>
-            </a:lvl1pPr>
-          </a:lstStyle>
-          <a:p>
-            <a:fld id="{CE5E9CC1-C706-0F49-92D6-E571CC5EEA8F}" type="slidenum">
-              <a:rPr lang="en-US"/>
-              <a:t>‹#›</a:t>
-            </a:fld>
-            <a:endParaRPr lang="en-US"/>
-          </a:p>
-        </p:txBody>
-      </p:sp>
     </p:spTree>
     <p:extLst>
       <p:ext uri="{BB962C8B-B14F-4D97-AF65-F5344CB8AC3E}">
-        <p14:creationId xmlns:p14="http://schemas.microsoft.com/office/powerpoint/2010/main" val="1024086991"/>
+        <p14:creationId xmlns:p14="http://schemas.microsoft.com/office/powerpoint/2010/main" val="565321329"/>
       </p:ext>
     </p:extLst>
   </p:cSld>
@@ -1126,7 +856,6 @@
               <a:rPr lang="en-US" dirty="0"/>
               <a:t>Frame: recommend and review AWS configurations against regulatory controls, and justify every finding as a traceable path. This review is about implementation progress since Phase-I; every number on the following slides comes from a committed results file.</a:t>
             </a:r>
-            <a:endParaRPr lang="en-US" dirty="0"/>
           </a:p>
         </p:txBody>
       </p:sp>
@@ -1214,7 +943,6 @@
               <a:rPr lang="en-US" dirty="0"/>
               <a:t>Sources: results/p4_df7_checkov_evidence.json (graph versus Checkov) and results/advisor_report.json (rule floor). DF-1 to DF-4 recall is 1.0 by construction because the injectors produce exactly what the rules check; it is a sanity floor, not a benchmark.</a:t>
             </a:r>
-            <a:endParaRPr lang="en-US" dirty="0"/>
           </a:p>
         </p:txBody>
       </p:sp>
@@ -1302,7 +1030,6 @@
               <a:rPr lang="en-US" dirty="0"/>
               <a:t>Sources: results/reconstruction_report.json; INV-2 is tests/explainer/test_explainer.py, which extracts claims back out of the rendered text. Cost deltas in explanations are stated as not modelled.</a:t>
             </a:r>
-            <a:endParaRPr lang="en-US" dirty="0"/>
           </a:p>
         </p:txBody>
       </p:sp>
@@ -1390,7 +1117,6 @@
               <a:rPr lang="en-US" dirty="0"/>
               <a:t>Live command: kgcr review --variant unencrypted_database --audience auditor. Output trimmed for the slide; run it live if time allows (about 15 seconds). PCI-DSS v4.0 3.5.1 covers stored PAN; 3.4 is display masking.</a:t>
             </a:r>
-            <a:endParaRPr lang="en-US" dirty="0"/>
           </a:p>
         </p:txBody>
       </p:sp>
@@ -1478,7 +1204,6 @@
               <a:rPr lang="en-US" dirty="0"/>
               <a:t>Source: docs/Project_Report.md section 8, the 21-service planning table. Nothing has been deployed and no AWS money has been spent. The pipeline talks to storage and notification only through two small interfaces, so AWS-backed versions slot in without changing it.</a:t>
             </a:r>
-            <a:endParaRPr lang="en-US" dirty="0"/>
           </a:p>
         </p:txBody>
       </p:sp>
@@ -1566,7 +1291,6 @@
               <a:rPr lang="en-US" dirty="0"/>
               <a:t>Close on the honest split. Code in this repository is authored by Udit with Claude's assistance; Manya and Tanmoy own their literature and research-gap sections.</a:t>
             </a:r>
-            <a:endParaRPr lang="en-US" dirty="0"/>
           </a:p>
         </p:txBody>
       </p:sp>
@@ -1654,7 +1378,6 @@
               <a:rPr lang="en-US" dirty="0"/>
               <a:t>Source: docs/Project_Report.md section 1 and FD-05 section 5. The right-hand chain is the injected DF-7 'indirect internet reachability' pattern used throughout the results.</a:t>
             </a:r>
-            <a:endParaRPr lang="en-US" dirty="0"/>
           </a:p>
         </p:txBody>
       </p:sp>
@@ -1742,7 +1465,6 @@
               <a:rPr lang="en-US" dirty="0"/>
               <a:t>Source: docs/Literature_Survey.md synthesis, docs/Research_Gap_Udit.md and the two companion gap documents. Each member presents their own five papers.</a:t>
             </a:r>
-            <a:endParaRPr lang="en-US" dirty="0"/>
           </a:p>
         </p:txBody>
       </p:sp>
@@ -1830,7 +1552,6 @@
               <a:rPr lang="en-US" dirty="0"/>
               <a:t>Source: docs/Objectives.md. 'Runs today' means code plus a committed result, on the synthetic corpus. O1 is a draft written by Claude and must be reviewed by Udit before it counts (FD-07 section 2: a model may read L1, never author it).</a:t>
             </a:r>
-            <a:endParaRPr lang="en-US" dirty="0"/>
           </a:p>
         </p:txBody>
       </p:sp>
@@ -1918,7 +1639,6 @@
               <a:rPr lang="en-US" dirty="0"/>
               <a:t>Source: architecture/AWS_Architecture.png, generated by architecture/make_diagrams.py. Say first that this is the planning diagram; slide 13 gives the planned-versus-running split.</a:t>
             </a:r>
-            <a:endParaRPr lang="en-US" dirty="0"/>
           </a:p>
         </p:txBody>
       </p:sp>
@@ -2006,7 +1726,6 @@
               <a:rPr lang="en-US" dirty="0"/>
               <a:t>Source: architecture/System_Architecture.png and FD-01. The plan, confirm and apply steps (S6 to S10) need live accounts and are not built.</a:t>
             </a:r>
-            <a:endParaRPr lang="en-US" dirty="0"/>
           </a:p>
         </p:txBody>
       </p:sp>
@@ -2094,7 +1813,6 @@
               <a:rPr lang="en-US" dirty="0"/>
               <a:t>Source: dataset/dataset_description.md and results/advisor_report.json (DF-7 count over the full injected corpus). Say 'synthetic' before anyone asks.</a:t>
             </a:r>
-            <a:endParaRPr lang="en-US" dirty="0"/>
           </a:p>
         </p:txBody>
       </p:sp>
@@ -2182,7 +1900,6 @@
               <a:rPr lang="en-US" dirty="0"/>
               <a:t>Source: src/backend/kgcr/orchestration/review.py and cli.py. Rule floor only means the advisor ran its deterministic rules; relational and resilience findings need the Gemini path, which has not run live.</a:t>
             </a:r>
-            <a:endParaRPr lang="en-US" dirty="0"/>
           </a:p>
         </p:txBody>
       </p:sp>
@@ -2270,7 +1987,6 @@
               <a:rPr lang="en-US" dirty="0"/>
               <a:t>Source: results/recommender_report.json. Options are (resource type, attribute, value) with identity attributes excluded. This measures recovery of the generator's mapping, not real-world recommendation quality.</a:t>
             </a:r>
-            <a:endParaRPr lang="en-US" dirty="0"/>
           </a:p>
         </p:txBody>
       </p:sp>
@@ -2348,6 +2064,7 @@
         <a:solidFill>
           <a:schemeClr val="tx2"/>
         </a:solidFill>
+        <a:effectLst/>
       </p:bgPr>
     </p:bg>
     <p:spTree>
@@ -2367,9 +2084,11 @@
       <p:sp>
         <p:nvSpPr>
           <p:cNvPr id="2" name="Text 0"/>
-          <p:cNvSpPr/>
+          <p:cNvSpPr>
+            <a:spLocks noGrp="1"/>
+          </p:cNvSpPr>
           <p:nvPr>
-            <p:ph idx="100" type="title" hasCustomPrompt="1"/>
+            <p:ph type="title" idx="100" hasCustomPrompt="1"/>
           </p:nvPr>
         </p:nvSpPr>
         <p:spPr>
@@ -2386,7 +2105,7 @@
         <p:txBody>
           <a:bodyPr wrap="square" rtlCol="0"/>
           <a:lstStyle>
-            <a:lvl1pPr indent="0" marL="0">
+            <a:lvl1pPr marL="0" indent="0">
               <a:buNone/>
               <a:defRPr lang="en-US" sz="4000" b="1" dirty="0">
                 <a:solidFill>
@@ -2396,7 +2115,7 @@
             </a:lvl1pPr>
           </a:lstStyle>
           <a:p>
-            <a:pPr indent="0" marL="0">
+            <a:pPr marL="0" indent="0">
               <a:buNone/>
             </a:pPr>
             <a:endParaRPr lang="en-US" sz="4000" dirty="0"/>
@@ -2406,9 +2125,11 @@
       <p:sp>
         <p:nvSpPr>
           <p:cNvPr id="3" name="Text 0"/>
-          <p:cNvSpPr/>
+          <p:cNvSpPr>
+            <a:spLocks noGrp="1"/>
+          </p:cNvSpPr>
           <p:nvPr>
-            <p:ph idx="101" type="body" hasCustomPrompt="1"/>
+            <p:ph type="body" idx="101" hasCustomPrompt="1"/>
           </p:nvPr>
         </p:nvSpPr>
         <p:spPr>
@@ -2425,7 +2146,7 @@
         <p:txBody>
           <a:bodyPr wrap="square" rtlCol="0"/>
           <a:lstStyle>
-            <a:lvl1pPr indent="0" marL="0">
+            <a:lvl1pPr marL="0" indent="0">
               <a:buNone/>
               <a:defRPr lang="en-US" sz="1800" dirty="0">
                 <a:solidFill>
@@ -2435,7 +2156,7 @@
             </a:lvl1pPr>
           </a:lstStyle>
           <a:p>
-            <a:pPr indent="0" marL="0">
+            <a:pPr marL="0" indent="0">
               <a:buNone/>
             </a:pPr>
             <a:endParaRPr lang="en-US" sz="1800" dirty="0"/>
@@ -2458,6 +2179,7 @@
         <a:solidFill>
           <a:schemeClr val="bg1"/>
         </a:solidFill>
+        <a:effectLst/>
       </p:bgPr>
     </p:bg>
     <p:spTree>
@@ -2477,9 +2199,11 @@
       <p:sp>
         <p:nvSpPr>
           <p:cNvPr id="2" name="Text 0"/>
-          <p:cNvSpPr/>
+          <p:cNvSpPr>
+            <a:spLocks noGrp="1"/>
+          </p:cNvSpPr>
           <p:nvPr>
-            <p:ph idx="100" type="title" hasCustomPrompt="1"/>
+            <p:ph type="title" idx="100" hasCustomPrompt="1"/>
           </p:nvPr>
         </p:nvSpPr>
         <p:spPr>
@@ -2496,7 +2220,7 @@
         <p:txBody>
           <a:bodyPr wrap="square" rtlCol="0"/>
           <a:lstStyle>
-            <a:lvl1pPr algn="l" indent="0" marL="0">
+            <a:lvl1pPr marL="0" indent="0" algn="l">
               <a:buNone/>
               <a:defRPr lang="en-US" sz="3000" b="1" dirty="0">
                 <a:solidFill>
@@ -2506,7 +2230,7 @@
             </a:lvl1pPr>
           </a:lstStyle>
           <a:p>
-            <a:pPr algn="l" indent="0" marL="0">
+            <a:pPr marL="0" indent="0" algn="l">
               <a:buNone/>
             </a:pPr>
             <a:endParaRPr lang="en-US" sz="3000" dirty="0"/>
@@ -2534,7 +2258,7 @@
           <a:bodyPr wrap="square" rtlCol="0" anchor="ctr"/>
           <a:lstStyle/>
           <a:p>
-            <a:pPr indent="0" marL="0">
+            <a:pPr marL="0" indent="0">
               <a:buNone/>
             </a:pPr>
             <a:r>
@@ -2569,7 +2293,7 @@
           </a:prstGeom>
           <a:extLst>
             <a:ext uri="{C572A759-6A51-4108-AA02-DFA0A04FC94B}">
-              <ma14:wrappingTextBoxFlag xmlns:ma14="http://schemas.microsoft.com/office/mac/drawingml/2011/main" val="0"/>
+              <ma14:wrappingTextBoxFlag xmlns:ma14="http://schemas.microsoft.com/office/mac/drawingml/2011/main" xmlns="" val="0"/>
             </a:ext>
           </a:extLst>
         </p:spPr>
@@ -2587,8 +2311,8 @@
           <a:p>
             <a:pPr algn="r"/>
             <a:fld id="{F7021451-1387-4CA6-816F-3879F97B5CBC}" type="slidenum">
-              <a:rPr b="0" lang="en-US"/>
-              <a:t>1003</a:t>
+              <a:rPr lang="en-US" b="0"/>
+              <a:t>‹#›</a:t>
             </a:fld>
             <a:endParaRPr lang="en-US"/>
           </a:p>
@@ -2605,6 +2329,11 @@
 <file path=ppt/slideMasters/slideMaster1.xml><?xml version="1.0" encoding="utf-8"?>
 <p:sldMaster xmlns:a="http://schemas.openxmlformats.org/drawingml/2006/main" xmlns:r="http://schemas.openxmlformats.org/officeDocument/2006/relationships" xmlns:p="http://schemas.openxmlformats.org/presentationml/2006/main">
   <p:cSld>
+    <p:bg>
+      <p:bgRef idx="1001">
+        <a:schemeClr val="bg1"/>
+      </p:bgRef>
+    </p:bg>
     <p:spTree>
       <p:nvGrpSpPr>
         <p:cNvPr id="1" name=""/>
@@ -2639,7 +2368,7 @@
           </a:prstGeom>
           <a:extLst>
             <a:ext uri="{C572A759-6A51-4108-AA02-DFA0A04FC94B}">
-              <ma14:wrappingTextBoxFlag xmlns:ma14="http://schemas.microsoft.com/office/mac/drawingml/2011/main" val="0"/>
+              <ma14:wrappingTextBoxFlag xmlns:ma14="http://schemas.microsoft.com/office/mac/drawingml/2011/main" xmlns="" val="0"/>
             </a:ext>
           </a:extLst>
         </p:spPr>
@@ -2657,8 +2386,8 @@
           <a:p>
             <a:pPr algn="r"/>
             <a:fld id="{F7021451-1387-4CA6-816F-3879F97B5CBC}" type="slidenum">
-              <a:rPr b="0" lang="en-US"/>
-              <a:t>null</a:t>
+              <a:rPr lang="en-US" b="0"/>
+              <a:t>‹#›</a:t>
             </a:fld>
             <a:endParaRPr lang="en-US"/>
           </a:p>
@@ -2946,9 +2675,11 @@
       <p:sp>
         <p:nvSpPr>
           <p:cNvPr id="2" name="Text 0"/>
-          <p:cNvSpPr/>
+          <p:cNvSpPr>
+            <a:spLocks noGrp="1"/>
+          </p:cNvSpPr>
           <p:nvPr>
-            <p:ph idx="100" type="title" hasCustomPrompt="1"/>
+            <p:ph type="title" idx="100" hasCustomPrompt="1"/>
           </p:nvPr>
         </p:nvSpPr>
         <p:spPr>
@@ -2966,7 +2697,7 @@
           <a:bodyPr wrap="square" rtlCol="0" anchor="b"/>
           <a:lstStyle/>
           <a:p>
-            <a:pPr indent="0" marL="0">
+            <a:pPr marL="0" indent="0">
               <a:buNone/>
             </a:pPr>
             <a:r>
@@ -2984,9 +2715,11 @@
       <p:sp>
         <p:nvSpPr>
           <p:cNvPr id="3" name="Text 0"/>
-          <p:cNvSpPr/>
+          <p:cNvSpPr>
+            <a:spLocks noGrp="1"/>
+          </p:cNvSpPr>
           <p:nvPr>
-            <p:ph idx="101" type="body" hasCustomPrompt="1"/>
+            <p:ph type="body" idx="101" hasCustomPrompt="1"/>
           </p:nvPr>
         </p:nvSpPr>
         <p:spPr>
@@ -3004,7 +2737,7 @@
           <a:bodyPr wrap="square" rtlCol="0" anchor="t"/>
           <a:lstStyle/>
           <a:p>
-            <a:pPr indent="0" marL="0">
+            <a:pPr marL="0" indent="0">
               <a:buNone/>
             </a:pPr>
             <a:r>
@@ -3018,7 +2751,7 @@
             <a:endParaRPr lang="en-US" sz="1800" dirty="0"/>
           </a:p>
           <a:p>
-            <a:pPr indent="0" marL="0">
+            <a:pPr marL="0" indent="0">
               <a:buNone/>
             </a:pPr>
             <a:r>
@@ -3032,16 +2765,36 @@
             <a:endParaRPr lang="en-US" sz="1800" dirty="0"/>
           </a:p>
           <a:p>
-            <a:pPr indent="0" marL="0">
-              <a:buNone/>
-            </a:pPr>
+            <a:pPr marL="0" indent="0">
+              <a:buNone/>
+            </a:pPr>
+            <a:r>
+              <a:rPr lang="en-US" sz="1800">
+                <a:solidFill>
+                  <a:schemeClr val="accent6"/>
+                </a:solidFill>
+              </a:rPr>
+              <a:t>Udit </a:t>
+            </a:r>
+            <a:r>
+              <a:rPr lang="en-US"/>
+              <a:t>Daftary</a:t>
+            </a:r>
+            <a:r>
+              <a:rPr lang="en-US" sz="1800">
+                <a:solidFill>
+                  <a:schemeClr val="accent6"/>
+                </a:solidFill>
+              </a:rPr>
+              <a:t>, Manya Dev, Tanmoy Paul </a:t>
+            </a:r>
             <a:r>
               <a:rPr lang="en-US" sz="1800" dirty="0">
                 <a:solidFill>
                   <a:schemeClr val="accent6"/>
                 </a:solidFill>
               </a:rPr>
-              <a:t>Udit (lead), Manya, Tanmoy   |   github.com/uditdaftary/KGCR_Cloud_Project_2026</a:t>
+              <a:t>|   github.com/uditdaftary/KGCR_Cloud_Project_2026</a:t>
             </a:r>
             <a:endParaRPr lang="en-US" sz="1800" dirty="0"/>
           </a:p>
@@ -3075,9 +2828,11 @@
       <p:sp>
         <p:nvSpPr>
           <p:cNvPr id="2" name="Text 0"/>
-          <p:cNvSpPr/>
+          <p:cNvSpPr>
+            <a:spLocks noGrp="1"/>
+          </p:cNvSpPr>
           <p:nvPr>
-            <p:ph idx="100" type="title" hasCustomPrompt="1"/>
+            <p:ph type="title" idx="100" hasCustomPrompt="1"/>
           </p:nvPr>
         </p:nvSpPr>
         <p:spPr>
@@ -3095,7 +2850,7 @@
           <a:bodyPr wrap="square" rtlCol="0" anchor="ctr"/>
           <a:lstStyle/>
           <a:p>
-            <a:pPr algn="l" indent="0" marL="0">
+            <a:pPr marL="0" indent="0" algn="l">
               <a:buNone/>
             </a:pPr>
             <a:r>
@@ -3131,7 +2886,7 @@
           <a:bodyPr wrap="square" lIns="0" tIns="0" rIns="0" bIns="0" rtlCol="0" anchor="ctr"/>
           <a:lstStyle/>
           <a:p>
-            <a:pPr indent="0" marL="0">
+            <a:pPr marL="0" indent="0">
               <a:buNone/>
             </a:pPr>
             <a:r>
@@ -3170,7 +2925,7 @@
           <a:bodyPr wrap="square" lIns="0" tIns="0" rIns="0" bIns="0" rtlCol="0" anchor="t"/>
           <a:lstStyle/>
           <a:p>
-            <a:pPr indent="0" marL="0">
+            <a:pPr marL="0" indent="0">
               <a:buNone/>
             </a:pPr>
             <a:r>
@@ -3206,7 +2961,7 @@
           <a:bodyPr wrap="square" lIns="0" tIns="0" rIns="0" bIns="0" rtlCol="0" anchor="ctr"/>
           <a:lstStyle/>
           <a:p>
-            <a:pPr indent="0" marL="0">
+            <a:pPr marL="0" indent="0">
               <a:buNone/>
             </a:pPr>
             <a:r>
@@ -3245,7 +3000,7 @@
           <a:bodyPr wrap="square" lIns="0" tIns="0" rIns="0" bIns="0" rtlCol="0" anchor="t"/>
           <a:lstStyle/>
           <a:p>
-            <a:pPr indent="0" marL="0">
+            <a:pPr marL="0" indent="0">
               <a:buNone/>
             </a:pPr>
             <a:r>
@@ -3281,7 +3036,7 @@
           <a:bodyPr wrap="square" lIns="0" tIns="0" rIns="0" bIns="0" rtlCol="0" anchor="ctr"/>
           <a:lstStyle/>
           <a:p>
-            <a:pPr indent="0" marL="0">
+            <a:pPr marL="0" indent="0">
               <a:buNone/>
             </a:pPr>
             <a:r>
@@ -3320,7 +3075,7 @@
           <a:bodyPr wrap="square" lIns="0" tIns="0" rIns="0" bIns="0" rtlCol="0" anchor="t"/>
           <a:lstStyle/>
           <a:p>
-            <a:pPr indent="0" marL="0">
+            <a:pPr marL="0" indent="0">
               <a:buNone/>
             </a:pPr>
             <a:r>
@@ -3356,7 +3111,7 @@
           <a:bodyPr wrap="square" lIns="0" tIns="0" rIns="0" bIns="0" rtlCol="0" anchor="ctr"/>
           <a:lstStyle/>
           <a:p>
-            <a:pPr indent="0" marL="0">
+            <a:pPr marL="0" indent="0">
               <a:buNone/>
             </a:pPr>
             <a:r>
@@ -3395,7 +3150,7 @@
           <a:bodyPr wrap="square" lIns="0" tIns="0" rIns="0" bIns="0" rtlCol="0" anchor="t"/>
           <a:lstStyle/>
           <a:p>
-            <a:pPr indent="0" marL="0">
+            <a:pPr marL="0" indent="0">
               <a:buNone/>
             </a:pPr>
             <a:r>
@@ -3460,7 +3215,7 @@
           <a:bodyPr wrap="square" lIns="0" tIns="0" rIns="0" bIns="0" rtlCol="0" anchor="ctr"/>
           <a:lstStyle/>
           <a:p>
-            <a:pPr algn="ctr" indent="0" marL="0">
+            <a:pPr marL="0" indent="0" algn="ctr">
               <a:buNone/>
             </a:pPr>
             <a:r>
@@ -3496,7 +3251,7 @@
           <a:bodyPr wrap="square" lIns="0" tIns="0" rIns="0" bIns="0" rtlCol="0" anchor="ctr"/>
           <a:lstStyle/>
           <a:p>
-            <a:pPr indent="0" marL="0">
+            <a:pPr marL="0" indent="0">
               <a:buNone/>
             </a:pPr>
             <a:r>
@@ -3610,7 +3365,7 @@
           </a:prstGeom>
           <a:extLst>
             <a:ext uri="{C572A759-6A51-4108-AA02-DFA0A04FC94B}">
-              <ma14:wrappingTextBoxFlag xmlns:ma14="http://schemas.microsoft.com/office/mac/drawingml/2011/main" val="0"/>
+              <ma14:wrappingTextBoxFlag xmlns:ma14="http://schemas.microsoft.com/office/mac/drawingml/2011/main" xmlns="" val="0"/>
             </a:ext>
           </a:extLst>
         </p:spPr>
@@ -3628,7 +3383,7 @@
           <a:p>
             <a:pPr algn="r"/>
             <a:fld id="{F7021451-1387-4CA6-816F-3879F97B5CBC}" type="slidenum">
-              <a:rPr b="0" lang="en-US"/>
+              <a:rPr lang="en-US" b="0"/>
               <a:t>10</a:t>
             </a:fld>
             <a:endParaRPr lang="en-US"/>
@@ -3663,9 +3418,11 @@
       <p:sp>
         <p:nvSpPr>
           <p:cNvPr id="2" name="Text 0"/>
-          <p:cNvSpPr/>
+          <p:cNvSpPr>
+            <a:spLocks noGrp="1"/>
+          </p:cNvSpPr>
           <p:nvPr>
-            <p:ph idx="100" type="title" hasCustomPrompt="1"/>
+            <p:ph type="title" idx="100" hasCustomPrompt="1"/>
           </p:nvPr>
         </p:nvSpPr>
         <p:spPr>
@@ -3683,7 +3440,7 @@
           <a:bodyPr wrap="square" rtlCol="0" anchor="ctr"/>
           <a:lstStyle/>
           <a:p>
-            <a:pPr algn="l" indent="0" marL="0">
+            <a:pPr marL="0" indent="0" algn="l">
               <a:buNone/>
             </a:pPr>
             <a:r>
@@ -3700,7 +3457,7 @@
       </p:sp>
       <p:graphicFrame>
         <p:nvGraphicFramePr>
-          <p:cNvPr id="3" name="Chart 0" descr=""/>
+          <p:cNvPr id="3" name="Chart 0"/>
           <p:cNvGraphicFramePr/>
           <p:nvPr/>
         </p:nvGraphicFramePr>
@@ -3708,9 +3465,9 @@
           <a:off x="548640" y="1280160"/>
           <a:ext cx="6766560" cy="4846320"/>
         </p:xfrm>
-        <a:graphic xmlns:a="http://schemas.openxmlformats.org/drawingml/2006/main">
+        <a:graphic>
           <a:graphicData uri="http://schemas.openxmlformats.org/drawingml/2006/chart">
-            <c:chart xmlns:c="http://schemas.openxmlformats.org/drawingml/2006/chart" r:id="rId1"/>
+            <c:chart xmlns:c="http://schemas.openxmlformats.org/drawingml/2006/chart" xmlns:r="http://schemas.openxmlformats.org/officeDocument/2006/relationships" r:id="rId3"/>
           </a:graphicData>
         </a:graphic>
       </p:graphicFrame>
@@ -3810,7 +3567,7 @@
           </a:prstGeom>
           <a:extLst>
             <a:ext uri="{C572A759-6A51-4108-AA02-DFA0A04FC94B}">
-              <ma14:wrappingTextBoxFlag xmlns:ma14="http://schemas.microsoft.com/office/mac/drawingml/2011/main" val="0"/>
+              <ma14:wrappingTextBoxFlag xmlns:ma14="http://schemas.microsoft.com/office/mac/drawingml/2011/main" xmlns="" val="0"/>
             </a:ext>
           </a:extLst>
         </p:spPr>
@@ -3828,7 +3585,7 @@
           <a:p>
             <a:pPr algn="r"/>
             <a:fld id="{F7021451-1387-4CA6-816F-3879F97B5CBC}" type="slidenum">
-              <a:rPr b="0" lang="en-US"/>
+              <a:rPr lang="en-US" b="0"/>
               <a:t>11</a:t>
             </a:fld>
             <a:endParaRPr lang="en-US"/>
@@ -3863,9 +3620,11 @@
       <p:sp>
         <p:nvSpPr>
           <p:cNvPr id="2" name="Text 0"/>
-          <p:cNvSpPr/>
+          <p:cNvSpPr>
+            <a:spLocks noGrp="1"/>
+          </p:cNvSpPr>
           <p:nvPr>
-            <p:ph idx="100" type="title" hasCustomPrompt="1"/>
+            <p:ph type="title" idx="100" hasCustomPrompt="1"/>
           </p:nvPr>
         </p:nvSpPr>
         <p:spPr>
@@ -3883,7 +3642,7 @@
           <a:bodyPr wrap="square" rtlCol="0" anchor="ctr"/>
           <a:lstStyle/>
           <a:p>
-            <a:pPr algn="l" indent="0" marL="0">
+            <a:pPr marL="0" indent="0" algn="l">
               <a:buNone/>
             </a:pPr>
             <a:r>
@@ -3921,7 +3680,7 @@
           <a:bodyPr wrap="square" lIns="152400" tIns="152400" rIns="152400" bIns="152400" rtlCol="0" anchor="ctr"/>
           <a:lstStyle/>
           <a:p>
-            <a:pPr indent="0" marL="0">
+            <a:pPr marL="0" indent="0">
               <a:buNone/>
             </a:pPr>
             <a:r>
@@ -3938,7 +3697,7 @@
             <a:endParaRPr lang="en-US" sz="1300" dirty="0"/>
           </a:p>
           <a:p>
-            <a:pPr indent="0" marL="0">
+            <a:pPr marL="0" indent="0">
               <a:buNone/>
             </a:pPr>
             <a:r>
@@ -3955,7 +3714,7 @@
             <a:endParaRPr lang="en-US" sz="1300" dirty="0"/>
           </a:p>
           <a:p>
-            <a:pPr indent="0" marL="0">
+            <a:pPr marL="0" indent="0">
               <a:buNone/>
             </a:pPr>
             <a:r>
@@ -3972,7 +3731,7 @@
             <a:endParaRPr lang="en-US" sz="1300" dirty="0"/>
           </a:p>
           <a:p>
-            <a:pPr indent="0" marL="0">
+            <a:pPr marL="0" indent="0">
               <a:buNone/>
             </a:pPr>
             <a:r>
@@ -3989,7 +3748,7 @@
             <a:endParaRPr lang="en-US" sz="1300" dirty="0"/>
           </a:p>
           <a:p>
-            <a:pPr indent="0" marL="0">
+            <a:pPr marL="0" indent="0">
               <a:buNone/>
             </a:pPr>
             <a:r>
@@ -4006,7 +3765,7 @@
             <a:endParaRPr lang="en-US" sz="1300" dirty="0"/>
           </a:p>
           <a:p>
-            <a:pPr indent="0" marL="0">
+            <a:pPr marL="0" indent="0">
               <a:buNone/>
             </a:pPr>
             <a:r>
@@ -4023,7 +3782,7 @@
             <a:endParaRPr lang="en-US" sz="1300" dirty="0"/>
           </a:p>
           <a:p>
-            <a:pPr indent="0" marL="0">
+            <a:pPr marL="0" indent="0">
               <a:buNone/>
             </a:pPr>
             <a:r>
@@ -4040,7 +3799,7 @@
             <a:endParaRPr lang="en-US" sz="1300" dirty="0"/>
           </a:p>
           <a:p>
-            <a:pPr indent="0" marL="0">
+            <a:pPr marL="0" indent="0">
               <a:buNone/>
             </a:pPr>
             <a:r>
@@ -4057,7 +3816,7 @@
             <a:endParaRPr lang="en-US" sz="1300" dirty="0"/>
           </a:p>
           <a:p>
-            <a:pPr indent="0" marL="0">
+            <a:pPr marL="0" indent="0">
               <a:buNone/>
             </a:pPr>
             <a:r>
@@ -4096,7 +3855,7 @@
           <a:bodyPr wrap="square" lIns="0" tIns="0" rIns="0" bIns="0" rtlCol="0" anchor="ctr"/>
           <a:lstStyle/>
           <a:p>
-            <a:pPr indent="0" marL="0">
+            <a:pPr marL="0" indent="0">
               <a:buNone/>
             </a:pPr>
             <a:r>
@@ -4134,7 +3893,7 @@
           <a:bodyPr wrap="square" lIns="152400" tIns="152400" rIns="152400" bIns="152400" rtlCol="0" anchor="ctr"/>
           <a:lstStyle/>
           <a:p>
-            <a:pPr indent="0" marL="0">
+            <a:pPr marL="0" indent="0">
               <a:buNone/>
             </a:pPr>
             <a:r>
@@ -4230,7 +3989,7 @@
           </a:prstGeom>
           <a:extLst>
             <a:ext uri="{C572A759-6A51-4108-AA02-DFA0A04FC94B}">
-              <ma14:wrappingTextBoxFlag xmlns:ma14="http://schemas.microsoft.com/office/mac/drawingml/2011/main" val="0"/>
+              <ma14:wrappingTextBoxFlag xmlns:ma14="http://schemas.microsoft.com/office/mac/drawingml/2011/main" xmlns="" val="0"/>
             </a:ext>
           </a:extLst>
         </p:spPr>
@@ -4248,7 +4007,7 @@
           <a:p>
             <a:pPr algn="r"/>
             <a:fld id="{F7021451-1387-4CA6-816F-3879F97B5CBC}" type="slidenum">
-              <a:rPr b="0" lang="en-US"/>
+              <a:rPr lang="en-US" b="0"/>
               <a:t>12</a:t>
             </a:fld>
             <a:endParaRPr lang="en-US"/>
@@ -4283,9 +4042,11 @@
       <p:sp>
         <p:nvSpPr>
           <p:cNvPr id="2" name="Text 0"/>
-          <p:cNvSpPr/>
+          <p:cNvSpPr>
+            <a:spLocks noGrp="1"/>
+          </p:cNvSpPr>
           <p:nvPr>
-            <p:ph idx="100" type="title" hasCustomPrompt="1"/>
+            <p:ph type="title" idx="100" hasCustomPrompt="1"/>
           </p:nvPr>
         </p:nvSpPr>
         <p:spPr>
@@ -4303,7 +4064,7 @@
           <a:bodyPr wrap="square" rtlCol="0" anchor="ctr"/>
           <a:lstStyle/>
           <a:p>
-            <a:pPr algn="l" indent="0" marL="0">
+            <a:pPr marL="0" indent="0" algn="l">
               <a:buNone/>
             </a:pPr>
             <a:r>
@@ -4368,7 +4129,7 @@
           <a:bodyPr wrap="square" lIns="0" tIns="0" rIns="0" bIns="0" rtlCol="0" anchor="ctr"/>
           <a:lstStyle/>
           <a:p>
-            <a:pPr algn="ctr" indent="0" marL="0">
+            <a:pPr marL="0" indent="0" algn="ctr">
               <a:buNone/>
             </a:pPr>
             <a:r>
@@ -4404,7 +4165,7 @@
           <a:bodyPr wrap="square" lIns="0" tIns="0" rIns="0" bIns="0" rtlCol="0" anchor="ctr"/>
           <a:lstStyle/>
           <a:p>
-            <a:pPr indent="0" marL="0">
+            <a:pPr marL="0" indent="0">
               <a:buNone/>
             </a:pPr>
             <a:r>
@@ -4584,7 +4345,7 @@
           <a:bodyPr wrap="square" lIns="0" tIns="0" rIns="0" bIns="0" rtlCol="0" anchor="ctr"/>
           <a:lstStyle/>
           <a:p>
-            <a:pPr algn="ctr" indent="0" marL="0">
+            <a:pPr marL="0" indent="0" algn="ctr">
               <a:buNone/>
             </a:pPr>
             <a:r>
@@ -4620,7 +4381,7 @@
           <a:bodyPr wrap="square" lIns="0" tIns="0" rIns="0" bIns="0" rtlCol="0" anchor="ctr"/>
           <a:lstStyle/>
           <a:p>
-            <a:pPr indent="0" marL="0">
+            <a:pPr marL="0" indent="0">
               <a:buNone/>
             </a:pPr>
             <a:r>
@@ -4782,7 +4543,7 @@
           <a:bodyPr wrap="square" lIns="0" tIns="0" rIns="0" bIns="0" rtlCol="0" anchor="ctr"/>
           <a:lstStyle/>
           <a:p>
-            <a:pPr algn="ctr" indent="0" marL="0">
+            <a:pPr marL="0" indent="0" algn="ctr">
               <a:buNone/>
             </a:pPr>
             <a:r>
@@ -4818,7 +4579,7 @@
           <a:bodyPr wrap="square" lIns="0" tIns="0" rIns="0" bIns="0" rtlCol="0" anchor="ctr"/>
           <a:lstStyle/>
           <a:p>
-            <a:pPr indent="0" marL="0">
+            <a:pPr marL="0" indent="0">
               <a:buNone/>
             </a:pPr>
             <a:r>
@@ -4968,7 +4729,7 @@
           </a:prstGeom>
           <a:extLst>
             <a:ext uri="{C572A759-6A51-4108-AA02-DFA0A04FC94B}">
-              <ma14:wrappingTextBoxFlag xmlns:ma14="http://schemas.microsoft.com/office/mac/drawingml/2011/main" val="0"/>
+              <ma14:wrappingTextBoxFlag xmlns:ma14="http://schemas.microsoft.com/office/mac/drawingml/2011/main" xmlns="" val="0"/>
             </a:ext>
           </a:extLst>
         </p:spPr>
@@ -4986,7 +4747,7 @@
           <a:p>
             <a:pPr algn="r"/>
             <a:fld id="{F7021451-1387-4CA6-816F-3879F97B5CBC}" type="slidenum">
-              <a:rPr b="0" lang="en-US"/>
+              <a:rPr lang="en-US" b="0"/>
               <a:t>13</a:t>
             </a:fld>
             <a:endParaRPr lang="en-US"/>
@@ -5021,9 +4782,11 @@
       <p:sp>
         <p:nvSpPr>
           <p:cNvPr id="2" name="Text 0"/>
-          <p:cNvSpPr/>
+          <p:cNvSpPr>
+            <a:spLocks noGrp="1"/>
+          </p:cNvSpPr>
           <p:nvPr>
-            <p:ph idx="100" type="title" hasCustomPrompt="1"/>
+            <p:ph type="title" idx="100" hasCustomPrompt="1"/>
           </p:nvPr>
         </p:nvSpPr>
         <p:spPr>
@@ -5041,7 +4804,7 @@
           <a:bodyPr wrap="square" rtlCol="0" anchor="b"/>
           <a:lstStyle/>
           <a:p>
-            <a:pPr indent="0" marL="0">
+            <a:pPr marL="0" indent="0">
               <a:buNone/>
             </a:pPr>
             <a:r>
@@ -5059,9 +4822,11 @@
       <p:sp>
         <p:nvSpPr>
           <p:cNvPr id="3" name="Text 0"/>
-          <p:cNvSpPr/>
+          <p:cNvSpPr>
+            <a:spLocks noGrp="1"/>
+          </p:cNvSpPr>
           <p:nvPr>
-            <p:ph idx="101" type="body" hasCustomPrompt="1"/>
+            <p:ph type="body" idx="101" hasCustomPrompt="1"/>
           </p:nvPr>
         </p:nvSpPr>
         <p:spPr>
@@ -5079,7 +4844,7 @@
           <a:bodyPr wrap="square" rtlCol="0" anchor="t"/>
           <a:lstStyle/>
           <a:p>
-            <a:pPr indent="0" marL="0">
+            <a:pPr marL="0" indent="0">
               <a:buNone/>
             </a:pPr>
             <a:r>
@@ -5093,7 +4858,7 @@
             <a:endParaRPr lang="en-US" sz="1800" dirty="0"/>
           </a:p>
           <a:p>
-            <a:pPr indent="0" marL="0">
+            <a:pPr marL="0" indent="0">
               <a:buNone/>
             </a:pPr>
             <a:r>
@@ -5107,7 +4872,7 @@
             <a:endParaRPr lang="en-US" sz="1800" dirty="0"/>
           </a:p>
           <a:p>
-            <a:pPr indent="0" marL="0">
+            <a:pPr marL="0" indent="0">
               <a:buNone/>
             </a:pPr>
             <a:r>
@@ -5150,9 +4915,11 @@
       <p:sp>
         <p:nvSpPr>
           <p:cNvPr id="2" name="Text 0"/>
-          <p:cNvSpPr/>
+          <p:cNvSpPr>
+            <a:spLocks noGrp="1"/>
+          </p:cNvSpPr>
           <p:nvPr>
-            <p:ph idx="100" type="title" hasCustomPrompt="1"/>
+            <p:ph type="title" idx="100" hasCustomPrompt="1"/>
           </p:nvPr>
         </p:nvSpPr>
         <p:spPr>
@@ -5170,7 +4937,7 @@
           <a:bodyPr wrap="square" rtlCol="0" anchor="ctr"/>
           <a:lstStyle/>
           <a:p>
-            <a:pPr algn="l" indent="0" marL="0">
+            <a:pPr marL="0" indent="0" algn="l">
               <a:buNone/>
             </a:pPr>
             <a:r>
@@ -5304,7 +5071,7 @@
           <a:bodyPr wrap="square" rtlCol="0" anchor="ctr"/>
           <a:lstStyle/>
           <a:p>
-            <a:pPr algn="ctr" indent="0" marL="0">
+            <a:pPr marL="0" indent="0" algn="ctr">
               <a:buNone/>
             </a:pPr>
             <a:r>
@@ -5340,7 +5107,7 @@
           <a:bodyPr wrap="square" lIns="0" tIns="0" rIns="0" bIns="0" rtlCol="0" anchor="ctr"/>
           <a:lstStyle/>
           <a:p>
-            <a:pPr indent="0" marL="0">
+            <a:pPr marL="0" indent="0">
               <a:buNone/>
             </a:pPr>
             <a:r>
@@ -5404,7 +5171,7 @@
           <a:bodyPr wrap="square" rtlCol="0" anchor="ctr"/>
           <a:lstStyle/>
           <a:p>
-            <a:pPr algn="ctr" indent="0" marL="0">
+            <a:pPr marL="0" indent="0" algn="ctr">
               <a:buNone/>
             </a:pPr>
             <a:r>
@@ -5440,7 +5207,7 @@
           <a:bodyPr wrap="square" lIns="0" tIns="0" rIns="0" bIns="0" rtlCol="0" anchor="ctr"/>
           <a:lstStyle/>
           <a:p>
-            <a:pPr indent="0" marL="0">
+            <a:pPr marL="0" indent="0">
               <a:buNone/>
             </a:pPr>
             <a:r>
@@ -5504,7 +5271,7 @@
           <a:bodyPr wrap="square" rtlCol="0" anchor="ctr"/>
           <a:lstStyle/>
           <a:p>
-            <a:pPr algn="ctr" indent="0" marL="0">
+            <a:pPr marL="0" indent="0" algn="ctr">
               <a:buNone/>
             </a:pPr>
             <a:r>
@@ -5540,7 +5307,7 @@
           <a:bodyPr wrap="square" lIns="0" tIns="0" rIns="0" bIns="0" rtlCol="0" anchor="ctr"/>
           <a:lstStyle/>
           <a:p>
-            <a:pPr indent="0" marL="0">
+            <a:pPr marL="0" indent="0">
               <a:buNone/>
             </a:pPr>
             <a:r>
@@ -5604,7 +5371,7 @@
           <a:bodyPr wrap="square" rtlCol="0" anchor="ctr"/>
           <a:lstStyle/>
           <a:p>
-            <a:pPr algn="ctr" indent="0" marL="0">
+            <a:pPr marL="0" indent="0" algn="ctr">
               <a:buNone/>
             </a:pPr>
             <a:r>
@@ -5640,7 +5407,7 @@
           <a:bodyPr wrap="square" lIns="0" tIns="0" rIns="0" bIns="0" rtlCol="0" anchor="ctr"/>
           <a:lstStyle/>
           <a:p>
-            <a:pPr indent="0" marL="0">
+            <a:pPr marL="0" indent="0">
               <a:buNone/>
             </a:pPr>
             <a:r>
@@ -5676,7 +5443,7 @@
           <a:bodyPr wrap="square" rtlCol="0" anchor="t"/>
           <a:lstStyle/>
           <a:p>
-            <a:pPr indent="0" marL="0">
+            <a:pPr marL="0" indent="0">
               <a:buNone/>
             </a:pPr>
             <a:r>
@@ -5711,7 +5478,7 @@
           </a:prstGeom>
           <a:extLst>
             <a:ext uri="{C572A759-6A51-4108-AA02-DFA0A04FC94B}">
-              <ma14:wrappingTextBoxFlag xmlns:ma14="http://schemas.microsoft.com/office/mac/drawingml/2011/main" val="0"/>
+              <ma14:wrappingTextBoxFlag xmlns:ma14="http://schemas.microsoft.com/office/mac/drawingml/2011/main" xmlns="" val="0"/>
             </a:ext>
           </a:extLst>
         </p:spPr>
@@ -5729,7 +5496,7 @@
           <a:p>
             <a:pPr algn="r"/>
             <a:fld id="{F7021451-1387-4CA6-816F-3879F97B5CBC}" type="slidenum">
-              <a:rPr b="0" lang="en-US"/>
+              <a:rPr lang="en-US" b="0"/>
               <a:t>2</a:t>
             </a:fld>
             <a:endParaRPr lang="en-US"/>
@@ -5764,9 +5531,11 @@
       <p:sp>
         <p:nvSpPr>
           <p:cNvPr id="2" name="Text 0"/>
-          <p:cNvSpPr/>
+          <p:cNvSpPr>
+            <a:spLocks noGrp="1"/>
+          </p:cNvSpPr>
           <p:nvPr>
-            <p:ph idx="100" type="title" hasCustomPrompt="1"/>
+            <p:ph type="title" idx="100" hasCustomPrompt="1"/>
           </p:nvPr>
         </p:nvSpPr>
         <p:spPr>
@@ -5784,7 +5553,7 @@
           <a:bodyPr wrap="square" rtlCol="0" anchor="ctr"/>
           <a:lstStyle/>
           <a:p>
-            <a:pPr algn="l" indent="0" marL="0">
+            <a:pPr marL="0" indent="0" algn="l">
               <a:buNone/>
             </a:pPr>
             <a:r>
@@ -5820,7 +5589,7 @@
           <a:bodyPr wrap="square" lIns="0" tIns="0" rIns="0" bIns="0" rtlCol="0" anchor="ctr"/>
           <a:lstStyle/>
           <a:p>
-            <a:pPr indent="0" marL="0">
+            <a:pPr marL="0" indent="0">
               <a:buNone/>
             </a:pPr>
             <a:r>
@@ -5859,7 +5628,7 @@
           <a:bodyPr wrap="square" lIns="0" tIns="0" rIns="0" bIns="0" rtlCol="0" anchor="t"/>
           <a:lstStyle/>
           <a:p>
-            <a:pPr indent="0" marL="0">
+            <a:pPr marL="0" indent="0">
               <a:buNone/>
             </a:pPr>
             <a:r>
@@ -5920,7 +5689,7 @@
           <a:bodyPr wrap="square" lIns="0" tIns="0" rIns="0" bIns="0" rtlCol="0" anchor="ctr"/>
           <a:lstStyle/>
           <a:p>
-            <a:pPr indent="0" marL="0">
+            <a:pPr marL="0" indent="0">
               <a:buNone/>
             </a:pPr>
             <a:r>
@@ -5959,7 +5728,7 @@
           <a:bodyPr wrap="square" lIns="0" tIns="0" rIns="0" bIns="0" rtlCol="0" anchor="t"/>
           <a:lstStyle/>
           <a:p>
-            <a:pPr indent="0" marL="0">
+            <a:pPr marL="0" indent="0">
               <a:buNone/>
             </a:pPr>
             <a:r>
@@ -6020,7 +5789,7 @@
           <a:bodyPr wrap="square" lIns="0" tIns="0" rIns="0" bIns="0" rtlCol="0" anchor="ctr"/>
           <a:lstStyle/>
           <a:p>
-            <a:pPr indent="0" marL="0">
+            <a:pPr marL="0" indent="0">
               <a:buNone/>
             </a:pPr>
             <a:r>
@@ -6059,7 +5828,7 @@
           <a:bodyPr wrap="square" lIns="0" tIns="0" rIns="0" bIns="0" rtlCol="0" anchor="t"/>
           <a:lstStyle/>
           <a:p>
-            <a:pPr indent="0" marL="0">
+            <a:pPr marL="0" indent="0">
               <a:buNone/>
             </a:pPr>
             <a:r>
@@ -6120,7 +5889,7 @@
           <a:bodyPr wrap="square" lIns="0" tIns="0" rIns="0" bIns="0" rtlCol="0" anchor="ctr"/>
           <a:lstStyle/>
           <a:p>
-            <a:pPr indent="0" marL="0">
+            <a:pPr marL="0" indent="0">
               <a:buNone/>
             </a:pPr>
             <a:r>
@@ -6159,7 +5928,7 @@
           <a:bodyPr wrap="square" lIns="0" tIns="0" rIns="0" bIns="0" rtlCol="0" anchor="t"/>
           <a:lstStyle/>
           <a:p>
-            <a:pPr indent="0" marL="0">
+            <a:pPr marL="0" indent="0">
               <a:buNone/>
             </a:pPr>
             <a:r>
@@ -6220,7 +5989,7 @@
           <a:bodyPr wrap="square" lIns="0" tIns="0" rIns="0" bIns="0" rtlCol="0" anchor="ctr"/>
           <a:lstStyle/>
           <a:p>
-            <a:pPr indent="0" marL="0">
+            <a:pPr marL="0" indent="0">
               <a:buNone/>
             </a:pPr>
             <a:r>
@@ -6259,7 +6028,7 @@
           <a:bodyPr wrap="square" lIns="0" tIns="0" rIns="0" bIns="0" rtlCol="0" anchor="t"/>
           <a:lstStyle/>
           <a:p>
-            <a:pPr indent="0" marL="0">
+            <a:pPr marL="0" indent="0">
               <a:buNone/>
             </a:pPr>
             <a:r>
@@ -6294,7 +6063,7 @@
           </a:prstGeom>
           <a:extLst>
             <a:ext uri="{C572A759-6A51-4108-AA02-DFA0A04FC94B}">
-              <ma14:wrappingTextBoxFlag xmlns:ma14="http://schemas.microsoft.com/office/mac/drawingml/2011/main" val="0"/>
+              <ma14:wrappingTextBoxFlag xmlns:ma14="http://schemas.microsoft.com/office/mac/drawingml/2011/main" xmlns="" val="0"/>
             </a:ext>
           </a:extLst>
         </p:spPr>
@@ -6312,7 +6081,7 @@
           <a:p>
             <a:pPr algn="r"/>
             <a:fld id="{F7021451-1387-4CA6-816F-3879F97B5CBC}" type="slidenum">
-              <a:rPr b="0" lang="en-US"/>
+              <a:rPr lang="en-US" b="0"/>
               <a:t>3</a:t>
             </a:fld>
             <a:endParaRPr lang="en-US"/>
@@ -6347,9 +6116,11 @@
       <p:sp>
         <p:nvSpPr>
           <p:cNvPr id="2" name="Text 0"/>
-          <p:cNvSpPr/>
+          <p:cNvSpPr>
+            <a:spLocks noGrp="1"/>
+          </p:cNvSpPr>
           <p:nvPr>
-            <p:ph idx="100" type="title" hasCustomPrompt="1"/>
+            <p:ph type="title" idx="100" hasCustomPrompt="1"/>
           </p:nvPr>
         </p:nvSpPr>
         <p:spPr>
@@ -6367,7 +6138,7 @@
           <a:bodyPr wrap="square" rtlCol="0" anchor="ctr"/>
           <a:lstStyle/>
           <a:p>
-            <a:pPr algn="l" indent="0" marL="0">
+            <a:pPr marL="0" indent="0" algn="l">
               <a:buNone/>
             </a:pPr>
             <a:r>
@@ -6403,7 +6174,7 @@
           <a:bodyPr wrap="square" lIns="0" tIns="0" rIns="0" bIns="0" rtlCol="0" anchor="ctr"/>
           <a:lstStyle/>
           <a:p>
-            <a:pPr indent="0" marL="0">
+            <a:pPr marL="0" indent="0">
               <a:buNone/>
             </a:pPr>
             <a:r>
@@ -6442,7 +6213,7 @@
           <a:bodyPr wrap="square" lIns="0" tIns="0" rIns="0" bIns="0" rtlCol="0" anchor="ctr"/>
           <a:lstStyle/>
           <a:p>
-            <a:pPr indent="0" marL="0">
+            <a:pPr marL="0" indent="0">
               <a:buNone/>
             </a:pPr>
             <a:r>
@@ -6482,7 +6253,7 @@
           <a:bodyPr wrap="square" lIns="0" tIns="0" rIns="0" bIns="0" rtlCol="0" anchor="ctr"/>
           <a:lstStyle/>
           <a:p>
-            <a:pPr algn="ctr" indent="0" marL="0">
+            <a:pPr marL="0" indent="0" algn="ctr">
               <a:buNone/>
             </a:pPr>
             <a:r>
@@ -6518,7 +6289,7 @@
           <a:bodyPr wrap="square" lIns="0" tIns="0" rIns="0" bIns="0" rtlCol="0" anchor="ctr"/>
           <a:lstStyle/>
           <a:p>
-            <a:pPr indent="0" marL="0">
+            <a:pPr marL="0" indent="0">
               <a:buNone/>
             </a:pPr>
             <a:r>
@@ -6554,7 +6325,7 @@
           <a:bodyPr wrap="square" lIns="0" tIns="0" rIns="0" bIns="0" rtlCol="0" anchor="ctr"/>
           <a:lstStyle/>
           <a:p>
-            <a:pPr indent="0" marL="0">
+            <a:pPr marL="0" indent="0">
               <a:buNone/>
             </a:pPr>
             <a:r>
@@ -6593,7 +6364,7 @@
           <a:bodyPr wrap="square" lIns="0" tIns="0" rIns="0" bIns="0" rtlCol="0" anchor="ctr"/>
           <a:lstStyle/>
           <a:p>
-            <a:pPr indent="0" marL="0">
+            <a:pPr marL="0" indent="0">
               <a:buNone/>
             </a:pPr>
             <a:r>
@@ -6633,7 +6404,7 @@
           <a:bodyPr wrap="square" lIns="0" tIns="0" rIns="0" bIns="0" rtlCol="0" anchor="ctr"/>
           <a:lstStyle/>
           <a:p>
-            <a:pPr algn="ctr" indent="0" marL="0">
+            <a:pPr marL="0" indent="0" algn="ctr">
               <a:buNone/>
             </a:pPr>
             <a:r>
@@ -6669,7 +6440,7 @@
           <a:bodyPr wrap="square" lIns="0" tIns="0" rIns="0" bIns="0" rtlCol="0" anchor="ctr"/>
           <a:lstStyle/>
           <a:p>
-            <a:pPr indent="0" marL="0">
+            <a:pPr marL="0" indent="0">
               <a:buNone/>
             </a:pPr>
             <a:r>
@@ -6705,7 +6476,7 @@
           <a:bodyPr wrap="square" lIns="0" tIns="0" rIns="0" bIns="0" rtlCol="0" anchor="ctr"/>
           <a:lstStyle/>
           <a:p>
-            <a:pPr indent="0" marL="0">
+            <a:pPr marL="0" indent="0">
               <a:buNone/>
             </a:pPr>
             <a:r>
@@ -6744,7 +6515,7 @@
           <a:bodyPr wrap="square" lIns="0" tIns="0" rIns="0" bIns="0" rtlCol="0" anchor="ctr"/>
           <a:lstStyle/>
           <a:p>
-            <a:pPr indent="0" marL="0">
+            <a:pPr marL="0" indent="0">
               <a:buNone/>
             </a:pPr>
             <a:r>
@@ -6784,7 +6555,7 @@
           <a:bodyPr wrap="square" lIns="0" tIns="0" rIns="0" bIns="0" rtlCol="0" anchor="ctr"/>
           <a:lstStyle/>
           <a:p>
-            <a:pPr algn="ctr" indent="0" marL="0">
+            <a:pPr marL="0" indent="0" algn="ctr">
               <a:buNone/>
             </a:pPr>
             <a:r>
@@ -6820,7 +6591,7 @@
           <a:bodyPr wrap="square" lIns="0" tIns="0" rIns="0" bIns="0" rtlCol="0" anchor="ctr"/>
           <a:lstStyle/>
           <a:p>
-            <a:pPr indent="0" marL="0">
+            <a:pPr marL="0" indent="0">
               <a:buNone/>
             </a:pPr>
             <a:r>
@@ -6856,7 +6627,7 @@
           <a:bodyPr wrap="square" lIns="0" tIns="0" rIns="0" bIns="0" rtlCol="0" anchor="ctr"/>
           <a:lstStyle/>
           <a:p>
-            <a:pPr indent="0" marL="0">
+            <a:pPr marL="0" indent="0">
               <a:buNone/>
             </a:pPr>
             <a:r>
@@ -6895,7 +6666,7 @@
           <a:bodyPr wrap="square" lIns="0" tIns="0" rIns="0" bIns="0" rtlCol="0" anchor="ctr"/>
           <a:lstStyle/>
           <a:p>
-            <a:pPr indent="0" marL="0">
+            <a:pPr marL="0" indent="0">
               <a:buNone/>
             </a:pPr>
             <a:r>
@@ -6935,7 +6706,7 @@
           <a:bodyPr wrap="square" lIns="0" tIns="0" rIns="0" bIns="0" rtlCol="0" anchor="ctr"/>
           <a:lstStyle/>
           <a:p>
-            <a:pPr algn="ctr" indent="0" marL="0">
+            <a:pPr marL="0" indent="0" algn="ctr">
               <a:buNone/>
             </a:pPr>
             <a:r>
@@ -6971,7 +6742,7 @@
           <a:bodyPr wrap="square" lIns="0" tIns="0" rIns="0" bIns="0" rtlCol="0" anchor="ctr"/>
           <a:lstStyle/>
           <a:p>
-            <a:pPr indent="0" marL="0">
+            <a:pPr marL="0" indent="0">
               <a:buNone/>
             </a:pPr>
             <a:r>
@@ -7007,7 +6778,7 @@
           <a:bodyPr wrap="square" lIns="0" tIns="0" rIns="0" bIns="0" rtlCol="0" anchor="ctr"/>
           <a:lstStyle/>
           <a:p>
-            <a:pPr indent="0" marL="0">
+            <a:pPr marL="0" indent="0">
               <a:buNone/>
             </a:pPr>
             <a:r>
@@ -7046,7 +6817,7 @@
           <a:bodyPr wrap="square" lIns="0" tIns="0" rIns="0" bIns="0" rtlCol="0" anchor="ctr"/>
           <a:lstStyle/>
           <a:p>
-            <a:pPr indent="0" marL="0">
+            <a:pPr marL="0" indent="0">
               <a:buNone/>
             </a:pPr>
             <a:r>
@@ -7086,7 +6857,7 @@
           <a:bodyPr wrap="square" lIns="0" tIns="0" rIns="0" bIns="0" rtlCol="0" anchor="ctr"/>
           <a:lstStyle/>
           <a:p>
-            <a:pPr algn="ctr" indent="0" marL="0">
+            <a:pPr marL="0" indent="0" algn="ctr">
               <a:buNone/>
             </a:pPr>
             <a:r>
@@ -7122,7 +6893,7 @@
           <a:bodyPr wrap="square" lIns="0" tIns="0" rIns="0" bIns="0" rtlCol="0" anchor="ctr"/>
           <a:lstStyle/>
           <a:p>
-            <a:pPr indent="0" marL="0">
+            <a:pPr marL="0" indent="0">
               <a:buNone/>
             </a:pPr>
             <a:r>
@@ -7158,7 +6929,7 @@
           <a:bodyPr wrap="square" lIns="0" tIns="0" rIns="0" bIns="0" rtlCol="0" anchor="ctr"/>
           <a:lstStyle/>
           <a:p>
-            <a:pPr indent="0" marL="0">
+            <a:pPr marL="0" indent="0">
               <a:buNone/>
             </a:pPr>
             <a:r>
@@ -7197,7 +6968,7 @@
           <a:bodyPr wrap="square" lIns="0" tIns="0" rIns="0" bIns="0" rtlCol="0" anchor="ctr"/>
           <a:lstStyle/>
           <a:p>
-            <a:pPr indent="0" marL="0">
+            <a:pPr marL="0" indent="0">
               <a:buNone/>
             </a:pPr>
             <a:r>
@@ -7237,7 +7008,7 @@
           <a:bodyPr wrap="square" lIns="0" tIns="0" rIns="0" bIns="0" rtlCol="0" anchor="ctr"/>
           <a:lstStyle/>
           <a:p>
-            <a:pPr algn="ctr" indent="0" marL="0">
+            <a:pPr marL="0" indent="0" algn="ctr">
               <a:buNone/>
             </a:pPr>
             <a:r>
@@ -7273,7 +7044,7 @@
           <a:bodyPr wrap="square" lIns="0" tIns="0" rIns="0" bIns="0" rtlCol="0" anchor="ctr"/>
           <a:lstStyle/>
           <a:p>
-            <a:pPr indent="0" marL="0">
+            <a:pPr marL="0" indent="0">
               <a:buNone/>
             </a:pPr>
             <a:r>
@@ -7290,7 +7061,7 @@
       </p:sp>
       <p:sp>
         <p:nvSpPr>
-          <p:cNvPr id="25" name="Slide Number Placeholder 0"/>
+          <p:cNvPr id="27" name="Slide Number Placeholder 0"/>
           <p:cNvSpPr>
             <a:spLocks noGrp="1"/>
           </p:cNvSpPr>
@@ -7308,7 +7079,7 @@
           </a:prstGeom>
           <a:extLst>
             <a:ext uri="{C572A759-6A51-4108-AA02-DFA0A04FC94B}">
-              <ma14:wrappingTextBoxFlag xmlns:ma14="http://schemas.microsoft.com/office/mac/drawingml/2011/main" val="0"/>
+              <ma14:wrappingTextBoxFlag xmlns:ma14="http://schemas.microsoft.com/office/mac/drawingml/2011/main" xmlns="" val="0"/>
             </a:ext>
           </a:extLst>
         </p:spPr>
@@ -7326,7 +7097,7 @@
           <a:p>
             <a:pPr algn="r"/>
             <a:fld id="{F7021451-1387-4CA6-816F-3879F97B5CBC}" type="slidenum">
-              <a:rPr b="0" lang="en-US"/>
+              <a:rPr lang="en-US" b="0"/>
               <a:t>4</a:t>
             </a:fld>
             <a:endParaRPr lang="en-US"/>
@@ -7361,9 +7132,11 @@
       <p:sp>
         <p:nvSpPr>
           <p:cNvPr id="2" name="Text 0"/>
-          <p:cNvSpPr/>
+          <p:cNvSpPr>
+            <a:spLocks noGrp="1"/>
+          </p:cNvSpPr>
           <p:nvPr>
-            <p:ph idx="100" type="title" hasCustomPrompt="1"/>
+            <p:ph type="title" idx="100" hasCustomPrompt="1"/>
           </p:nvPr>
         </p:nvSpPr>
         <p:spPr>
@@ -7381,7 +7154,7 @@
           <a:bodyPr wrap="square" rtlCol="0" anchor="ctr"/>
           <a:lstStyle/>
           <a:p>
-            <a:pPr algn="l" indent="0" marL="0">
+            <a:pPr marL="0" indent="0" algn="l">
               <a:buNone/>
             </a:pPr>
             <a:r>
@@ -7398,14 +7171,14 @@
       </p:sp>
       <p:pic>
         <p:nvPicPr>
-          <p:cNvPr id="3" name="aws-diagram" descr="C:\Projects\KGCR_Cloud_Project_2026\architecture\AWS_Architecture.png">    </p:cNvPr>
+          <p:cNvPr id="3" name="aws-diagram" descr="C:\Projects\KGCR_Cloud_Project_2026\architecture\AWS_Architecture.png"/>
           <p:cNvPicPr>
             <a:picLocks noChangeAspect="1"/>
           </p:cNvPicPr>
           <p:nvPr/>
         </p:nvPicPr>
         <p:blipFill>
-          <a:blip r:embed="rId1"/>
+          <a:blip r:embed="rId3"/>
           <a:stretch>
             <a:fillRect/>
           </a:stretch>
@@ -7445,7 +7218,7 @@
           <a:bodyPr wrap="square" lIns="0" tIns="0" rIns="0" bIns="0" rtlCol="0" anchor="ctr"/>
           <a:lstStyle/>
           <a:p>
-            <a:pPr algn="ctr" indent="0" marL="0">
+            <a:pPr marL="0" indent="0" algn="ctr">
               <a:buNone/>
             </a:pPr>
             <a:r>
@@ -7556,7 +7329,7 @@
           </a:prstGeom>
           <a:extLst>
             <a:ext uri="{C572A759-6A51-4108-AA02-DFA0A04FC94B}">
-              <ma14:wrappingTextBoxFlag xmlns:ma14="http://schemas.microsoft.com/office/mac/drawingml/2011/main" val="0"/>
+              <ma14:wrappingTextBoxFlag xmlns:ma14="http://schemas.microsoft.com/office/mac/drawingml/2011/main" xmlns="" val="0"/>
             </a:ext>
           </a:extLst>
         </p:spPr>
@@ -7574,7 +7347,7 @@
           <a:p>
             <a:pPr algn="r"/>
             <a:fld id="{F7021451-1387-4CA6-816F-3879F97B5CBC}" type="slidenum">
-              <a:rPr b="0" lang="en-US"/>
+              <a:rPr lang="en-US" b="0"/>
               <a:t>5</a:t>
             </a:fld>
             <a:endParaRPr lang="en-US"/>
@@ -7609,9 +7382,11 @@
       <p:sp>
         <p:nvSpPr>
           <p:cNvPr id="2" name="Text 0"/>
-          <p:cNvSpPr/>
+          <p:cNvSpPr>
+            <a:spLocks noGrp="1"/>
+          </p:cNvSpPr>
           <p:nvPr>
-            <p:ph idx="100" type="title" hasCustomPrompt="1"/>
+            <p:ph type="title" idx="100" hasCustomPrompt="1"/>
           </p:nvPr>
         </p:nvSpPr>
         <p:spPr>
@@ -7629,7 +7404,7 @@
           <a:bodyPr wrap="square" rtlCol="0" anchor="ctr"/>
           <a:lstStyle/>
           <a:p>
-            <a:pPr algn="l" indent="0" marL="0">
+            <a:pPr marL="0" indent="0" algn="l">
               <a:buNone/>
             </a:pPr>
             <a:r>
@@ -7646,14 +7421,14 @@
       </p:sp>
       <p:pic>
         <p:nvPicPr>
-          <p:cNvPr id="3" name="system-diagram" descr="C:\Projects\KGCR_Cloud_Project_2026\architecture\System_Architecture.png">    </p:cNvPr>
+          <p:cNvPr id="3" name="system-diagram" descr="C:\Projects\KGCR_Cloud_Project_2026\architecture\System_Architecture.png"/>
           <p:cNvPicPr>
             <a:picLocks noChangeAspect="1"/>
           </p:cNvPicPr>
           <p:nvPr/>
         </p:nvPicPr>
         <p:blipFill>
-          <a:blip r:embed="rId1"/>
+          <a:blip r:embed="rId3"/>
           <a:stretch>
             <a:fillRect/>
           </a:stretch>
@@ -7764,7 +7539,7 @@
           </a:prstGeom>
           <a:extLst>
             <a:ext uri="{C572A759-6A51-4108-AA02-DFA0A04FC94B}">
-              <ma14:wrappingTextBoxFlag xmlns:ma14="http://schemas.microsoft.com/office/mac/drawingml/2011/main" val="0"/>
+              <ma14:wrappingTextBoxFlag xmlns:ma14="http://schemas.microsoft.com/office/mac/drawingml/2011/main" xmlns="" val="0"/>
             </a:ext>
           </a:extLst>
         </p:spPr>
@@ -7782,7 +7557,7 @@
           <a:p>
             <a:pPr algn="r"/>
             <a:fld id="{F7021451-1387-4CA6-816F-3879F97B5CBC}" type="slidenum">
-              <a:rPr b="0" lang="en-US"/>
+              <a:rPr lang="en-US" b="0"/>
               <a:t>6</a:t>
             </a:fld>
             <a:endParaRPr lang="en-US"/>
@@ -7817,9 +7592,11 @@
       <p:sp>
         <p:nvSpPr>
           <p:cNvPr id="2" name="Text 0"/>
-          <p:cNvSpPr/>
+          <p:cNvSpPr>
+            <a:spLocks noGrp="1"/>
+          </p:cNvSpPr>
           <p:nvPr>
-            <p:ph idx="100" type="title" hasCustomPrompt="1"/>
+            <p:ph type="title" idx="100" hasCustomPrompt="1"/>
           </p:nvPr>
         </p:nvSpPr>
         <p:spPr>
@@ -7837,7 +7614,7 @@
           <a:bodyPr wrap="square" rtlCol="0" anchor="ctr"/>
           <a:lstStyle/>
           <a:p>
-            <a:pPr algn="l" indent="0" marL="0">
+            <a:pPr marL="0" indent="0" algn="l">
               <a:buNone/>
             </a:pPr>
             <a:r>
@@ -7873,7 +7650,7 @@
           <a:bodyPr wrap="square" lIns="0" tIns="0" rIns="0" bIns="0" rtlCol="0" anchor="ctr"/>
           <a:lstStyle/>
           <a:p>
-            <a:pPr indent="0" marL="0">
+            <a:pPr marL="0" indent="0">
               <a:buNone/>
             </a:pPr>
             <a:r>
@@ -7912,7 +7689,7 @@
           <a:bodyPr wrap="square" lIns="0" tIns="0" rIns="0" bIns="0" rtlCol="0" anchor="t"/>
           <a:lstStyle/>
           <a:p>
-            <a:pPr indent="0" marL="0">
+            <a:pPr marL="0" indent="0">
               <a:buNone/>
             </a:pPr>
             <a:r>
@@ -7948,7 +7725,7 @@
           <a:bodyPr wrap="square" lIns="0" tIns="0" rIns="0" bIns="0" rtlCol="0" anchor="ctr"/>
           <a:lstStyle/>
           <a:p>
-            <a:pPr indent="0" marL="0">
+            <a:pPr marL="0" indent="0">
               <a:buNone/>
             </a:pPr>
             <a:r>
@@ -7987,7 +7764,7 @@
           <a:bodyPr wrap="square" lIns="0" tIns="0" rIns="0" bIns="0" rtlCol="0" anchor="t"/>
           <a:lstStyle/>
           <a:p>
-            <a:pPr indent="0" marL="0">
+            <a:pPr marL="0" indent="0">
               <a:buNone/>
             </a:pPr>
             <a:r>
@@ -8023,7 +7800,7 @@
           <a:bodyPr wrap="square" lIns="0" tIns="0" rIns="0" bIns="0" rtlCol="0" anchor="ctr"/>
           <a:lstStyle/>
           <a:p>
-            <a:pPr indent="0" marL="0">
+            <a:pPr marL="0" indent="0">
               <a:buNone/>
             </a:pPr>
             <a:r>
@@ -8062,7 +7839,7 @@
           <a:bodyPr wrap="square" lIns="0" tIns="0" rIns="0" bIns="0" rtlCol="0" anchor="t"/>
           <a:lstStyle/>
           <a:p>
-            <a:pPr indent="0" marL="0">
+            <a:pPr marL="0" indent="0">
               <a:buNone/>
             </a:pPr>
             <a:r>
@@ -8098,7 +7875,7 @@
           <a:bodyPr wrap="square" lIns="0" tIns="0" rIns="0" bIns="0" rtlCol="0" anchor="ctr"/>
           <a:lstStyle/>
           <a:p>
-            <a:pPr indent="0" marL="0">
+            <a:pPr marL="0" indent="0">
               <a:buNone/>
             </a:pPr>
             <a:r>
@@ -8137,7 +7914,7 @@
           <a:bodyPr wrap="square" lIns="0" tIns="0" rIns="0" bIns="0" rtlCol="0" anchor="t"/>
           <a:lstStyle/>
           <a:p>
-            <a:pPr indent="0" marL="0">
+            <a:pPr marL="0" indent="0">
               <a:buNone/>
             </a:pPr>
             <a:r>
@@ -8273,7 +8050,7 @@
           </a:prstGeom>
           <a:extLst>
             <a:ext uri="{C572A759-6A51-4108-AA02-DFA0A04FC94B}">
-              <ma14:wrappingTextBoxFlag xmlns:ma14="http://schemas.microsoft.com/office/mac/drawingml/2011/main" val="0"/>
+              <ma14:wrappingTextBoxFlag xmlns:ma14="http://schemas.microsoft.com/office/mac/drawingml/2011/main" xmlns="" val="0"/>
             </a:ext>
           </a:extLst>
         </p:spPr>
@@ -8291,7 +8068,7 @@
           <a:p>
             <a:pPr algn="r"/>
             <a:fld id="{F7021451-1387-4CA6-816F-3879F97B5CBC}" type="slidenum">
-              <a:rPr b="0" lang="en-US"/>
+              <a:rPr lang="en-US" b="0"/>
               <a:t>7</a:t>
             </a:fld>
             <a:endParaRPr lang="en-US"/>
@@ -8326,9 +8103,11 @@
       <p:sp>
         <p:nvSpPr>
           <p:cNvPr id="2" name="Text 0"/>
-          <p:cNvSpPr/>
+          <p:cNvSpPr>
+            <a:spLocks noGrp="1"/>
+          </p:cNvSpPr>
           <p:nvPr>
-            <p:ph idx="100" type="title" hasCustomPrompt="1"/>
+            <p:ph type="title" idx="100" hasCustomPrompt="1"/>
           </p:nvPr>
         </p:nvSpPr>
         <p:spPr>
@@ -8346,7 +8125,7 @@
           <a:bodyPr wrap="square" rtlCol="0" anchor="ctr"/>
           <a:lstStyle/>
           <a:p>
-            <a:pPr algn="l" indent="0" marL="0">
+            <a:pPr marL="0" indent="0" algn="l">
               <a:buNone/>
             </a:pPr>
             <a:r>
@@ -8407,7 +8186,7 @@
           <a:bodyPr wrap="square" lIns="0" tIns="0" rIns="0" bIns="0" rtlCol="0" anchor="ctr"/>
           <a:lstStyle/>
           <a:p>
-            <a:pPr indent="0" marL="0">
+            <a:pPr marL="0" indent="0">
               <a:buNone/>
             </a:pPr>
             <a:r>
@@ -8446,7 +8225,7 @@
           <a:bodyPr wrap="square" lIns="0" tIns="0" rIns="0" bIns="0" rtlCol="0" anchor="t"/>
           <a:lstStyle/>
           <a:p>
-            <a:pPr indent="0" marL="0">
+            <a:pPr marL="0" indent="0">
               <a:buNone/>
             </a:pPr>
             <a:r>
@@ -8486,7 +8265,7 @@
           <a:bodyPr wrap="square" lIns="0" tIns="0" rIns="0" bIns="0" rtlCol="0" anchor="ctr"/>
           <a:lstStyle/>
           <a:p>
-            <a:pPr algn="ctr" indent="0" marL="0">
+            <a:pPr marL="0" indent="0" algn="ctr">
               <a:buNone/>
             </a:pPr>
             <a:r>
@@ -8547,7 +8326,7 @@
           <a:bodyPr wrap="square" lIns="0" tIns="0" rIns="0" bIns="0" rtlCol="0" anchor="ctr"/>
           <a:lstStyle/>
           <a:p>
-            <a:pPr indent="0" marL="0">
+            <a:pPr marL="0" indent="0">
               <a:buNone/>
             </a:pPr>
             <a:r>
@@ -8586,7 +8365,7 @@
           <a:bodyPr wrap="square" lIns="0" tIns="0" rIns="0" bIns="0" rtlCol="0" anchor="t"/>
           <a:lstStyle/>
           <a:p>
-            <a:pPr indent="0" marL="0">
+            <a:pPr marL="0" indent="0">
               <a:buNone/>
             </a:pPr>
             <a:r>
@@ -8626,7 +8405,7 @@
           <a:bodyPr wrap="square" lIns="0" tIns="0" rIns="0" bIns="0" rtlCol="0" anchor="ctr"/>
           <a:lstStyle/>
           <a:p>
-            <a:pPr algn="ctr" indent="0" marL="0">
+            <a:pPr marL="0" indent="0" algn="ctr">
               <a:buNone/>
             </a:pPr>
             <a:r>
@@ -8687,7 +8466,7 @@
           <a:bodyPr wrap="square" lIns="0" tIns="0" rIns="0" bIns="0" rtlCol="0" anchor="ctr"/>
           <a:lstStyle/>
           <a:p>
-            <a:pPr indent="0" marL="0">
+            <a:pPr marL="0" indent="0">
               <a:buNone/>
             </a:pPr>
             <a:r>
@@ -8726,7 +8505,7 @@
           <a:bodyPr wrap="square" lIns="0" tIns="0" rIns="0" bIns="0" rtlCol="0" anchor="t"/>
           <a:lstStyle/>
           <a:p>
-            <a:pPr indent="0" marL="0">
+            <a:pPr marL="0" indent="0">
               <a:buNone/>
             </a:pPr>
             <a:r>
@@ -8766,7 +8545,7 @@
           <a:bodyPr wrap="square" lIns="0" tIns="0" rIns="0" bIns="0" rtlCol="0" anchor="ctr"/>
           <a:lstStyle/>
           <a:p>
-            <a:pPr algn="ctr" indent="0" marL="0">
+            <a:pPr marL="0" indent="0" algn="ctr">
               <a:buNone/>
             </a:pPr>
             <a:r>
@@ -8827,7 +8606,7 @@
           <a:bodyPr wrap="square" lIns="0" tIns="0" rIns="0" bIns="0" rtlCol="0" anchor="ctr"/>
           <a:lstStyle/>
           <a:p>
-            <a:pPr indent="0" marL="0">
+            <a:pPr marL="0" indent="0">
               <a:buNone/>
             </a:pPr>
             <a:r>
@@ -8866,7 +8645,7 @@
           <a:bodyPr wrap="square" lIns="0" tIns="0" rIns="0" bIns="0" rtlCol="0" anchor="t"/>
           <a:lstStyle/>
           <a:p>
-            <a:pPr indent="0" marL="0">
+            <a:pPr marL="0" indent="0">
               <a:buNone/>
             </a:pPr>
             <a:r>
@@ -8906,7 +8685,7 @@
           <a:bodyPr wrap="square" lIns="0" tIns="0" rIns="0" bIns="0" rtlCol="0" anchor="ctr"/>
           <a:lstStyle/>
           <a:p>
-            <a:pPr algn="ctr" indent="0" marL="0">
+            <a:pPr marL="0" indent="0" algn="ctr">
               <a:buNone/>
             </a:pPr>
             <a:r>
@@ -8967,7 +8746,7 @@
           <a:bodyPr wrap="square" lIns="0" tIns="0" rIns="0" bIns="0" rtlCol="0" anchor="ctr"/>
           <a:lstStyle/>
           <a:p>
-            <a:pPr indent="0" marL="0">
+            <a:pPr marL="0" indent="0">
               <a:buNone/>
             </a:pPr>
             <a:r>
@@ -9006,7 +8785,7 @@
           <a:bodyPr wrap="square" lIns="0" tIns="0" rIns="0" bIns="0" rtlCol="0" anchor="t"/>
           <a:lstStyle/>
           <a:p>
-            <a:pPr indent="0" marL="0">
+            <a:pPr marL="0" indent="0">
               <a:buNone/>
             </a:pPr>
             <a:r>
@@ -9046,7 +8825,7 @@
           <a:bodyPr wrap="square" lIns="0" tIns="0" rIns="0" bIns="0" rtlCol="0" anchor="ctr"/>
           <a:lstStyle/>
           <a:p>
-            <a:pPr algn="ctr" indent="0" marL="0">
+            <a:pPr marL="0" indent="0" algn="ctr">
               <a:buNone/>
             </a:pPr>
             <a:r>
@@ -9107,7 +8886,7 @@
           <a:bodyPr wrap="square" lIns="0" tIns="0" rIns="0" bIns="0" rtlCol="0" anchor="ctr"/>
           <a:lstStyle/>
           <a:p>
-            <a:pPr indent="0" marL="0">
+            <a:pPr marL="0" indent="0">
               <a:buNone/>
             </a:pPr>
             <a:r>
@@ -9146,7 +8925,7 @@
           <a:bodyPr wrap="square" lIns="0" tIns="0" rIns="0" bIns="0" rtlCol="0" anchor="t"/>
           <a:lstStyle/>
           <a:p>
-            <a:pPr indent="0" marL="0">
+            <a:pPr marL="0" indent="0">
               <a:buNone/>
             </a:pPr>
             <a:r>
@@ -9186,7 +8965,7 @@
           <a:bodyPr wrap="square" lIns="0" tIns="0" rIns="0" bIns="0" rtlCol="0" anchor="ctr"/>
           <a:lstStyle/>
           <a:p>
-            <a:pPr algn="ctr" indent="0" marL="0">
+            <a:pPr marL="0" indent="0" algn="ctr">
               <a:buNone/>
             </a:pPr>
             <a:r>
@@ -9224,7 +9003,7 @@
           <a:bodyPr wrap="square" lIns="152400" tIns="152400" rIns="152400" bIns="152400" rtlCol="0" anchor="ctr"/>
           <a:lstStyle/>
           <a:p>
-            <a:pPr indent="0" marL="0">
+            <a:pPr marL="0" indent="0">
               <a:buNone/>
             </a:pPr>
             <a:r>
@@ -9320,7 +9099,7 @@
       </p:sp>
       <p:sp>
         <p:nvSpPr>
-          <p:cNvPr id="25" name="Slide Number Placeholder 0"/>
+          <p:cNvPr id="29" name="Slide Number Placeholder 0"/>
           <p:cNvSpPr>
             <a:spLocks noGrp="1"/>
           </p:cNvSpPr>
@@ -9338,7 +9117,7 @@
           </a:prstGeom>
           <a:extLst>
             <a:ext uri="{C572A759-6A51-4108-AA02-DFA0A04FC94B}">
-              <ma14:wrappingTextBoxFlag xmlns:ma14="http://schemas.microsoft.com/office/mac/drawingml/2011/main" val="0"/>
+              <ma14:wrappingTextBoxFlag xmlns:ma14="http://schemas.microsoft.com/office/mac/drawingml/2011/main" xmlns="" val="0"/>
             </a:ext>
           </a:extLst>
         </p:spPr>
@@ -9356,7 +9135,7 @@
           <a:p>
             <a:pPr algn="r"/>
             <a:fld id="{F7021451-1387-4CA6-816F-3879F97B5CBC}" type="slidenum">
-              <a:rPr b="0" lang="en-US"/>
+              <a:rPr lang="en-US" b="0"/>
               <a:t>8</a:t>
             </a:fld>
             <a:endParaRPr lang="en-US"/>
@@ -9391,9 +9170,11 @@
       <p:sp>
         <p:nvSpPr>
           <p:cNvPr id="2" name="Text 0"/>
-          <p:cNvSpPr/>
+          <p:cNvSpPr>
+            <a:spLocks noGrp="1"/>
+          </p:cNvSpPr>
           <p:nvPr>
-            <p:ph idx="100" type="title" hasCustomPrompt="1"/>
+            <p:ph type="title" idx="100" hasCustomPrompt="1"/>
           </p:nvPr>
         </p:nvSpPr>
         <p:spPr>
@@ -9411,7 +9192,7 @@
           <a:bodyPr wrap="square" rtlCol="0" anchor="ctr"/>
           <a:lstStyle/>
           <a:p>
-            <a:pPr algn="l" indent="0" marL="0">
+            <a:pPr marL="0" indent="0" algn="l">
               <a:buNone/>
             </a:pPr>
             <a:r>
@@ -9428,7 +9209,7 @@
       </p:sp>
       <p:graphicFrame>
         <p:nvGraphicFramePr>
-          <p:cNvPr id="3" name="Chart 0" descr=""/>
+          <p:cNvPr id="3" name="Chart 0"/>
           <p:cNvGraphicFramePr/>
           <p:nvPr/>
         </p:nvGraphicFramePr>
@@ -9436,9 +9217,9 @@
           <a:off x="548640" y="1280160"/>
           <a:ext cx="6766560" cy="4846320"/>
         </p:xfrm>
-        <a:graphic xmlns:a="http://schemas.openxmlformats.org/drawingml/2006/main">
+        <a:graphic>
           <a:graphicData uri="http://schemas.openxmlformats.org/drawingml/2006/chart">
-            <c:chart xmlns:c="http://schemas.openxmlformats.org/drawingml/2006/chart" r:id="rId1"/>
+            <c:chart xmlns:c="http://schemas.openxmlformats.org/drawingml/2006/chart" xmlns:r="http://schemas.openxmlformats.org/officeDocument/2006/relationships" r:id="rId3"/>
           </a:graphicData>
         </a:graphic>
       </p:graphicFrame>
@@ -9538,7 +9319,7 @@
           </a:prstGeom>
           <a:extLst>
             <a:ext uri="{C572A759-6A51-4108-AA02-DFA0A04FC94B}">
-              <ma14:wrappingTextBoxFlag xmlns:ma14="http://schemas.microsoft.com/office/mac/drawingml/2011/main" val="0"/>
+              <ma14:wrappingTextBoxFlag xmlns:ma14="http://schemas.microsoft.com/office/mac/drawingml/2011/main" xmlns="" val="0"/>
             </a:ext>
           </a:extLst>
         </p:spPr>
@@ -9556,7 +9337,7 @@
           <a:p>
             <a:pPr algn="r"/>
             <a:fld id="{F7021451-1387-4CA6-816F-3879F97B5CBC}" type="slidenum">
-              <a:rPr b="0" lang="en-US"/>
+              <a:rPr lang="en-US" b="0"/>
               <a:t>9</a:t>
             </a:fld>
             <a:endParaRPr lang="en-US"/>
@@ -9864,4 +9645,299 @@
     </a:ext>
   </a:extLst>
 </a:theme>
+</file>
+
+<file path=ppt/theme/theme2.xml><?xml version="1.0" encoding="utf-8"?>
+<a:theme xmlns:a="http://schemas.openxmlformats.org/drawingml/2006/main" name="Office Theme">
+  <a:themeElements>
+    <a:clrScheme name="Office">
+      <a:dk1>
+        <a:sysClr val="windowText" lastClr="000000"/>
+      </a:dk1>
+      <a:lt1>
+        <a:sysClr val="window" lastClr="FFFFFF"/>
+      </a:lt1>
+      <a:dk2>
+        <a:srgbClr val="44546A"/>
+      </a:dk2>
+      <a:lt2>
+        <a:srgbClr val="E7E6E6"/>
+      </a:lt2>
+      <a:accent1>
+        <a:srgbClr val="4472C4"/>
+      </a:accent1>
+      <a:accent2>
+        <a:srgbClr val="ED7D31"/>
+      </a:accent2>
+      <a:accent3>
+        <a:srgbClr val="A5A5A5"/>
+      </a:accent3>
+      <a:accent4>
+        <a:srgbClr val="FFC000"/>
+      </a:accent4>
+      <a:accent5>
+        <a:srgbClr val="5B9BD5"/>
+      </a:accent5>
+      <a:accent6>
+        <a:srgbClr val="70AD47"/>
+      </a:accent6>
+      <a:hlink>
+        <a:srgbClr val="0563C1"/>
+      </a:hlink>
+      <a:folHlink>
+        <a:srgbClr val="954F72"/>
+      </a:folHlink>
+    </a:clrScheme>
+    <a:fontScheme name="Office">
+      <a:majorFont>
+        <a:latin typeface="Calibri Light" panose="020F0302020204030204"/>
+        <a:ea typeface=""/>
+        <a:cs typeface=""/>
+        <a:font script="Jpan" typeface="游ゴシック Light"/>
+        <a:font script="Hang" typeface="맑은 고딕"/>
+        <a:font script="Hans" typeface="等线 Light"/>
+        <a:font script="Hant" typeface="新細明體"/>
+        <a:font script="Arab" typeface="Times New Roman"/>
+        <a:font script="Hebr" typeface="Times New Roman"/>
+        <a:font script="Thai" typeface="Angsana New"/>
+        <a:font script="Ethi" typeface="Nyala"/>
+        <a:font script="Beng" typeface="Vrinda"/>
+        <a:font script="Gujr" typeface="Shruti"/>
+        <a:font script="Khmr" typeface="MoolBoran"/>
+        <a:font script="Knda" typeface="Tunga"/>
+        <a:font script="Guru" typeface="Raavi"/>
+        <a:font script="Cans" typeface="Euphemia"/>
+        <a:font script="Cher" typeface="Plantagenet Cherokee"/>
+        <a:font script="Yiii" typeface="Microsoft Yi Baiti"/>
+        <a:font script="Tibt" typeface="Microsoft Himalaya"/>
+        <a:font script="Thaa" typeface="MV Boli"/>
+        <a:font script="Deva" typeface="Mangal"/>
+        <a:font script="Telu" typeface="Gautami"/>
+        <a:font script="Taml" typeface="Latha"/>
+        <a:font script="Syrc" typeface="Estrangelo Edessa"/>
+        <a:font script="Orya" typeface="Kalinga"/>
+        <a:font script="Mlym" typeface="Kartika"/>
+        <a:font script="Laoo" typeface="DokChampa"/>
+        <a:font script="Sinh" typeface="Iskoola Pota"/>
+        <a:font script="Mong" typeface="Mongolian Baiti"/>
+        <a:font script="Viet" typeface="Times New Roman"/>
+        <a:font script="Uigh" typeface="Microsoft Uighur"/>
+        <a:font script="Geor" typeface="Sylfaen"/>
+        <a:font script="Armn" typeface="Arial"/>
+        <a:font script="Bugi" typeface="Leelawadee UI"/>
+        <a:font script="Bopo" typeface="Microsoft JhengHei"/>
+        <a:font script="Java" typeface="Javanese Text"/>
+        <a:font script="Lisu" typeface="Segoe UI"/>
+        <a:font script="Mymr" typeface="Myanmar Text"/>
+        <a:font script="Nkoo" typeface="Ebrima"/>
+        <a:font script="Olck" typeface="Nirmala UI"/>
+        <a:font script="Osma" typeface="Ebrima"/>
+        <a:font script="Phag" typeface="Phagspa"/>
+        <a:font script="Syrn" typeface="Estrangelo Edessa"/>
+        <a:font script="Syrj" typeface="Estrangelo Edessa"/>
+        <a:font script="Syre" typeface="Estrangelo Edessa"/>
+        <a:font script="Sora" typeface="Nirmala UI"/>
+        <a:font script="Tale" typeface="Microsoft Tai Le"/>
+        <a:font script="Talu" typeface="Microsoft New Tai Lue"/>
+        <a:font script="Tfng" typeface="Ebrima"/>
+      </a:majorFont>
+      <a:minorFont>
+        <a:latin typeface="Calibri" panose="020F0502020204030204"/>
+        <a:ea typeface=""/>
+        <a:cs typeface=""/>
+        <a:font script="Jpan" typeface="游ゴシック"/>
+        <a:font script="Hang" typeface="맑은 고딕"/>
+        <a:font script="Hans" typeface="等线"/>
+        <a:font script="Hant" typeface="新細明體"/>
+        <a:font script="Arab" typeface="Arial"/>
+        <a:font script="Hebr" typeface="Arial"/>
+        <a:font script="Thai" typeface="Cordia New"/>
+        <a:font script="Ethi" typeface="Nyala"/>
+        <a:font script="Beng" typeface="Vrinda"/>
+        <a:font script="Gujr" typeface="Shruti"/>
+        <a:font script="Khmr" typeface="DaunPenh"/>
+        <a:font script="Knda" typeface="Tunga"/>
+        <a:font script="Guru" typeface="Raavi"/>
+        <a:font script="Cans" typeface="Euphemia"/>
+        <a:font script="Cher" typeface="Plantagenet Cherokee"/>
+        <a:font script="Yiii" typeface="Microsoft Yi Baiti"/>
+        <a:font script="Tibt" typeface="Microsoft Himalaya"/>
+        <a:font script="Thaa" typeface="MV Boli"/>
+        <a:font script="Deva" typeface="Mangal"/>
+        <a:font script="Telu" typeface="Gautami"/>
+        <a:font script="Taml" typeface="Latha"/>
+        <a:font script="Syrc" typeface="Estrangelo Edessa"/>
+        <a:font script="Orya" typeface="Kalinga"/>
+        <a:font script="Mlym" typeface="Kartika"/>
+        <a:font script="Laoo" typeface="DokChampa"/>
+        <a:font script="Sinh" typeface="Iskoola Pota"/>
+        <a:font script="Mong" typeface="Mongolian Baiti"/>
+        <a:font script="Viet" typeface="Arial"/>
+        <a:font script="Uigh" typeface="Microsoft Uighur"/>
+        <a:font script="Geor" typeface="Sylfaen"/>
+        <a:font script="Armn" typeface="Arial"/>
+        <a:font script="Bugi" typeface="Leelawadee UI"/>
+        <a:font script="Bopo" typeface="Microsoft JhengHei"/>
+        <a:font script="Java" typeface="Javanese Text"/>
+        <a:font script="Lisu" typeface="Segoe UI"/>
+        <a:font script="Mymr" typeface="Myanmar Text"/>
+        <a:font script="Nkoo" typeface="Ebrima"/>
+        <a:font script="Olck" typeface="Nirmala UI"/>
+        <a:font script="Osma" typeface="Ebrima"/>
+        <a:font script="Phag" typeface="Phagspa"/>
+        <a:font script="Syrn" typeface="Estrangelo Edessa"/>
+        <a:font script="Syrj" typeface="Estrangelo Edessa"/>
+        <a:font script="Syre" typeface="Estrangelo Edessa"/>
+        <a:font script="Sora" typeface="Nirmala UI"/>
+        <a:font script="Tale" typeface="Microsoft Tai Le"/>
+        <a:font script="Talu" typeface="Microsoft New Tai Lue"/>
+        <a:font script="Tfng" typeface="Ebrima"/>
+      </a:minorFont>
+    </a:fontScheme>
+    <a:fmtScheme name="Office">
+      <a:fillStyleLst>
+        <a:solidFill>
+          <a:schemeClr val="phClr"/>
+        </a:solidFill>
+        <a:gradFill rotWithShape="1">
+          <a:gsLst>
+            <a:gs pos="0">
+              <a:schemeClr val="phClr">
+                <a:lumMod val="110000"/>
+                <a:satMod val="105000"/>
+                <a:tint val="67000"/>
+              </a:schemeClr>
+            </a:gs>
+            <a:gs pos="50000">
+              <a:schemeClr val="phClr">
+                <a:lumMod val="105000"/>
+                <a:satMod val="103000"/>
+                <a:tint val="73000"/>
+              </a:schemeClr>
+            </a:gs>
+            <a:gs pos="100000">
+              <a:schemeClr val="phClr">
+                <a:lumMod val="105000"/>
+                <a:satMod val="109000"/>
+                <a:tint val="81000"/>
+              </a:schemeClr>
+            </a:gs>
+          </a:gsLst>
+          <a:lin ang="5400000" scaled="0"/>
+        </a:gradFill>
+        <a:gradFill rotWithShape="1">
+          <a:gsLst>
+            <a:gs pos="0">
+              <a:schemeClr val="phClr">
+                <a:satMod val="103000"/>
+                <a:lumMod val="102000"/>
+                <a:tint val="94000"/>
+              </a:schemeClr>
+            </a:gs>
+            <a:gs pos="50000">
+              <a:schemeClr val="phClr">
+                <a:satMod val="110000"/>
+                <a:lumMod val="100000"/>
+                <a:shade val="100000"/>
+              </a:schemeClr>
+            </a:gs>
+            <a:gs pos="100000">
+              <a:schemeClr val="phClr">
+                <a:lumMod val="99000"/>
+                <a:satMod val="120000"/>
+                <a:shade val="78000"/>
+              </a:schemeClr>
+            </a:gs>
+          </a:gsLst>
+          <a:lin ang="5400000" scaled="0"/>
+        </a:gradFill>
+      </a:fillStyleLst>
+      <a:lnStyleLst>
+        <a:ln w="6350" cap="flat" cmpd="sng" algn="ctr">
+          <a:solidFill>
+            <a:schemeClr val="phClr"/>
+          </a:solidFill>
+          <a:prstDash val="solid"/>
+          <a:miter lim="800000"/>
+        </a:ln>
+        <a:ln w="12700" cap="flat" cmpd="sng" algn="ctr">
+          <a:solidFill>
+            <a:schemeClr val="phClr"/>
+          </a:solidFill>
+          <a:prstDash val="solid"/>
+          <a:miter lim="800000"/>
+        </a:ln>
+        <a:ln w="19050" cap="flat" cmpd="sng" algn="ctr">
+          <a:solidFill>
+            <a:schemeClr val="phClr"/>
+          </a:solidFill>
+          <a:prstDash val="solid"/>
+          <a:miter lim="800000"/>
+        </a:ln>
+      </a:lnStyleLst>
+      <a:effectStyleLst>
+        <a:effectStyle>
+          <a:effectLst/>
+        </a:effectStyle>
+        <a:effectStyle>
+          <a:effectLst/>
+        </a:effectStyle>
+        <a:effectStyle>
+          <a:effectLst>
+            <a:outerShdw blurRad="57150" dist="19050" dir="5400000" algn="ctr" rotWithShape="0">
+              <a:srgbClr val="000000">
+                <a:alpha val="63000"/>
+              </a:srgbClr>
+            </a:outerShdw>
+          </a:effectLst>
+        </a:effectStyle>
+      </a:effectStyleLst>
+      <a:bgFillStyleLst>
+        <a:solidFill>
+          <a:schemeClr val="phClr"/>
+        </a:solidFill>
+        <a:solidFill>
+          <a:schemeClr val="phClr">
+            <a:tint val="95000"/>
+            <a:satMod val="170000"/>
+          </a:schemeClr>
+        </a:solidFill>
+        <a:gradFill rotWithShape="1">
+          <a:gsLst>
+            <a:gs pos="0">
+              <a:schemeClr val="phClr">
+                <a:tint val="93000"/>
+                <a:satMod val="150000"/>
+                <a:shade val="98000"/>
+                <a:lumMod val="102000"/>
+              </a:schemeClr>
+            </a:gs>
+            <a:gs pos="50000">
+              <a:schemeClr val="phClr">
+                <a:tint val="98000"/>
+                <a:satMod val="130000"/>
+                <a:shade val="90000"/>
+                <a:lumMod val="103000"/>
+              </a:schemeClr>
+            </a:gs>
+            <a:gs pos="100000">
+              <a:schemeClr val="phClr">
+                <a:shade val="63000"/>
+                <a:satMod val="120000"/>
+              </a:schemeClr>
+            </a:gs>
+          </a:gsLst>
+          <a:lin ang="5400000" scaled="0"/>
+        </a:gradFill>
+      </a:bgFillStyleLst>
+    </a:fmtScheme>
+  </a:themeElements>
+  <a:objectDefaults/>
+  <a:extraClrSchemeLst/>
+  <a:extLst>
+    <a:ext uri="{05A4C25C-085E-4340-85A3-A5531E510DB2}">
+      <thm15:themeFamily xmlns:thm15="http://schemas.microsoft.com/office/thememl/2012/main" name="Office Theme" id="{62F939B6-93AF-4DB8-9C6B-D6C7DFDC589F}" vid="{4A3C46E8-61CC-4603-A589-7422A47A8E4A}"/>
+    </a:ext>
+  </a:extLst>
+</a:theme>
 </file>
</xml_diff>

<commit_message>
docs: replace not-run statements with the live advisor result and its caveats
</commit_message>
<xml_diff>
--- a/presentation/KGCR_Review2.pptx
+++ b/presentation/KGCR_Review2.pptx
@@ -4,9 +4,6 @@
   <p:sldMasterIdLst>
     <p:sldMasterId id="2147483648" r:id="rId1"/>
   </p:sldMasterIdLst>
-  <p:notesMasterIdLst>
-    <p:notesMasterId r:id="rId16"/>
-  </p:notesMasterIdLst>
   <p:sldIdLst>
     <p:sldId id="256" r:id="rId2"/>
     <p:sldId id="257" r:id="rId3"/>
@@ -23,6 +20,9 @@
     <p:sldId id="268" r:id="rId14"/>
     <p:sldId id="269" r:id="rId15"/>
   </p:sldIdLst>
+  <p:notesMasterIdLst>
+    <p:notesMasterId r:id="rId16"/>
+  </p:notesMasterIdLst>
   <p:sldSz cx="12192000" cy="6858000"/>
   <p:notesSz cx="6858000" cy="12192000"/>
   <p:defaultTextStyle>
@@ -120,39 +120,39 @@
   <p:extLst>
     <p:ext uri="{521415D9-36F7-43E2-AB2F-B90AF26B5E84}">
       <p14:sectionLst xmlns:p14="http://schemas.microsoft.com/office/powerpoint/2010/main">
-        <p14:section name="Opening" id="{ED87F44C-174F-8838-D3F8-034AE25B33E9}">
+        <p14:section name="Opening" id="{2781c3d0-6951-522c-ed99-279716750f7d}">
           <p14:sldIdLst>
             <p14:sldId id="256"/>
           </p14:sldIdLst>
         </p14:section>
-        <p14:section name="Problem and gap" id="{CD5C4CEB-3C31-96E3-9A89-B5B0489C8AA1}">
+        <p14:section name="Problem and gap" id="{3c89eebe-6c82-2c84-ce0d-bdf3007141e7}">
           <p14:sldIdLst>
             <p14:sldId id="257"/>
             <p14:sldId id="258"/>
           </p14:sldIdLst>
         </p14:section>
-        <p14:section name="Plan" id="{AB42D79F-EF11-8A18-7C2F-AFAF637B0C21}">
+        <p14:section name="Plan" id="{671fd6d1-a15b-32c5-515b-5606fbebdf97}">
           <p14:sldIdLst>
             <p14:sldId id="259"/>
           </p14:sldIdLst>
         </p14:section>
-        <p14:section name="Architecture" id="{5203A884-B850-D873-CB43-E7D64DFDD3CF}">
+        <p14:section name="Architecture" id="{327fa09b-911e-32a7-bc14-747575c0157e}">
           <p14:sldIdLst>
             <p14:sldId id="260"/>
             <p14:sldId id="261"/>
           </p14:sldIdLst>
         </p14:section>
-        <p14:section name="Data" id="{5EE50052-ED14-BA94-5AAF-AA6AF7B700E9}">
+        <p14:section name="Data" id="{dcb9a35d-be5c-2ba2-562a-a14ed7d13d88}">
           <p14:sldIdLst>
             <p14:sldId id="262"/>
           </p14:sldIdLst>
         </p14:section>
-        <p14:section name="Implementation" id="{EEF610E6-2C66-0FB8-9091-B161156ECA0A}">
+        <p14:section name="Implementation" id="{cb73f849-efb2-a9a8-91cb-f8dfd5dbaeb7}">
           <p14:sldIdLst>
             <p14:sldId id="263"/>
           </p14:sldIdLst>
         </p14:section>
-        <p14:section name="Results" id="{9ACAE94E-ACEA-EB13-0835-0D85ADCE1A38}">
+        <p14:section name="Results" id="{e8bd40bf-5b6c-bdde-8a5c-0af2dab7db69}">
           <p14:sldIdLst>
             <p14:sldId id="264"/>
             <p14:sldId id="265"/>
@@ -160,12 +160,12 @@
             <p14:sldId id="267"/>
           </p14:sldIdLst>
         </p14:section>
-        <p14:section name="Cloud" id="{0B1BBB07-C57D-FE19-2D95-0E8805ABD743}">
+        <p14:section name="Cloud" id="{7152606d-ed40-3636-4775-40b724d8e4db}">
           <p14:sldIdLst>
             <p14:sldId id="268"/>
           </p14:sldIdLst>
         </p14:section>
-        <p14:section name="Close" id="{47310F79-8226-BC47-0AF5-B1F863AEEE5B}">
+        <p14:section name="Close" id="{acf5dcde-741d-8bd0-9d14-9ce6e1d3279d}">
           <p14:sldIdLst>
             <p14:sldId id="269"/>
           </p14:sldIdLst>
@@ -180,11 +180,9 @@
 </file>
 
 <file path=ppt/charts/chart1.xml><?xml version="1.0" encoding="utf-8"?>
-<c:chartSpace xmlns:c="http://schemas.openxmlformats.org/drawingml/2006/chart" xmlns:a="http://schemas.openxmlformats.org/drawingml/2006/main" xmlns:r="http://schemas.openxmlformats.org/officeDocument/2006/relationships" xmlns:c16r2="http://schemas.microsoft.com/office/drawing/2015/06/chart">
+<c:chartSpace xmlns:c="http://schemas.openxmlformats.org/drawingml/2006/chart" xmlns:a="http://schemas.openxmlformats.org/drawingml/2006/main" xmlns:r="http://schemas.openxmlformats.org/officeDocument/2006/relationships">
   <c:date1904 val="0"/>
-  <c:lang val="en-US"/>
   <c:roundedCorners val="1"/>
-  <c:style val="2"/>
   <c:chart>
     <c:title>
       <c:tx>
@@ -212,6 +210,7 @@
           </a:p>
         </c:rich>
       </c:tx>
+      <c:layout/>
       <c:overlay val="0"/>
     </c:title>
     <c:autoTitleDeleted val="0"/>
@@ -244,26 +243,18 @@
           <c:invertIfNegative val="0"/>
           <c:dLbls>
             <c:numFmt formatCode="0.000" sourceLinked="0"/>
-            <c:spPr>
-              <a:noFill/>
-              <a:ln>
-                <a:noFill/>
-              </a:ln>
-              <a:effectLst/>
-            </c:spPr>
             <c:txPr>
               <a:bodyPr/>
               <a:lstStyle/>
               <a:p>
                 <a:pPr>
-                  <a:defRPr sz="1200" b="0" i="0" u="none" strike="noStrike">
+                  <a:defRPr b="0" i="0" strike="noStrike" sz="1200" u="none">
                     <a:solidFill>
                       <a:srgbClr val="1B2A2F"/>
                     </a:solidFill>
                     <a:latin typeface="+mn-lt"/>
                   </a:defRPr>
                 </a:pPr>
-                <a:endParaRPr lang="en-US"/>
               </a:p>
             </c:txPr>
             <c:showLegendKey val="0"/>
@@ -273,31 +264,28 @@
             <c:showPercent val="0"/>
             <c:showBubbleSize val="0"/>
             <c:showLeaderLines val="0"/>
-            <c:extLst>
-              <c:ext xmlns:c15="http://schemas.microsoft.com/office/drawing/2012/chart" uri="{CE6537A1-D6FC-4f65-9D91-7224C49458BB}">
-                <c15:showLeaderLines val="0"/>
-              </c:ext>
-            </c:extLst>
           </c:dLbls>
           <c:cat>
-            <c:strRef>
+            <c:multiLvlStrRef>
               <c:f>Sheet1!$A$2:$A$5</c:f>
-              <c:strCache>
+              <c:multiLvlStrCache>
                 <c:ptCount val="4"/>
-                <c:pt idx="0">
-                  <c:v>Popularity</c:v>
-                </c:pt>
-                <c:pt idx="1">
-                  <c:v>Per-archetype</c:v>
-                </c:pt>
-                <c:pt idx="2">
-                  <c:v>Model, true intent</c:v>
-                </c:pt>
-                <c:pt idx="3">
-                  <c:v>Model, reconstructed intent</c:v>
-                </c:pt>
-              </c:strCache>
-            </c:strRef>
+                <c:lvl>
+                  <c:pt idx="0">
+                    <c:v>Popularity</c:v>
+                  </c:pt>
+                  <c:pt idx="1">
+                    <c:v>Per-archetype</c:v>
+                  </c:pt>
+                  <c:pt idx="2">
+                    <c:v>Model, true intent</c:v>
+                  </c:pt>
+                  <c:pt idx="3">
+                    <c:v>Model, reconstructed intent</c:v>
+                  </c:pt>
+                </c:lvl>
+              </c:multiLvlStrCache>
+            </c:multiLvlStrRef>
           </c:cat>
           <c:val>
             <c:numRef>
@@ -309,34 +297,47 @@
                   <c:v>0</c:v>
                 </c:pt>
                 <c:pt idx="1">
-                  <c:v>0.20830000000000001</c:v>
+                  <c:v>0.2083</c:v>
                 </c:pt>
                 <c:pt idx="2">
-                  <c:v>0.95830000000000004</c:v>
+                  <c:v>0.9583</c:v>
                 </c:pt>
                 <c:pt idx="3">
-                  <c:v>0.95830000000000004</c:v>
+                  <c:v>0.9583</c:v>
                 </c:pt>
               </c:numCache>
             </c:numRef>
           </c:val>
-          <c:extLst>
-            <c:ext xmlns:c16="http://schemas.microsoft.com/office/drawing/2014/chart" uri="{C3380CC4-5D6E-409C-BE32-E72D297353CC}">
-              <c16:uniqueId val="{00000000-0F76-40A1-948F-82CFE5C7A957}"/>
-            </c:ext>
-          </c:extLst>
         </c:ser>
         <c:dLbls>
+          <c:numFmt formatCode="0.000" sourceLinked="0"/>
+          <c:txPr>
+            <a:bodyPr/>
+            <a:lstStyle/>
+            <a:p>
+              <a:pPr>
+                <a:defRPr b="0" i="0" strike="noStrike" sz="1200" u="none">
+                  <a:solidFill>
+                    <a:srgbClr val="1B2A2F"/>
+                  </a:solidFill>
+                  <a:latin typeface="+mn-lt"/>
+                </a:defRPr>
+              </a:pPr>
+            </a:p>
+          </c:txPr>
           <c:showLegendKey val="0"/>
           <c:showVal val="1"/>
           <c:showCatName val="0"/>
           <c:showSerName val="0"/>
           <c:showPercent val="0"/>
           <c:showBubbleSize val="0"/>
+          <c:showLeaderLines val="0"/>
         </c:dLbls>
         <c:gapWidth val="150"/>
+        <c:overlap val="0"/>
         <c:axId val="2094734554"/>
         <c:axId val="2094734552"/>
+        <c:axId val="2094734556"/>
       </c:barChart>
       <c:catAx>
         <c:axId val="2094734554"/>
@@ -377,14 +378,13 @@
         <c:crosses val="autoZero"/>
         <c:auto val="1"/>
         <c:lblAlgn val="ctr"/>
-        <c:lblOffset val="100"/>
         <c:noMultiLvlLbl val="1"/>
       </c:catAx>
       <c:valAx>
         <c:axId val="2094734552"/>
         <c:scaling>
           <c:orientation val="minMax"/>
-          <c:max val="1.1499999999999999"/>
+          <c:max val="1.15"/>
           <c:min val="0"/>
         </c:scaling>
         <c:delete val="1"/>
@@ -393,6 +393,30 @@
         <c:majorTickMark val="out"/>
         <c:minorTickMark val="none"/>
         <c:tickLblPos val="low"/>
+        <c:spPr>
+          <a:ln w="12700" cap="flat">
+            <a:solidFill>
+              <a:srgbClr val="888888"/>
+            </a:solidFill>
+            <a:prstDash val="solid"/>
+            <a:round/>
+          </a:ln>
+        </c:spPr>
+        <c:txPr>
+          <a:bodyPr/>
+          <a:lstStyle/>
+          <a:p>
+            <a:pPr>
+              <a:defRPr sz="1100" b="0" i="0" u="none" strike="noStrike">
+                <a:solidFill>
+                  <a:srgbClr val="5B6B70"/>
+                </a:solidFill>
+                <a:latin typeface="+mn-lt"/>
+              </a:defRPr>
+            </a:pPr>
+            <a:endParaRPr lang="en-US"/>
+          </a:p>
+        </c:txPr>
         <c:crossAx val="2094734554"/>
         <c:crosses val="autoZero"/>
         <c:crossBetween val="between"/>
@@ -407,7 +431,6 @@
     </c:plotArea>
     <c:plotVisOnly val="1"/>
     <c:dispBlanksAs val="span"/>
-    <c:showDLblsOverMax val="1"/>
   </c:chart>
   <c:spPr>
     <a:noFill/>
@@ -423,11 +446,9 @@
 </file>
 
 <file path=ppt/charts/chart2.xml><?xml version="1.0" encoding="utf-8"?>
-<c:chartSpace xmlns:c="http://schemas.openxmlformats.org/drawingml/2006/chart" xmlns:a="http://schemas.openxmlformats.org/drawingml/2006/main" xmlns:r="http://schemas.openxmlformats.org/officeDocument/2006/relationships" xmlns:c16r2="http://schemas.microsoft.com/office/drawing/2015/06/chart">
+<c:chartSpace xmlns:c="http://schemas.openxmlformats.org/drawingml/2006/chart" xmlns:a="http://schemas.openxmlformats.org/drawingml/2006/main" xmlns:r="http://schemas.openxmlformats.org/officeDocument/2006/relationships">
   <c:date1904 val="0"/>
-  <c:lang val="en-US"/>
   <c:roundedCorners val="1"/>
-  <c:style val="2"/>
   <c:chart>
     <c:title>
       <c:tx>
@@ -455,6 +476,7 @@
           </a:p>
         </c:rich>
       </c:tx>
+      <c:layout/>
       <c:overlay val="0"/>
     </c:title>
     <c:autoTitleDeleted val="0"/>
@@ -487,26 +509,18 @@
           <c:invertIfNegative val="0"/>
           <c:dLbls>
             <c:numFmt formatCode="0.000" sourceLinked="0"/>
-            <c:spPr>
-              <a:noFill/>
-              <a:ln>
-                <a:noFill/>
-              </a:ln>
-              <a:effectLst/>
-            </c:spPr>
             <c:txPr>
               <a:bodyPr/>
               <a:lstStyle/>
               <a:p>
                 <a:pPr>
-                  <a:defRPr sz="1200" b="0" i="0" u="none" strike="noStrike">
+                  <a:defRPr b="0" i="0" strike="noStrike" sz="1200" u="none">
                     <a:solidFill>
                       <a:srgbClr val="1B2A2F"/>
                     </a:solidFill>
                     <a:latin typeface="+mn-lt"/>
                   </a:defRPr>
                 </a:pPr>
-                <a:endParaRPr lang="en-US"/>
               </a:p>
             </c:txPr>
             <c:showLegendKey val="0"/>
@@ -516,40 +530,37 @@
             <c:showPercent val="0"/>
             <c:showBubbleSize val="0"/>
             <c:showLeaderLines val="0"/>
-            <c:extLst>
-              <c:ext xmlns:c15="http://schemas.microsoft.com/office/drawing/2012/chart" uri="{CE6537A1-D6FC-4f65-9D91-7224C49458BB}">
-                <c15:showLeaderLines val="0"/>
-              </c:ext>
-            </c:extLst>
           </c:dLbls>
           <c:cat>
-            <c:strRef>
+            <c:multiLvlStrRef>
               <c:f>Sheet1!$A$2:$A$8</c:f>
-              <c:strCache>
+              <c:multiLvlStrCache>
                 <c:ptCount val="7"/>
-                <c:pt idx="0">
-                  <c:v>archetype</c:v>
-                </c:pt>
-                <c:pt idx="1">
-                  <c:v>az spread</c:v>
-                </c:pt>
-                <c:pt idx="2">
-                  <c:v>iam shape</c:v>
-                </c:pt>
-                <c:pt idx="3">
-                  <c:v>logging</c:v>
-                </c:pt>
-                <c:pt idx="4">
-                  <c:v>network layout</c:v>
-                </c:pt>
-                <c:pt idx="5">
-                  <c:v>scale</c:v>
-                </c:pt>
-                <c:pt idx="6">
-                  <c:v>tagging</c:v>
-                </c:pt>
-              </c:strCache>
-            </c:strRef>
+                <c:lvl>
+                  <c:pt idx="0">
+                    <c:v>archetype</c:v>
+                  </c:pt>
+                  <c:pt idx="1">
+                    <c:v>az spread</c:v>
+                  </c:pt>
+                  <c:pt idx="2">
+                    <c:v>iam shape</c:v>
+                  </c:pt>
+                  <c:pt idx="3">
+                    <c:v>logging</c:v>
+                  </c:pt>
+                  <c:pt idx="4">
+                    <c:v>network layout</c:v>
+                  </c:pt>
+                  <c:pt idx="5">
+                    <c:v>scale</c:v>
+                  </c:pt>
+                  <c:pt idx="6">
+                    <c:v>tagging</c:v>
+                  </c:pt>
+                </c:lvl>
+              </c:multiLvlStrCache>
+            </c:multiLvlStrRef>
           </c:cat>
           <c:val>
             <c:numRef>
@@ -564,7 +575,7 @@
                   <c:v>1</c:v>
                 </c:pt>
                 <c:pt idx="2">
-                  <c:v>0.41666666666666669</c:v>
+                  <c:v>0.4166666666666667</c:v>
                 </c:pt>
                 <c:pt idx="3">
                   <c:v>1</c:v>
@@ -573,7 +584,7 @@
                   <c:v>1</c:v>
                 </c:pt>
                 <c:pt idx="5">
-                  <c:v>0.83333333333333337</c:v>
+                  <c:v>0.8333333333333334</c:v>
                 </c:pt>
                 <c:pt idx="6">
                   <c:v>0.875</c:v>
@@ -581,23 +592,36 @@
               </c:numCache>
             </c:numRef>
           </c:val>
-          <c:extLst>
-            <c:ext xmlns:c16="http://schemas.microsoft.com/office/drawing/2014/chart" uri="{C3380CC4-5D6E-409C-BE32-E72D297353CC}">
-              <c16:uniqueId val="{00000000-2A28-47BA-B901-3E27F2D20838}"/>
-            </c:ext>
-          </c:extLst>
         </c:ser>
         <c:dLbls>
+          <c:numFmt formatCode="0.000" sourceLinked="0"/>
+          <c:txPr>
+            <a:bodyPr/>
+            <a:lstStyle/>
+            <a:p>
+              <a:pPr>
+                <a:defRPr b="0" i="0" strike="noStrike" sz="1200" u="none">
+                  <a:solidFill>
+                    <a:srgbClr val="1B2A2F"/>
+                  </a:solidFill>
+                  <a:latin typeface="+mn-lt"/>
+                </a:defRPr>
+              </a:pPr>
+            </a:p>
+          </c:txPr>
           <c:showLegendKey val="0"/>
           <c:showVal val="1"/>
           <c:showCatName val="0"/>
           <c:showSerName val="0"/>
           <c:showPercent val="0"/>
           <c:showBubbleSize val="0"/>
+          <c:showLeaderLines val="0"/>
         </c:dLbls>
         <c:gapWidth val="150"/>
+        <c:overlap val="0"/>
         <c:axId val="2094734554"/>
         <c:axId val="2094734552"/>
+        <c:axId val="2094734556"/>
       </c:barChart>
       <c:catAx>
         <c:axId val="2094734554"/>
@@ -638,14 +662,13 @@
         <c:crosses val="autoZero"/>
         <c:auto val="1"/>
         <c:lblAlgn val="ctr"/>
-        <c:lblOffset val="100"/>
         <c:noMultiLvlLbl val="1"/>
       </c:catAx>
       <c:valAx>
         <c:axId val="2094734552"/>
         <c:scaling>
           <c:orientation val="minMax"/>
-          <c:max val="1.1499999999999999"/>
+          <c:max val="1.15"/>
           <c:min val="0"/>
         </c:scaling>
         <c:delete val="1"/>
@@ -654,6 +677,30 @@
         <c:majorTickMark val="out"/>
         <c:minorTickMark val="none"/>
         <c:tickLblPos val="low"/>
+        <c:spPr>
+          <a:ln w="12700" cap="flat">
+            <a:solidFill>
+              <a:srgbClr val="888888"/>
+            </a:solidFill>
+            <a:prstDash val="solid"/>
+            <a:round/>
+          </a:ln>
+        </c:spPr>
+        <c:txPr>
+          <a:bodyPr/>
+          <a:lstStyle/>
+          <a:p>
+            <a:pPr>
+              <a:defRPr sz="1100" b="0" i="0" u="none" strike="noStrike">
+                <a:solidFill>
+                  <a:srgbClr val="5B6B70"/>
+                </a:solidFill>
+                <a:latin typeface="+mn-lt"/>
+              </a:defRPr>
+            </a:pPr>
+            <a:endParaRPr lang="en-US"/>
+          </a:p>
+        </c:txPr>
         <c:crossAx val="2094734554"/>
         <c:crosses val="autoZero"/>
         <c:crossBetween val="between"/>
@@ -668,7 +715,6 @@
     </c:plotArea>
     <c:plotVisOnly val="1"/>
     <c:dispBlanksAs val="span"/>
-    <c:showDLblsOverMax val="1"/>
   </c:chart>
   <c:spPr>
     <a:noFill/>
@@ -705,10 +751,234 @@
           <a:chExt cx="0" cy="0"/>
         </a:xfrm>
       </p:grpSpPr>
+      <p:sp>
+        <p:nvSpPr>
+          <p:cNvPr id="2" name="Header Placeholder 1"/>
+          <p:cNvSpPr>
+            <a:spLocks noGrp="1"/>
+          </p:cNvSpPr>
+          <p:nvPr>
+            <p:ph type="hdr" sz="quarter"/>
+          </p:nvPr>
+        </p:nvSpPr>
+        <p:spPr>
+          <a:xfrm>
+            <a:off x="0" y="0"/>
+            <a:ext cx="2971800" cy="458788"/>
+          </a:xfrm>
+          <a:prstGeom prst="rect">
+            <a:avLst/>
+          </a:prstGeom>
+        </p:spPr>
+        <p:txBody>
+          <a:bodyPr vert="horz" lIns="91440" tIns="45720" rIns="91440" bIns="45720" rtlCol="0"/>
+          <a:lstStyle>
+            <a:lvl1pPr algn="l">
+              <a:defRPr sz="1200"/>
+            </a:lvl1pPr>
+          </a:lstStyle>
+          <a:p>
+            <a:endParaRPr lang="en-US"/>
+          </a:p>
+        </p:txBody>
+      </p:sp>
+      <p:sp>
+        <p:nvSpPr>
+          <p:cNvPr id="3" name="Date Placeholder 2"/>
+          <p:cNvSpPr>
+            <a:spLocks noGrp="1"/>
+          </p:cNvSpPr>
+          <p:nvPr>
+            <p:ph type="dt" idx="1"/>
+          </p:nvPr>
+        </p:nvSpPr>
+        <p:spPr>
+          <a:xfrm>
+            <a:off x="3884613" y="0"/>
+            <a:ext cx="2971800" cy="458788"/>
+          </a:xfrm>
+          <a:prstGeom prst="rect">
+            <a:avLst/>
+          </a:prstGeom>
+        </p:spPr>
+        <p:txBody>
+          <a:bodyPr vert="horz" lIns="91440" tIns="45720" rIns="91440" bIns="45720" rtlCol="0"/>
+          <a:lstStyle>
+            <a:lvl1pPr algn="r">
+              <a:defRPr sz="1200"/>
+            </a:lvl1pPr>
+          </a:lstStyle>
+          <a:p>
+            <a:fld id="{5282F153-3F37-0F45-9E97-73ACFA13230C}" type="datetimeFigureOut">
+              <a:rPr lang="en-US"/>
+              <a:t>7/23/19</a:t>
+            </a:fld>
+            <a:endParaRPr lang="en-US"/>
+          </a:p>
+        </p:txBody>
+      </p:sp>
+      <p:sp>
+        <p:nvSpPr>
+          <p:cNvPr id="4" name="Slide Image Placeholder 3"/>
+          <p:cNvSpPr>
+            <a:spLocks noGrp="1" noRot="1" noChangeAspect="1"/>
+          </p:cNvSpPr>
+          <p:nvPr>
+            <p:ph type="sldImg" idx="2"/>
+          </p:nvPr>
+        </p:nvSpPr>
+        <p:spPr>
+          <a:xfrm>
+            <a:off x="685800" y="1143000"/>
+            <a:ext cx="5486400" cy="3086100"/>
+          </a:xfrm>
+          <a:prstGeom prst="rect">
+            <a:avLst/>
+          </a:prstGeom>
+          <a:noFill/>
+          <a:ln w="12700">
+            <a:solidFill>
+              <a:prstClr val="black"/>
+            </a:solidFill>
+          </a:ln>
+        </p:spPr>
+        <p:txBody>
+          <a:bodyPr vert="horz" lIns="91440" tIns="45720" rIns="91440" bIns="45720" rtlCol="0" anchor="ctr"/>
+          <a:lstStyle/>
+          <a:p>
+            <a:endParaRPr lang="en-US"/>
+          </a:p>
+        </p:txBody>
+      </p:sp>
+      <p:sp>
+        <p:nvSpPr>
+          <p:cNvPr id="5" name="Notes Placeholder 4"/>
+          <p:cNvSpPr>
+            <a:spLocks noGrp="1"/>
+          </p:cNvSpPr>
+          <p:nvPr>
+            <p:ph type="body" sz="quarter" idx="3"/>
+          </p:nvPr>
+        </p:nvSpPr>
+        <p:spPr>
+          <a:xfrm>
+            <a:off x="685800" y="4400550"/>
+            <a:ext cx="5486400" cy="3600450"/>
+          </a:xfrm>
+          <a:prstGeom prst="rect">
+            <a:avLst/>
+          </a:prstGeom>
+        </p:spPr>
+        <p:txBody>
+          <a:bodyPr vert="horz" lIns="91440" tIns="45720" rIns="91440" bIns="45720" rtlCol="0"/>
+          <a:lstStyle/>
+          <a:p>
+            <a:pPr lvl="0"/>
+            <a:r>
+              <a:rPr lang="en-US"/>
+              <a:t>Click to edit Master text styles</a:t>
+            </a:r>
+          </a:p>
+          <a:p>
+            <a:pPr lvl="1"/>
+            <a:r>
+              <a:rPr lang="en-US"/>
+              <a:t>Second level</a:t>
+            </a:r>
+          </a:p>
+          <a:p>
+            <a:pPr lvl="2"/>
+            <a:r>
+              <a:rPr lang="en-US"/>
+              <a:t>Third level</a:t>
+            </a:r>
+          </a:p>
+          <a:p>
+            <a:pPr lvl="3"/>
+            <a:r>
+              <a:rPr lang="en-US"/>
+              <a:t>Fourth level</a:t>
+            </a:r>
+          </a:p>
+          <a:p>
+            <a:pPr lvl="4"/>
+            <a:r>
+              <a:rPr lang="en-US"/>
+              <a:t>Fifth level</a:t>
+            </a:r>
+          </a:p>
+        </p:txBody>
+      </p:sp>
+      <p:sp>
+        <p:nvSpPr>
+          <p:cNvPr id="6" name="Footer Placeholder 5"/>
+          <p:cNvSpPr>
+            <a:spLocks noGrp="1"/>
+          </p:cNvSpPr>
+          <p:nvPr>
+            <p:ph type="ftr" sz="quarter" idx="4"/>
+          </p:nvPr>
+        </p:nvSpPr>
+        <p:spPr>
+          <a:xfrm>
+            <a:off x="0" y="8685213"/>
+            <a:ext cx="2971800" cy="458787"/>
+          </a:xfrm>
+          <a:prstGeom prst="rect">
+            <a:avLst/>
+          </a:prstGeom>
+        </p:spPr>
+        <p:txBody>
+          <a:bodyPr vert="horz" lIns="91440" tIns="45720" rIns="91440" bIns="45720" rtlCol="0" anchor="b"/>
+          <a:lstStyle>
+            <a:lvl1pPr algn="l">
+              <a:defRPr sz="1200"/>
+            </a:lvl1pPr>
+          </a:lstStyle>
+          <a:p>
+            <a:endParaRPr lang="en-US"/>
+          </a:p>
+        </p:txBody>
+      </p:sp>
+      <p:sp>
+        <p:nvSpPr>
+          <p:cNvPr id="7" name="Slide Number Placeholder 6"/>
+          <p:cNvSpPr>
+            <a:spLocks noGrp="1"/>
+          </p:cNvSpPr>
+          <p:nvPr>
+            <p:ph type="sldNum" sz="quarter" idx="5"/>
+          </p:nvPr>
+        </p:nvSpPr>
+        <p:spPr>
+          <a:xfrm>
+            <a:off x="3884613" y="8685213"/>
+            <a:ext cx="2971800" cy="458787"/>
+          </a:xfrm>
+          <a:prstGeom prst="rect">
+            <a:avLst/>
+          </a:prstGeom>
+        </p:spPr>
+        <p:txBody>
+          <a:bodyPr vert="horz" lIns="91440" tIns="45720" rIns="91440" bIns="45720" rtlCol="0" anchor="b"/>
+          <a:lstStyle>
+            <a:lvl1pPr algn="r">
+              <a:defRPr sz="1200"/>
+            </a:lvl1pPr>
+          </a:lstStyle>
+          <a:p>
+            <a:fld id="{CE5E9CC1-C706-0F49-92D6-E571CC5EEA8F}" type="slidenum">
+              <a:rPr lang="en-US"/>
+              <a:t>‹#›</a:t>
+            </a:fld>
+            <a:endParaRPr lang="en-US"/>
+          </a:p>
+        </p:txBody>
+      </p:sp>
     </p:spTree>
     <p:extLst>
       <p:ext uri="{BB962C8B-B14F-4D97-AF65-F5344CB8AC3E}">
-        <p14:creationId xmlns:p14="http://schemas.microsoft.com/office/powerpoint/2010/main" val="565321329"/>
+        <p14:creationId xmlns:p14="http://schemas.microsoft.com/office/powerpoint/2010/main" val="1024086991"/>
       </p:ext>
     </p:extLst>
   </p:cSld>
@@ -856,6 +1126,7 @@
               <a:rPr lang="en-US" dirty="0"/>
               <a:t>Frame: recommend and review AWS configurations against regulatory controls, and justify every finding as a traceable path. This review is about implementation progress since Phase-I; every number on the following slides comes from a committed results file.</a:t>
             </a:r>
+            <a:endParaRPr lang="en-US" dirty="0"/>
           </a:p>
         </p:txBody>
       </p:sp>
@@ -943,6 +1214,7 @@
               <a:rPr lang="en-US" dirty="0"/>
               <a:t>Sources: results/p4_df7_checkov_evidence.json (graph versus Checkov) and results/advisor_report.json (rule floor). DF-1 to DF-4 recall is 1.0 by construction because the injectors produce exactly what the rules check; it is a sanity floor, not a benchmark.</a:t>
             </a:r>
+            <a:endParaRPr lang="en-US" dirty="0"/>
           </a:p>
         </p:txBody>
       </p:sp>
@@ -1030,6 +1302,7 @@
               <a:rPr lang="en-US" dirty="0"/>
               <a:t>Sources: results/reconstruction_report.json; INV-2 is tests/explainer/test_explainer.py, which extracts claims back out of the rendered text. Cost deltas in explanations are stated as not modelled.</a:t>
             </a:r>
+            <a:endParaRPr lang="en-US" dirty="0"/>
           </a:p>
         </p:txBody>
       </p:sp>
@@ -1117,6 +1390,7 @@
               <a:rPr lang="en-US" dirty="0"/>
               <a:t>Live command: kgcr review --variant unencrypted_database --audience auditor. Output trimmed for the slide; run it live if time allows (about 15 seconds). PCI-DSS v4.0 3.5.1 covers stored PAN; 3.4 is display masking.</a:t>
             </a:r>
+            <a:endParaRPr lang="en-US" dirty="0"/>
           </a:p>
         </p:txBody>
       </p:sp>
@@ -1204,6 +1478,7 @@
               <a:rPr lang="en-US" dirty="0"/>
               <a:t>Source: docs/Project_Report.md section 8, the 21-service planning table. Nothing has been deployed and no AWS money has been spent. The pipeline talks to storage and notification only through two small interfaces, so AWS-backed versions slot in without changing it.</a:t>
             </a:r>
+            <a:endParaRPr lang="en-US" dirty="0"/>
           </a:p>
         </p:txBody>
       </p:sp>
@@ -1291,6 +1566,7 @@
               <a:rPr lang="en-US" dirty="0"/>
               <a:t>Close on the honest split. Code in this repository is authored by Udit with Claude's assistance; Manya and Tanmoy own their literature and research-gap sections.</a:t>
             </a:r>
+            <a:endParaRPr lang="en-US" dirty="0"/>
           </a:p>
         </p:txBody>
       </p:sp>
@@ -1378,6 +1654,7 @@
               <a:rPr lang="en-US" dirty="0"/>
               <a:t>Source: docs/Project_Report.md section 1 and FD-05 section 5. The right-hand chain is the injected DF-7 'indirect internet reachability' pattern used throughout the results.</a:t>
             </a:r>
+            <a:endParaRPr lang="en-US" dirty="0"/>
           </a:p>
         </p:txBody>
       </p:sp>
@@ -1465,6 +1742,7 @@
               <a:rPr lang="en-US" dirty="0"/>
               <a:t>Source: docs/Literature_Survey.md synthesis, docs/Research_Gap_Udit.md and the two companion gap documents. Each member presents their own five papers.</a:t>
             </a:r>
+            <a:endParaRPr lang="en-US" dirty="0"/>
           </a:p>
         </p:txBody>
       </p:sp>
@@ -1552,6 +1830,7 @@
               <a:rPr lang="en-US" dirty="0"/>
               <a:t>Source: docs/Objectives.md. 'Runs today' means code plus a committed result, on the synthetic corpus. O1 is a draft written by Claude and must be reviewed by Udit before it counts (FD-07 section 2: a model may read L1, never author it).</a:t>
             </a:r>
+            <a:endParaRPr lang="en-US" dirty="0"/>
           </a:p>
         </p:txBody>
       </p:sp>
@@ -1639,6 +1918,7 @@
               <a:rPr lang="en-US" dirty="0"/>
               <a:t>Source: architecture/AWS_Architecture.png, generated by architecture/make_diagrams.py. Say first that this is the planning diagram; slide 13 gives the planned-versus-running split.</a:t>
             </a:r>
+            <a:endParaRPr lang="en-US" dirty="0"/>
           </a:p>
         </p:txBody>
       </p:sp>
@@ -1726,6 +2006,7 @@
               <a:rPr lang="en-US" dirty="0"/>
               <a:t>Source: architecture/System_Architecture.png and FD-01. The plan, confirm and apply steps (S6 to S10) need live accounts and are not built.</a:t>
             </a:r>
+            <a:endParaRPr lang="en-US" dirty="0"/>
           </a:p>
         </p:txBody>
       </p:sp>
@@ -1813,6 +2094,7 @@
               <a:rPr lang="en-US" dirty="0"/>
               <a:t>Source: dataset/dataset_description.md and results/advisor_report.json (DF-7 count over the full injected corpus). Say 'synthetic' before anyone asks.</a:t>
             </a:r>
+            <a:endParaRPr lang="en-US" dirty="0"/>
           </a:p>
         </p:txBody>
       </p:sp>
@@ -1898,8 +2180,9 @@
           <a:p>
             <a:r>
               <a:rPr lang="en-US" dirty="0"/>
-              <a:t>Source: src/backend/kgcr/orchestration/review.py and cli.py. Rule floor only means the advisor ran its deterministic rules; relational and resilience findings need the Gemini path, which has not run live.</a:t>
-            </a:r>
+              <a:t>Source: src/backend/kgcr/orchestration/review.py and cli.py. Rule floor only means the advisor ran its deterministic rules; relational and resilience findings need the Gemini path, which ran live once (recorded in results/llm_fixtures).</a:t>
+            </a:r>
+            <a:endParaRPr lang="en-US" dirty="0"/>
           </a:p>
         </p:txBody>
       </p:sp>
@@ -1987,6 +2270,7 @@
               <a:rPr lang="en-US" dirty="0"/>
               <a:t>Source: results/recommender_report.json. Options are (resource type, attribute, value) with identity attributes excluded. This measures recovery of the generator's mapping, not real-world recommendation quality.</a:t>
             </a:r>
+            <a:endParaRPr lang="en-US" dirty="0"/>
           </a:p>
         </p:txBody>
       </p:sp>
@@ -2064,7 +2348,6 @@
         <a:solidFill>
           <a:schemeClr val="tx2"/>
         </a:solidFill>
-        <a:effectLst/>
       </p:bgPr>
     </p:bg>
     <p:spTree>
@@ -2084,11 +2367,9 @@
       <p:sp>
         <p:nvSpPr>
           <p:cNvPr id="2" name="Text 0"/>
-          <p:cNvSpPr>
-            <a:spLocks noGrp="1"/>
-          </p:cNvSpPr>
+          <p:cNvSpPr/>
           <p:nvPr>
-            <p:ph type="title" idx="100" hasCustomPrompt="1"/>
+            <p:ph idx="100" type="title" hasCustomPrompt="1"/>
           </p:nvPr>
         </p:nvSpPr>
         <p:spPr>
@@ -2105,7 +2386,7 @@
         <p:txBody>
           <a:bodyPr wrap="square" rtlCol="0"/>
           <a:lstStyle>
-            <a:lvl1pPr marL="0" indent="0">
+            <a:lvl1pPr indent="0" marL="0">
               <a:buNone/>
               <a:defRPr lang="en-US" sz="4000" b="1" dirty="0">
                 <a:solidFill>
@@ -2115,7 +2396,7 @@
             </a:lvl1pPr>
           </a:lstStyle>
           <a:p>
-            <a:pPr marL="0" indent="0">
+            <a:pPr indent="0" marL="0">
               <a:buNone/>
             </a:pPr>
             <a:endParaRPr lang="en-US" sz="4000" dirty="0"/>
@@ -2125,11 +2406,9 @@
       <p:sp>
         <p:nvSpPr>
           <p:cNvPr id="3" name="Text 0"/>
-          <p:cNvSpPr>
-            <a:spLocks noGrp="1"/>
-          </p:cNvSpPr>
+          <p:cNvSpPr/>
           <p:nvPr>
-            <p:ph type="body" idx="101" hasCustomPrompt="1"/>
+            <p:ph idx="101" type="body" hasCustomPrompt="1"/>
           </p:nvPr>
         </p:nvSpPr>
         <p:spPr>
@@ -2146,7 +2425,7 @@
         <p:txBody>
           <a:bodyPr wrap="square" rtlCol="0"/>
           <a:lstStyle>
-            <a:lvl1pPr marL="0" indent="0">
+            <a:lvl1pPr indent="0" marL="0">
               <a:buNone/>
               <a:defRPr lang="en-US" sz="1800" dirty="0">
                 <a:solidFill>
@@ -2156,7 +2435,7 @@
             </a:lvl1pPr>
           </a:lstStyle>
           <a:p>
-            <a:pPr marL="0" indent="0">
+            <a:pPr indent="0" marL="0">
               <a:buNone/>
             </a:pPr>
             <a:endParaRPr lang="en-US" sz="1800" dirty="0"/>
@@ -2179,7 +2458,6 @@
         <a:solidFill>
           <a:schemeClr val="bg1"/>
         </a:solidFill>
-        <a:effectLst/>
       </p:bgPr>
     </p:bg>
     <p:spTree>
@@ -2199,11 +2477,9 @@
       <p:sp>
         <p:nvSpPr>
           <p:cNvPr id="2" name="Text 0"/>
-          <p:cNvSpPr>
-            <a:spLocks noGrp="1"/>
-          </p:cNvSpPr>
+          <p:cNvSpPr/>
           <p:nvPr>
-            <p:ph type="title" idx="100" hasCustomPrompt="1"/>
+            <p:ph idx="100" type="title" hasCustomPrompt="1"/>
           </p:nvPr>
         </p:nvSpPr>
         <p:spPr>
@@ -2220,7 +2496,7 @@
         <p:txBody>
           <a:bodyPr wrap="square" rtlCol="0"/>
           <a:lstStyle>
-            <a:lvl1pPr marL="0" indent="0" algn="l">
+            <a:lvl1pPr algn="l" indent="0" marL="0">
               <a:buNone/>
               <a:defRPr lang="en-US" sz="3000" b="1" dirty="0">
                 <a:solidFill>
@@ -2230,7 +2506,7 @@
             </a:lvl1pPr>
           </a:lstStyle>
           <a:p>
-            <a:pPr marL="0" indent="0" algn="l">
+            <a:pPr algn="l" indent="0" marL="0">
               <a:buNone/>
             </a:pPr>
             <a:endParaRPr lang="en-US" sz="3000" dirty="0"/>
@@ -2258,7 +2534,7 @@
           <a:bodyPr wrap="square" rtlCol="0" anchor="ctr"/>
           <a:lstStyle/>
           <a:p>
-            <a:pPr marL="0" indent="0">
+            <a:pPr indent="0" marL="0">
               <a:buNone/>
             </a:pPr>
             <a:r>
@@ -2293,7 +2569,7 @@
           </a:prstGeom>
           <a:extLst>
             <a:ext uri="{C572A759-6A51-4108-AA02-DFA0A04FC94B}">
-              <ma14:wrappingTextBoxFlag xmlns:ma14="http://schemas.microsoft.com/office/mac/drawingml/2011/main" xmlns="" val="0"/>
+              <ma14:wrappingTextBoxFlag xmlns:ma14="http://schemas.microsoft.com/office/mac/drawingml/2011/main" val="0"/>
             </a:ext>
           </a:extLst>
         </p:spPr>
@@ -2311,8 +2587,8 @@
           <a:p>
             <a:pPr algn="r"/>
             <a:fld id="{F7021451-1387-4CA6-816F-3879F97B5CBC}" type="slidenum">
-              <a:rPr lang="en-US" b="0"/>
-              <a:t>‹#›</a:t>
+              <a:rPr b="0" lang="en-US"/>
+              <a:t>1003</a:t>
             </a:fld>
             <a:endParaRPr lang="en-US"/>
           </a:p>
@@ -2329,11 +2605,6 @@
 <file path=ppt/slideMasters/slideMaster1.xml><?xml version="1.0" encoding="utf-8"?>
 <p:sldMaster xmlns:a="http://schemas.openxmlformats.org/drawingml/2006/main" xmlns:r="http://schemas.openxmlformats.org/officeDocument/2006/relationships" xmlns:p="http://schemas.openxmlformats.org/presentationml/2006/main">
   <p:cSld>
-    <p:bg>
-      <p:bgRef idx="1001">
-        <a:schemeClr val="bg1"/>
-      </p:bgRef>
-    </p:bg>
     <p:spTree>
       <p:nvGrpSpPr>
         <p:cNvPr id="1" name=""/>
@@ -2368,7 +2639,7 @@
           </a:prstGeom>
           <a:extLst>
             <a:ext uri="{C572A759-6A51-4108-AA02-DFA0A04FC94B}">
-              <ma14:wrappingTextBoxFlag xmlns:ma14="http://schemas.microsoft.com/office/mac/drawingml/2011/main" xmlns="" val="0"/>
+              <ma14:wrappingTextBoxFlag xmlns:ma14="http://schemas.microsoft.com/office/mac/drawingml/2011/main" val="0"/>
             </a:ext>
           </a:extLst>
         </p:spPr>
@@ -2386,8 +2657,8 @@
           <a:p>
             <a:pPr algn="r"/>
             <a:fld id="{F7021451-1387-4CA6-816F-3879F97B5CBC}" type="slidenum">
-              <a:rPr lang="en-US" b="0"/>
-              <a:t>‹#›</a:t>
+              <a:rPr b="0" lang="en-US"/>
+              <a:t>null</a:t>
             </a:fld>
             <a:endParaRPr lang="en-US"/>
           </a:p>
@@ -2675,11 +2946,9 @@
       <p:sp>
         <p:nvSpPr>
           <p:cNvPr id="2" name="Text 0"/>
-          <p:cNvSpPr>
-            <a:spLocks noGrp="1"/>
-          </p:cNvSpPr>
+          <p:cNvSpPr/>
           <p:nvPr>
-            <p:ph type="title" idx="100" hasCustomPrompt="1"/>
+            <p:ph idx="100" type="title" hasCustomPrompt="1"/>
           </p:nvPr>
         </p:nvSpPr>
         <p:spPr>
@@ -2697,7 +2966,7 @@
           <a:bodyPr wrap="square" rtlCol="0" anchor="b"/>
           <a:lstStyle/>
           <a:p>
-            <a:pPr marL="0" indent="0">
+            <a:pPr indent="0" marL="0">
               <a:buNone/>
             </a:pPr>
             <a:r>
@@ -2715,11 +2984,9 @@
       <p:sp>
         <p:nvSpPr>
           <p:cNvPr id="3" name="Text 0"/>
-          <p:cNvSpPr>
-            <a:spLocks noGrp="1"/>
-          </p:cNvSpPr>
+          <p:cNvSpPr/>
           <p:nvPr>
-            <p:ph type="body" idx="101" hasCustomPrompt="1"/>
+            <p:ph idx="101" type="body" hasCustomPrompt="1"/>
           </p:nvPr>
         </p:nvSpPr>
         <p:spPr>
@@ -2737,7 +3004,7 @@
           <a:bodyPr wrap="square" rtlCol="0" anchor="t"/>
           <a:lstStyle/>
           <a:p>
-            <a:pPr marL="0" indent="0">
+            <a:pPr indent="0" marL="0">
               <a:buNone/>
             </a:pPr>
             <a:r>
@@ -2751,7 +3018,7 @@
             <a:endParaRPr lang="en-US" sz="1800" dirty="0"/>
           </a:p>
           <a:p>
-            <a:pPr marL="0" indent="0">
+            <a:pPr indent="0" marL="0">
               <a:buNone/>
             </a:pPr>
             <a:r>
@@ -2765,36 +3032,16 @@
             <a:endParaRPr lang="en-US" sz="1800" dirty="0"/>
           </a:p>
           <a:p>
-            <a:pPr marL="0" indent="0">
-              <a:buNone/>
-            </a:pPr>
-            <a:r>
-              <a:rPr lang="en-US" sz="1800">
+            <a:pPr indent="0" marL="0">
+              <a:buNone/>
+            </a:pPr>
+            <a:r>
+              <a:rPr lang="en-US" sz="1800" dirty="0">
                 <a:solidFill>
                   <a:schemeClr val="accent6"/>
                 </a:solidFill>
               </a:rPr>
-              <a:t>Udit </a:t>
-            </a:r>
-            <a:r>
-              <a:rPr lang="en-US"/>
-              <a:t>Daftary</a:t>
-            </a:r>
-            <a:r>
-              <a:rPr lang="en-US" sz="1800">
-                <a:solidFill>
-                  <a:schemeClr val="accent6"/>
-                </a:solidFill>
-              </a:rPr>
-              <a:t>, Manya Dev, Tanmoy Paul </a:t>
-            </a:r>
-            <a:r>
-              <a:rPr lang="en-US" sz="1800" dirty="0">
-                <a:solidFill>
-                  <a:schemeClr val="accent6"/>
-                </a:solidFill>
-              </a:rPr>
-              <a:t>|   github.com/uditdaftary/KGCR_Cloud_Project_2026</a:t>
+              <a:t>Udit (lead), Manya, Tanmoy   |   github.com/uditdaftary/KGCR_Cloud_Project_2026</a:t>
             </a:r>
             <a:endParaRPr lang="en-US" sz="1800" dirty="0"/>
           </a:p>
@@ -2828,11 +3075,9 @@
       <p:sp>
         <p:nvSpPr>
           <p:cNvPr id="2" name="Text 0"/>
-          <p:cNvSpPr>
-            <a:spLocks noGrp="1"/>
-          </p:cNvSpPr>
+          <p:cNvSpPr/>
           <p:nvPr>
-            <p:ph type="title" idx="100" hasCustomPrompt="1"/>
+            <p:ph idx="100" type="title" hasCustomPrompt="1"/>
           </p:nvPr>
         </p:nvSpPr>
         <p:spPr>
@@ -2850,7 +3095,7 @@
           <a:bodyPr wrap="square" rtlCol="0" anchor="ctr"/>
           <a:lstStyle/>
           <a:p>
-            <a:pPr marL="0" indent="0" algn="l">
+            <a:pPr algn="l" indent="0" marL="0">
               <a:buNone/>
             </a:pPr>
             <a:r>
@@ -2886,7 +3131,7 @@
           <a:bodyPr wrap="square" lIns="0" tIns="0" rIns="0" bIns="0" rtlCol="0" anchor="ctr"/>
           <a:lstStyle/>
           <a:p>
-            <a:pPr marL="0" indent="0">
+            <a:pPr indent="0" marL="0">
               <a:buNone/>
             </a:pPr>
             <a:r>
@@ -2925,7 +3170,7 @@
           <a:bodyPr wrap="square" lIns="0" tIns="0" rIns="0" bIns="0" rtlCol="0" anchor="t"/>
           <a:lstStyle/>
           <a:p>
-            <a:pPr marL="0" indent="0">
+            <a:pPr indent="0" marL="0">
               <a:buNone/>
             </a:pPr>
             <a:r>
@@ -2961,7 +3206,7 @@
           <a:bodyPr wrap="square" lIns="0" tIns="0" rIns="0" bIns="0" rtlCol="0" anchor="ctr"/>
           <a:lstStyle/>
           <a:p>
-            <a:pPr marL="0" indent="0">
+            <a:pPr indent="0" marL="0">
               <a:buNone/>
             </a:pPr>
             <a:r>
@@ -3000,7 +3245,7 @@
           <a:bodyPr wrap="square" lIns="0" tIns="0" rIns="0" bIns="0" rtlCol="0" anchor="t"/>
           <a:lstStyle/>
           <a:p>
-            <a:pPr marL="0" indent="0">
+            <a:pPr indent="0" marL="0">
               <a:buNone/>
             </a:pPr>
             <a:r>
@@ -3036,7 +3281,7 @@
           <a:bodyPr wrap="square" lIns="0" tIns="0" rIns="0" bIns="0" rtlCol="0" anchor="ctr"/>
           <a:lstStyle/>
           <a:p>
-            <a:pPr marL="0" indent="0">
+            <a:pPr indent="0" marL="0">
               <a:buNone/>
             </a:pPr>
             <a:r>
@@ -3075,7 +3320,7 @@
           <a:bodyPr wrap="square" lIns="0" tIns="0" rIns="0" bIns="0" rtlCol="0" anchor="t"/>
           <a:lstStyle/>
           <a:p>
-            <a:pPr marL="0" indent="0">
+            <a:pPr indent="0" marL="0">
               <a:buNone/>
             </a:pPr>
             <a:r>
@@ -3111,7 +3356,7 @@
           <a:bodyPr wrap="square" lIns="0" tIns="0" rIns="0" bIns="0" rtlCol="0" anchor="ctr"/>
           <a:lstStyle/>
           <a:p>
-            <a:pPr marL="0" indent="0">
+            <a:pPr indent="0" marL="0">
               <a:buNone/>
             </a:pPr>
             <a:r>
@@ -3150,7 +3395,7 @@
           <a:bodyPr wrap="square" lIns="0" tIns="0" rIns="0" bIns="0" rtlCol="0" anchor="t"/>
           <a:lstStyle/>
           <a:p>
-            <a:pPr marL="0" indent="0">
+            <a:pPr indent="0" marL="0">
               <a:buNone/>
             </a:pPr>
             <a:r>
@@ -3192,7 +3437,7 @@
       </p:sp>
       <p:sp>
         <p:nvSpPr>
-          <p:cNvPr id="12" name="chip-notrun"/>
+          <p:cNvPr id="12" name="chip-gatepass"/>
           <p:cNvSpPr txBox="1"/>
           <p:nvPr/>
         </p:nvSpPr>
@@ -3207,7 +3452,7 @@
             </a:avLst>
           </a:prstGeom>
           <a:solidFill>
-            <a:schemeClr val="accent4"/>
+            <a:schemeClr val="accent1"/>
           </a:solidFill>
           <a:ln/>
         </p:spPr>
@@ -3215,7 +3460,7 @@
           <a:bodyPr wrap="square" lIns="0" tIns="0" rIns="0" bIns="0" rtlCol="0" anchor="ctr"/>
           <a:lstStyle/>
           <a:p>
-            <a:pPr marL="0" indent="0" algn="ctr">
+            <a:pPr algn="ctr" indent="0" marL="0">
               <a:buNone/>
             </a:pPr>
             <a:r>
@@ -3224,7 +3469,7 @@
                   <a:schemeClr val="bg1"/>
                 </a:solidFill>
               </a:rPr>
-              <a:t>Not run yet</a:t>
+              <a:t>Gate passed</a:t>
             </a:r>
             <a:endParaRPr lang="en-US" sz="1100" dirty="0"/>
           </a:p>
@@ -3251,7 +3496,7 @@
           <a:bodyPr wrap="square" lIns="0" tIns="0" rIns="0" bIns="0" rtlCol="0" anchor="ctr"/>
           <a:lstStyle/>
           <a:p>
-            <a:pPr marL="0" indent="0">
+            <a:pPr indent="0" marL="0">
               <a:buNone/>
             </a:pPr>
             <a:r>
@@ -3339,7 +3584,7 @@
                   <a:schemeClr val="tx1"/>
                 </a:solidFill>
               </a:rPr>
-              <a:t>The live result needs a Gemini API key; it has not run, and no result is claimed.</a:t>
+              <a:t>Live result: passed on 3 of 4 trials (the rest invalid). Beyond the rule floor it found 2 of 4 variants and raised 1 false CRITICAL on 4 clean estates.</a:t>
             </a:r>
             <a:endParaRPr lang="en-US" sz="1400" dirty="0"/>
           </a:p>
@@ -3365,7 +3610,7 @@
           </a:prstGeom>
           <a:extLst>
             <a:ext uri="{C572A759-6A51-4108-AA02-DFA0A04FC94B}">
-              <ma14:wrappingTextBoxFlag xmlns:ma14="http://schemas.microsoft.com/office/mac/drawingml/2011/main" xmlns="" val="0"/>
+              <ma14:wrappingTextBoxFlag xmlns:ma14="http://schemas.microsoft.com/office/mac/drawingml/2011/main" val="0"/>
             </a:ext>
           </a:extLst>
         </p:spPr>
@@ -3383,7 +3628,7 @@
           <a:p>
             <a:pPr algn="r"/>
             <a:fld id="{F7021451-1387-4CA6-816F-3879F97B5CBC}" type="slidenum">
-              <a:rPr lang="en-US" b="0"/>
+              <a:rPr b="0" lang="en-US"/>
               <a:t>10</a:t>
             </a:fld>
             <a:endParaRPr lang="en-US"/>
@@ -3418,11 +3663,9 @@
       <p:sp>
         <p:nvSpPr>
           <p:cNvPr id="2" name="Text 0"/>
-          <p:cNvSpPr>
-            <a:spLocks noGrp="1"/>
-          </p:cNvSpPr>
+          <p:cNvSpPr/>
           <p:nvPr>
-            <p:ph type="title" idx="100" hasCustomPrompt="1"/>
+            <p:ph idx="100" type="title" hasCustomPrompt="1"/>
           </p:nvPr>
         </p:nvSpPr>
         <p:spPr>
@@ -3440,7 +3683,7 @@
           <a:bodyPr wrap="square" rtlCol="0" anchor="ctr"/>
           <a:lstStyle/>
           <a:p>
-            <a:pPr marL="0" indent="0" algn="l">
+            <a:pPr algn="l" indent="0" marL="0">
               <a:buNone/>
             </a:pPr>
             <a:r>
@@ -3457,7 +3700,7 @@
       </p:sp>
       <p:graphicFrame>
         <p:nvGraphicFramePr>
-          <p:cNvPr id="3" name="Chart 0"/>
+          <p:cNvPr id="3" name="Chart 0" descr=""/>
           <p:cNvGraphicFramePr/>
           <p:nvPr/>
         </p:nvGraphicFramePr>
@@ -3465,9 +3708,9 @@
           <a:off x="548640" y="1280160"/>
           <a:ext cx="6766560" cy="4846320"/>
         </p:xfrm>
-        <a:graphic>
+        <a:graphic xmlns:a="http://schemas.openxmlformats.org/drawingml/2006/main">
           <a:graphicData uri="http://schemas.openxmlformats.org/drawingml/2006/chart">
-            <c:chart xmlns:c="http://schemas.openxmlformats.org/drawingml/2006/chart" xmlns:r="http://schemas.openxmlformats.org/officeDocument/2006/relationships" r:id="rId3"/>
+            <c:chart xmlns:c="http://schemas.openxmlformats.org/drawingml/2006/chart" r:id="rId1"/>
           </a:graphicData>
         </a:graphic>
       </p:graphicFrame>
@@ -3567,7 +3810,7 @@
           </a:prstGeom>
           <a:extLst>
             <a:ext uri="{C572A759-6A51-4108-AA02-DFA0A04FC94B}">
-              <ma14:wrappingTextBoxFlag xmlns:ma14="http://schemas.microsoft.com/office/mac/drawingml/2011/main" xmlns="" val="0"/>
+              <ma14:wrappingTextBoxFlag xmlns:ma14="http://schemas.microsoft.com/office/mac/drawingml/2011/main" val="0"/>
             </a:ext>
           </a:extLst>
         </p:spPr>
@@ -3585,7 +3828,7 @@
           <a:p>
             <a:pPr algn="r"/>
             <a:fld id="{F7021451-1387-4CA6-816F-3879F97B5CBC}" type="slidenum">
-              <a:rPr lang="en-US" b="0"/>
+              <a:rPr b="0" lang="en-US"/>
               <a:t>11</a:t>
             </a:fld>
             <a:endParaRPr lang="en-US"/>
@@ -3620,11 +3863,9 @@
       <p:sp>
         <p:nvSpPr>
           <p:cNvPr id="2" name="Text 0"/>
-          <p:cNvSpPr>
-            <a:spLocks noGrp="1"/>
-          </p:cNvSpPr>
+          <p:cNvSpPr/>
           <p:nvPr>
-            <p:ph type="title" idx="100" hasCustomPrompt="1"/>
+            <p:ph idx="100" type="title" hasCustomPrompt="1"/>
           </p:nvPr>
         </p:nvSpPr>
         <p:spPr>
@@ -3642,7 +3883,7 @@
           <a:bodyPr wrap="square" rtlCol="0" anchor="ctr"/>
           <a:lstStyle/>
           <a:p>
-            <a:pPr marL="0" indent="0" algn="l">
+            <a:pPr algn="l" indent="0" marL="0">
               <a:buNone/>
             </a:pPr>
             <a:r>
@@ -3680,7 +3921,7 @@
           <a:bodyPr wrap="square" lIns="152400" tIns="152400" rIns="152400" bIns="152400" rtlCol="0" anchor="ctr"/>
           <a:lstStyle/>
           <a:p>
-            <a:pPr marL="0" indent="0">
+            <a:pPr indent="0" marL="0">
               <a:buNone/>
             </a:pPr>
             <a:r>
@@ -3697,7 +3938,7 @@
             <a:endParaRPr lang="en-US" sz="1300" dirty="0"/>
           </a:p>
           <a:p>
-            <a:pPr marL="0" indent="0">
+            <a:pPr indent="0" marL="0">
               <a:buNone/>
             </a:pPr>
             <a:r>
@@ -3714,7 +3955,7 @@
             <a:endParaRPr lang="en-US" sz="1300" dirty="0"/>
           </a:p>
           <a:p>
-            <a:pPr marL="0" indent="0">
+            <a:pPr indent="0" marL="0">
               <a:buNone/>
             </a:pPr>
             <a:r>
@@ -3731,7 +3972,7 @@
             <a:endParaRPr lang="en-US" sz="1300" dirty="0"/>
           </a:p>
           <a:p>
-            <a:pPr marL="0" indent="0">
+            <a:pPr indent="0" marL="0">
               <a:buNone/>
             </a:pPr>
             <a:r>
@@ -3748,7 +3989,7 @@
             <a:endParaRPr lang="en-US" sz="1300" dirty="0"/>
           </a:p>
           <a:p>
-            <a:pPr marL="0" indent="0">
+            <a:pPr indent="0" marL="0">
               <a:buNone/>
             </a:pPr>
             <a:r>
@@ -3765,7 +4006,7 @@
             <a:endParaRPr lang="en-US" sz="1300" dirty="0"/>
           </a:p>
           <a:p>
-            <a:pPr marL="0" indent="0">
+            <a:pPr indent="0" marL="0">
               <a:buNone/>
             </a:pPr>
             <a:r>
@@ -3782,7 +4023,7 @@
             <a:endParaRPr lang="en-US" sz="1300" dirty="0"/>
           </a:p>
           <a:p>
-            <a:pPr marL="0" indent="0">
+            <a:pPr indent="0" marL="0">
               <a:buNone/>
             </a:pPr>
             <a:r>
@@ -3799,7 +4040,7 @@
             <a:endParaRPr lang="en-US" sz="1300" dirty="0"/>
           </a:p>
           <a:p>
-            <a:pPr marL="0" indent="0">
+            <a:pPr indent="0" marL="0">
               <a:buNone/>
             </a:pPr>
             <a:r>
@@ -3816,7 +4057,7 @@
             <a:endParaRPr lang="en-US" sz="1300" dirty="0"/>
           </a:p>
           <a:p>
-            <a:pPr marL="0" indent="0">
+            <a:pPr indent="0" marL="0">
               <a:buNone/>
             </a:pPr>
             <a:r>
@@ -3855,7 +4096,7 @@
           <a:bodyPr wrap="square" lIns="0" tIns="0" rIns="0" bIns="0" rtlCol="0" anchor="ctr"/>
           <a:lstStyle/>
           <a:p>
-            <a:pPr marL="0" indent="0">
+            <a:pPr indent="0" marL="0">
               <a:buNone/>
             </a:pPr>
             <a:r>
@@ -3893,7 +4134,7 @@
           <a:bodyPr wrap="square" lIns="152400" tIns="152400" rIns="152400" bIns="152400" rtlCol="0" anchor="ctr"/>
           <a:lstStyle/>
           <a:p>
-            <a:pPr marL="0" indent="0">
+            <a:pPr indent="0" marL="0">
               <a:buNone/>
             </a:pPr>
             <a:r>
@@ -3989,7 +4230,7 @@
           </a:prstGeom>
           <a:extLst>
             <a:ext uri="{C572A759-6A51-4108-AA02-DFA0A04FC94B}">
-              <ma14:wrappingTextBoxFlag xmlns:ma14="http://schemas.microsoft.com/office/mac/drawingml/2011/main" xmlns="" val="0"/>
+              <ma14:wrappingTextBoxFlag xmlns:ma14="http://schemas.microsoft.com/office/mac/drawingml/2011/main" val="0"/>
             </a:ext>
           </a:extLst>
         </p:spPr>
@@ -4007,7 +4248,7 @@
           <a:p>
             <a:pPr algn="r"/>
             <a:fld id="{F7021451-1387-4CA6-816F-3879F97B5CBC}" type="slidenum">
-              <a:rPr lang="en-US" b="0"/>
+              <a:rPr b="0" lang="en-US"/>
               <a:t>12</a:t>
             </a:fld>
             <a:endParaRPr lang="en-US"/>
@@ -4042,11 +4283,9 @@
       <p:sp>
         <p:nvSpPr>
           <p:cNvPr id="2" name="Text 0"/>
-          <p:cNvSpPr>
-            <a:spLocks noGrp="1"/>
-          </p:cNvSpPr>
+          <p:cNvSpPr/>
           <p:nvPr>
-            <p:ph type="title" idx="100" hasCustomPrompt="1"/>
+            <p:ph idx="100" type="title" hasCustomPrompt="1"/>
           </p:nvPr>
         </p:nvSpPr>
         <p:spPr>
@@ -4064,7 +4303,7 @@
           <a:bodyPr wrap="square" rtlCol="0" anchor="ctr"/>
           <a:lstStyle/>
           <a:p>
-            <a:pPr marL="0" indent="0" algn="l">
+            <a:pPr algn="l" indent="0" marL="0">
               <a:buNone/>
             </a:pPr>
             <a:r>
@@ -4129,7 +4368,7 @@
           <a:bodyPr wrap="square" lIns="0" tIns="0" rIns="0" bIns="0" rtlCol="0" anchor="ctr"/>
           <a:lstStyle/>
           <a:p>
-            <a:pPr marL="0" indent="0" algn="ctr">
+            <a:pPr algn="ctr" indent="0" marL="0">
               <a:buNone/>
             </a:pPr>
             <a:r>
@@ -4165,7 +4404,7 @@
           <a:bodyPr wrap="square" lIns="0" tIns="0" rIns="0" bIns="0" rtlCol="0" anchor="ctr"/>
           <a:lstStyle/>
           <a:p>
-            <a:pPr marL="0" indent="0">
+            <a:pPr indent="0" marL="0">
               <a:buNone/>
             </a:pPr>
             <a:r>
@@ -4345,7 +4584,7 @@
           <a:bodyPr wrap="square" lIns="0" tIns="0" rIns="0" bIns="0" rtlCol="0" anchor="ctr"/>
           <a:lstStyle/>
           <a:p>
-            <a:pPr marL="0" indent="0" algn="ctr">
+            <a:pPr algn="ctr" indent="0" marL="0">
               <a:buNone/>
             </a:pPr>
             <a:r>
@@ -4381,7 +4620,7 @@
           <a:bodyPr wrap="square" lIns="0" tIns="0" rIns="0" bIns="0" rtlCol="0" anchor="ctr"/>
           <a:lstStyle/>
           <a:p>
-            <a:pPr marL="0" indent="0">
+            <a:pPr indent="0" marL="0">
               <a:buNone/>
             </a:pPr>
             <a:r>
@@ -4543,7 +4782,7 @@
           <a:bodyPr wrap="square" lIns="0" tIns="0" rIns="0" bIns="0" rtlCol="0" anchor="ctr"/>
           <a:lstStyle/>
           <a:p>
-            <a:pPr marL="0" indent="0" algn="ctr">
+            <a:pPr algn="ctr" indent="0" marL="0">
               <a:buNone/>
             </a:pPr>
             <a:r>
@@ -4579,7 +4818,7 @@
           <a:bodyPr wrap="square" lIns="0" tIns="0" rIns="0" bIns="0" rtlCol="0" anchor="ctr"/>
           <a:lstStyle/>
           <a:p>
-            <a:pPr marL="0" indent="0">
+            <a:pPr indent="0" marL="0">
               <a:buNone/>
             </a:pPr>
             <a:r>
@@ -4729,7 +4968,7 @@
           </a:prstGeom>
           <a:extLst>
             <a:ext uri="{C572A759-6A51-4108-AA02-DFA0A04FC94B}">
-              <ma14:wrappingTextBoxFlag xmlns:ma14="http://schemas.microsoft.com/office/mac/drawingml/2011/main" xmlns="" val="0"/>
+              <ma14:wrappingTextBoxFlag xmlns:ma14="http://schemas.microsoft.com/office/mac/drawingml/2011/main" val="0"/>
             </a:ext>
           </a:extLst>
         </p:spPr>
@@ -4747,7 +4986,7 @@
           <a:p>
             <a:pPr algn="r"/>
             <a:fld id="{F7021451-1387-4CA6-816F-3879F97B5CBC}" type="slidenum">
-              <a:rPr lang="en-US" b="0"/>
+              <a:rPr b="0" lang="en-US"/>
               <a:t>13</a:t>
             </a:fld>
             <a:endParaRPr lang="en-US"/>
@@ -4782,11 +5021,9 @@
       <p:sp>
         <p:nvSpPr>
           <p:cNvPr id="2" name="Text 0"/>
-          <p:cNvSpPr>
-            <a:spLocks noGrp="1"/>
-          </p:cNvSpPr>
+          <p:cNvSpPr/>
           <p:nvPr>
-            <p:ph type="title" idx="100" hasCustomPrompt="1"/>
+            <p:ph idx="100" type="title" hasCustomPrompt="1"/>
           </p:nvPr>
         </p:nvSpPr>
         <p:spPr>
@@ -4804,7 +5041,7 @@
           <a:bodyPr wrap="square" rtlCol="0" anchor="b"/>
           <a:lstStyle/>
           <a:p>
-            <a:pPr marL="0" indent="0">
+            <a:pPr indent="0" marL="0">
               <a:buNone/>
             </a:pPr>
             <a:r>
@@ -4822,11 +5059,9 @@
       <p:sp>
         <p:nvSpPr>
           <p:cNvPr id="3" name="Text 0"/>
-          <p:cNvSpPr>
-            <a:spLocks noGrp="1"/>
-          </p:cNvSpPr>
+          <p:cNvSpPr/>
           <p:nvPr>
-            <p:ph type="body" idx="101" hasCustomPrompt="1"/>
+            <p:ph idx="101" type="body" hasCustomPrompt="1"/>
           </p:nvPr>
         </p:nvSpPr>
         <p:spPr>
@@ -4844,7 +5079,7 @@
           <a:bodyPr wrap="square" rtlCol="0" anchor="t"/>
           <a:lstStyle/>
           <a:p>
-            <a:pPr marL="0" indent="0">
+            <a:pPr indent="0" marL="0">
               <a:buNone/>
             </a:pPr>
             <a:r>
@@ -4853,12 +5088,12 @@
                   <a:schemeClr val="accent6"/>
                 </a:solidFill>
               </a:rPr>
-              <a:t>Limits: synthetic corpus; draft L1 awaiting review; sycophancy gate not run yet; no cost model.</a:t>
+              <a:t>Limits: synthetic corpus; draft L1 awaiting review; sycophancy gate passed; no cost model.</a:t>
             </a:r>
             <a:endParaRPr lang="en-US" sz="1800" dirty="0"/>
           </a:p>
           <a:p>
-            <a:pPr marL="0" indent="0">
+            <a:pPr indent="0" marL="0">
               <a:buNone/>
             </a:pPr>
             <a:r>
@@ -4867,12 +5102,12 @@
                   <a:schemeClr val="accent6"/>
                 </a:solidFill>
               </a:rPr>
-              <a:t>Next: run the sycophancy gate live, review and verify L1, validate and apply the Terraform in a sandbox.</a:t>
+              <a:t>Next: review and verify L1, validate and apply the Terraform in a sandbox.</a:t>
             </a:r>
             <a:endParaRPr lang="en-US" sz="1800" dirty="0"/>
           </a:p>
           <a:p>
-            <a:pPr marL="0" indent="0">
+            <a:pPr indent="0" marL="0">
               <a:buNone/>
             </a:pPr>
             <a:r>
@@ -4915,11 +5150,9 @@
       <p:sp>
         <p:nvSpPr>
           <p:cNvPr id="2" name="Text 0"/>
-          <p:cNvSpPr>
-            <a:spLocks noGrp="1"/>
-          </p:cNvSpPr>
+          <p:cNvSpPr/>
           <p:nvPr>
-            <p:ph type="title" idx="100" hasCustomPrompt="1"/>
+            <p:ph idx="100" type="title" hasCustomPrompt="1"/>
           </p:nvPr>
         </p:nvSpPr>
         <p:spPr>
@@ -4937,7 +5170,7 @@
           <a:bodyPr wrap="square" rtlCol="0" anchor="ctr"/>
           <a:lstStyle/>
           <a:p>
-            <a:pPr marL="0" indent="0" algn="l">
+            <a:pPr algn="l" indent="0" marL="0">
               <a:buNone/>
             </a:pPr>
             <a:r>
@@ -5071,7 +5304,7 @@
           <a:bodyPr wrap="square" rtlCol="0" anchor="ctr"/>
           <a:lstStyle/>
           <a:p>
-            <a:pPr marL="0" indent="0" algn="ctr">
+            <a:pPr algn="ctr" indent="0" marL="0">
               <a:buNone/>
             </a:pPr>
             <a:r>
@@ -5107,7 +5340,7 @@
           <a:bodyPr wrap="square" lIns="0" tIns="0" rIns="0" bIns="0" rtlCol="0" anchor="ctr"/>
           <a:lstStyle/>
           <a:p>
-            <a:pPr marL="0" indent="0">
+            <a:pPr indent="0" marL="0">
               <a:buNone/>
             </a:pPr>
             <a:r>
@@ -5171,7 +5404,7 @@
           <a:bodyPr wrap="square" rtlCol="0" anchor="ctr"/>
           <a:lstStyle/>
           <a:p>
-            <a:pPr marL="0" indent="0" algn="ctr">
+            <a:pPr algn="ctr" indent="0" marL="0">
               <a:buNone/>
             </a:pPr>
             <a:r>
@@ -5207,7 +5440,7 @@
           <a:bodyPr wrap="square" lIns="0" tIns="0" rIns="0" bIns="0" rtlCol="0" anchor="ctr"/>
           <a:lstStyle/>
           <a:p>
-            <a:pPr marL="0" indent="0">
+            <a:pPr indent="0" marL="0">
               <a:buNone/>
             </a:pPr>
             <a:r>
@@ -5271,7 +5504,7 @@
           <a:bodyPr wrap="square" rtlCol="0" anchor="ctr"/>
           <a:lstStyle/>
           <a:p>
-            <a:pPr marL="0" indent="0" algn="ctr">
+            <a:pPr algn="ctr" indent="0" marL="0">
               <a:buNone/>
             </a:pPr>
             <a:r>
@@ -5307,7 +5540,7 @@
           <a:bodyPr wrap="square" lIns="0" tIns="0" rIns="0" bIns="0" rtlCol="0" anchor="ctr"/>
           <a:lstStyle/>
           <a:p>
-            <a:pPr marL="0" indent="0">
+            <a:pPr indent="0" marL="0">
               <a:buNone/>
             </a:pPr>
             <a:r>
@@ -5371,7 +5604,7 @@
           <a:bodyPr wrap="square" rtlCol="0" anchor="ctr"/>
           <a:lstStyle/>
           <a:p>
-            <a:pPr marL="0" indent="0" algn="ctr">
+            <a:pPr algn="ctr" indent="0" marL="0">
               <a:buNone/>
             </a:pPr>
             <a:r>
@@ -5407,7 +5640,7 @@
           <a:bodyPr wrap="square" lIns="0" tIns="0" rIns="0" bIns="0" rtlCol="0" anchor="ctr"/>
           <a:lstStyle/>
           <a:p>
-            <a:pPr marL="0" indent="0">
+            <a:pPr indent="0" marL="0">
               <a:buNone/>
             </a:pPr>
             <a:r>
@@ -5443,7 +5676,7 @@
           <a:bodyPr wrap="square" rtlCol="0" anchor="t"/>
           <a:lstStyle/>
           <a:p>
-            <a:pPr marL="0" indent="0">
+            <a:pPr indent="0" marL="0">
               <a:buNone/>
             </a:pPr>
             <a:r>
@@ -5478,7 +5711,7 @@
           </a:prstGeom>
           <a:extLst>
             <a:ext uri="{C572A759-6A51-4108-AA02-DFA0A04FC94B}">
-              <ma14:wrappingTextBoxFlag xmlns:ma14="http://schemas.microsoft.com/office/mac/drawingml/2011/main" xmlns="" val="0"/>
+              <ma14:wrappingTextBoxFlag xmlns:ma14="http://schemas.microsoft.com/office/mac/drawingml/2011/main" val="0"/>
             </a:ext>
           </a:extLst>
         </p:spPr>
@@ -5496,7 +5729,7 @@
           <a:p>
             <a:pPr algn="r"/>
             <a:fld id="{F7021451-1387-4CA6-816F-3879F97B5CBC}" type="slidenum">
-              <a:rPr lang="en-US" b="0"/>
+              <a:rPr b="0" lang="en-US"/>
               <a:t>2</a:t>
             </a:fld>
             <a:endParaRPr lang="en-US"/>
@@ -5531,11 +5764,9 @@
       <p:sp>
         <p:nvSpPr>
           <p:cNvPr id="2" name="Text 0"/>
-          <p:cNvSpPr>
-            <a:spLocks noGrp="1"/>
-          </p:cNvSpPr>
+          <p:cNvSpPr/>
           <p:nvPr>
-            <p:ph type="title" idx="100" hasCustomPrompt="1"/>
+            <p:ph idx="100" type="title" hasCustomPrompt="1"/>
           </p:nvPr>
         </p:nvSpPr>
         <p:spPr>
@@ -5553,7 +5784,7 @@
           <a:bodyPr wrap="square" rtlCol="0" anchor="ctr"/>
           <a:lstStyle/>
           <a:p>
-            <a:pPr marL="0" indent="0" algn="l">
+            <a:pPr algn="l" indent="0" marL="0">
               <a:buNone/>
             </a:pPr>
             <a:r>
@@ -5589,7 +5820,7 @@
           <a:bodyPr wrap="square" lIns="0" tIns="0" rIns="0" bIns="0" rtlCol="0" anchor="ctr"/>
           <a:lstStyle/>
           <a:p>
-            <a:pPr marL="0" indent="0">
+            <a:pPr indent="0" marL="0">
               <a:buNone/>
             </a:pPr>
             <a:r>
@@ -5628,7 +5859,7 @@
           <a:bodyPr wrap="square" lIns="0" tIns="0" rIns="0" bIns="0" rtlCol="0" anchor="t"/>
           <a:lstStyle/>
           <a:p>
-            <a:pPr marL="0" indent="0">
+            <a:pPr indent="0" marL="0">
               <a:buNone/>
             </a:pPr>
             <a:r>
@@ -5689,7 +5920,7 @@
           <a:bodyPr wrap="square" lIns="0" tIns="0" rIns="0" bIns="0" rtlCol="0" anchor="ctr"/>
           <a:lstStyle/>
           <a:p>
-            <a:pPr marL="0" indent="0">
+            <a:pPr indent="0" marL="0">
               <a:buNone/>
             </a:pPr>
             <a:r>
@@ -5728,7 +5959,7 @@
           <a:bodyPr wrap="square" lIns="0" tIns="0" rIns="0" bIns="0" rtlCol="0" anchor="t"/>
           <a:lstStyle/>
           <a:p>
-            <a:pPr marL="0" indent="0">
+            <a:pPr indent="0" marL="0">
               <a:buNone/>
             </a:pPr>
             <a:r>
@@ -5789,7 +6020,7 @@
           <a:bodyPr wrap="square" lIns="0" tIns="0" rIns="0" bIns="0" rtlCol="0" anchor="ctr"/>
           <a:lstStyle/>
           <a:p>
-            <a:pPr marL="0" indent="0">
+            <a:pPr indent="0" marL="0">
               <a:buNone/>
             </a:pPr>
             <a:r>
@@ -5828,7 +6059,7 @@
           <a:bodyPr wrap="square" lIns="0" tIns="0" rIns="0" bIns="0" rtlCol="0" anchor="t"/>
           <a:lstStyle/>
           <a:p>
-            <a:pPr marL="0" indent="0">
+            <a:pPr indent="0" marL="0">
               <a:buNone/>
             </a:pPr>
             <a:r>
@@ -5889,7 +6120,7 @@
           <a:bodyPr wrap="square" lIns="0" tIns="0" rIns="0" bIns="0" rtlCol="0" anchor="ctr"/>
           <a:lstStyle/>
           <a:p>
-            <a:pPr marL="0" indent="0">
+            <a:pPr indent="0" marL="0">
               <a:buNone/>
             </a:pPr>
             <a:r>
@@ -5928,7 +6159,7 @@
           <a:bodyPr wrap="square" lIns="0" tIns="0" rIns="0" bIns="0" rtlCol="0" anchor="t"/>
           <a:lstStyle/>
           <a:p>
-            <a:pPr marL="0" indent="0">
+            <a:pPr indent="0" marL="0">
               <a:buNone/>
             </a:pPr>
             <a:r>
@@ -5989,7 +6220,7 @@
           <a:bodyPr wrap="square" lIns="0" tIns="0" rIns="0" bIns="0" rtlCol="0" anchor="ctr"/>
           <a:lstStyle/>
           <a:p>
-            <a:pPr marL="0" indent="0">
+            <a:pPr indent="0" marL="0">
               <a:buNone/>
             </a:pPr>
             <a:r>
@@ -6028,7 +6259,7 @@
           <a:bodyPr wrap="square" lIns="0" tIns="0" rIns="0" bIns="0" rtlCol="0" anchor="t"/>
           <a:lstStyle/>
           <a:p>
-            <a:pPr marL="0" indent="0">
+            <a:pPr indent="0" marL="0">
               <a:buNone/>
             </a:pPr>
             <a:r>
@@ -6063,7 +6294,7 @@
           </a:prstGeom>
           <a:extLst>
             <a:ext uri="{C572A759-6A51-4108-AA02-DFA0A04FC94B}">
-              <ma14:wrappingTextBoxFlag xmlns:ma14="http://schemas.microsoft.com/office/mac/drawingml/2011/main" xmlns="" val="0"/>
+              <ma14:wrappingTextBoxFlag xmlns:ma14="http://schemas.microsoft.com/office/mac/drawingml/2011/main" val="0"/>
             </a:ext>
           </a:extLst>
         </p:spPr>
@@ -6081,7 +6312,7 @@
           <a:p>
             <a:pPr algn="r"/>
             <a:fld id="{F7021451-1387-4CA6-816F-3879F97B5CBC}" type="slidenum">
-              <a:rPr lang="en-US" b="0"/>
+              <a:rPr b="0" lang="en-US"/>
               <a:t>3</a:t>
             </a:fld>
             <a:endParaRPr lang="en-US"/>
@@ -6116,11 +6347,9 @@
       <p:sp>
         <p:nvSpPr>
           <p:cNvPr id="2" name="Text 0"/>
-          <p:cNvSpPr>
-            <a:spLocks noGrp="1"/>
-          </p:cNvSpPr>
+          <p:cNvSpPr/>
           <p:nvPr>
-            <p:ph type="title" idx="100" hasCustomPrompt="1"/>
+            <p:ph idx="100" type="title" hasCustomPrompt="1"/>
           </p:nvPr>
         </p:nvSpPr>
         <p:spPr>
@@ -6138,7 +6367,7 @@
           <a:bodyPr wrap="square" rtlCol="0" anchor="ctr"/>
           <a:lstStyle/>
           <a:p>
-            <a:pPr marL="0" indent="0" algn="l">
+            <a:pPr algn="l" indent="0" marL="0">
               <a:buNone/>
             </a:pPr>
             <a:r>
@@ -6174,7 +6403,7 @@
           <a:bodyPr wrap="square" lIns="0" tIns="0" rIns="0" bIns="0" rtlCol="0" anchor="ctr"/>
           <a:lstStyle/>
           <a:p>
-            <a:pPr marL="0" indent="0">
+            <a:pPr indent="0" marL="0">
               <a:buNone/>
             </a:pPr>
             <a:r>
@@ -6213,7 +6442,7 @@
           <a:bodyPr wrap="square" lIns="0" tIns="0" rIns="0" bIns="0" rtlCol="0" anchor="ctr"/>
           <a:lstStyle/>
           <a:p>
-            <a:pPr marL="0" indent="0">
+            <a:pPr indent="0" marL="0">
               <a:buNone/>
             </a:pPr>
             <a:r>
@@ -6253,7 +6482,7 @@
           <a:bodyPr wrap="square" lIns="0" tIns="0" rIns="0" bIns="0" rtlCol="0" anchor="ctr"/>
           <a:lstStyle/>
           <a:p>
-            <a:pPr marL="0" indent="0" algn="ctr">
+            <a:pPr algn="ctr" indent="0" marL="0">
               <a:buNone/>
             </a:pPr>
             <a:r>
@@ -6289,7 +6518,7 @@
           <a:bodyPr wrap="square" lIns="0" tIns="0" rIns="0" bIns="0" rtlCol="0" anchor="ctr"/>
           <a:lstStyle/>
           <a:p>
-            <a:pPr marL="0" indent="0">
+            <a:pPr indent="0" marL="0">
               <a:buNone/>
             </a:pPr>
             <a:r>
@@ -6325,7 +6554,7 @@
           <a:bodyPr wrap="square" lIns="0" tIns="0" rIns="0" bIns="0" rtlCol="0" anchor="ctr"/>
           <a:lstStyle/>
           <a:p>
-            <a:pPr marL="0" indent="0">
+            <a:pPr indent="0" marL="0">
               <a:buNone/>
             </a:pPr>
             <a:r>
@@ -6364,7 +6593,7 @@
           <a:bodyPr wrap="square" lIns="0" tIns="0" rIns="0" bIns="0" rtlCol="0" anchor="ctr"/>
           <a:lstStyle/>
           <a:p>
-            <a:pPr marL="0" indent="0">
+            <a:pPr indent="0" marL="0">
               <a:buNone/>
             </a:pPr>
             <a:r>
@@ -6404,7 +6633,7 @@
           <a:bodyPr wrap="square" lIns="0" tIns="0" rIns="0" bIns="0" rtlCol="0" anchor="ctr"/>
           <a:lstStyle/>
           <a:p>
-            <a:pPr marL="0" indent="0" algn="ctr">
+            <a:pPr algn="ctr" indent="0" marL="0">
               <a:buNone/>
             </a:pPr>
             <a:r>
@@ -6440,7 +6669,7 @@
           <a:bodyPr wrap="square" lIns="0" tIns="0" rIns="0" bIns="0" rtlCol="0" anchor="ctr"/>
           <a:lstStyle/>
           <a:p>
-            <a:pPr marL="0" indent="0">
+            <a:pPr indent="0" marL="0">
               <a:buNone/>
             </a:pPr>
             <a:r>
@@ -6476,7 +6705,7 @@
           <a:bodyPr wrap="square" lIns="0" tIns="0" rIns="0" bIns="0" rtlCol="0" anchor="ctr"/>
           <a:lstStyle/>
           <a:p>
-            <a:pPr marL="0" indent="0">
+            <a:pPr indent="0" marL="0">
               <a:buNone/>
             </a:pPr>
             <a:r>
@@ -6515,7 +6744,7 @@
           <a:bodyPr wrap="square" lIns="0" tIns="0" rIns="0" bIns="0" rtlCol="0" anchor="ctr"/>
           <a:lstStyle/>
           <a:p>
-            <a:pPr marL="0" indent="0">
+            <a:pPr indent="0" marL="0">
               <a:buNone/>
             </a:pPr>
             <a:r>
@@ -6555,7 +6784,7 @@
           <a:bodyPr wrap="square" lIns="0" tIns="0" rIns="0" bIns="0" rtlCol="0" anchor="ctr"/>
           <a:lstStyle/>
           <a:p>
-            <a:pPr marL="0" indent="0" algn="ctr">
+            <a:pPr algn="ctr" indent="0" marL="0">
               <a:buNone/>
             </a:pPr>
             <a:r>
@@ -6591,7 +6820,7 @@
           <a:bodyPr wrap="square" lIns="0" tIns="0" rIns="0" bIns="0" rtlCol="0" anchor="ctr"/>
           <a:lstStyle/>
           <a:p>
-            <a:pPr marL="0" indent="0">
+            <a:pPr indent="0" marL="0">
               <a:buNone/>
             </a:pPr>
             <a:r>
@@ -6627,7 +6856,7 @@
           <a:bodyPr wrap="square" lIns="0" tIns="0" rIns="0" bIns="0" rtlCol="0" anchor="ctr"/>
           <a:lstStyle/>
           <a:p>
-            <a:pPr marL="0" indent="0">
+            <a:pPr indent="0" marL="0">
               <a:buNone/>
             </a:pPr>
             <a:r>
@@ -6666,7 +6895,7 @@
           <a:bodyPr wrap="square" lIns="0" tIns="0" rIns="0" bIns="0" rtlCol="0" anchor="ctr"/>
           <a:lstStyle/>
           <a:p>
-            <a:pPr marL="0" indent="0">
+            <a:pPr indent="0" marL="0">
               <a:buNone/>
             </a:pPr>
             <a:r>
@@ -6706,7 +6935,7 @@
           <a:bodyPr wrap="square" lIns="0" tIns="0" rIns="0" bIns="0" rtlCol="0" anchor="ctr"/>
           <a:lstStyle/>
           <a:p>
-            <a:pPr marL="0" indent="0" algn="ctr">
+            <a:pPr algn="ctr" indent="0" marL="0">
               <a:buNone/>
             </a:pPr>
             <a:r>
@@ -6742,7 +6971,7 @@
           <a:bodyPr wrap="square" lIns="0" tIns="0" rIns="0" bIns="0" rtlCol="0" anchor="ctr"/>
           <a:lstStyle/>
           <a:p>
-            <a:pPr marL="0" indent="0">
+            <a:pPr indent="0" marL="0">
               <a:buNone/>
             </a:pPr>
             <a:r>
@@ -6778,7 +7007,7 @@
           <a:bodyPr wrap="square" lIns="0" tIns="0" rIns="0" bIns="0" rtlCol="0" anchor="ctr"/>
           <a:lstStyle/>
           <a:p>
-            <a:pPr marL="0" indent="0">
+            <a:pPr indent="0" marL="0">
               <a:buNone/>
             </a:pPr>
             <a:r>
@@ -6817,7 +7046,7 @@
           <a:bodyPr wrap="square" lIns="0" tIns="0" rIns="0" bIns="0" rtlCol="0" anchor="ctr"/>
           <a:lstStyle/>
           <a:p>
-            <a:pPr marL="0" indent="0">
+            <a:pPr indent="0" marL="0">
               <a:buNone/>
             </a:pPr>
             <a:r>
@@ -6857,7 +7086,7 @@
           <a:bodyPr wrap="square" lIns="0" tIns="0" rIns="0" bIns="0" rtlCol="0" anchor="ctr"/>
           <a:lstStyle/>
           <a:p>
-            <a:pPr marL="0" indent="0" algn="ctr">
+            <a:pPr algn="ctr" indent="0" marL="0">
               <a:buNone/>
             </a:pPr>
             <a:r>
@@ -6893,7 +7122,7 @@
           <a:bodyPr wrap="square" lIns="0" tIns="0" rIns="0" bIns="0" rtlCol="0" anchor="ctr"/>
           <a:lstStyle/>
           <a:p>
-            <a:pPr marL="0" indent="0">
+            <a:pPr indent="0" marL="0">
               <a:buNone/>
             </a:pPr>
             <a:r>
@@ -6929,7 +7158,7 @@
           <a:bodyPr wrap="square" lIns="0" tIns="0" rIns="0" bIns="0" rtlCol="0" anchor="ctr"/>
           <a:lstStyle/>
           <a:p>
-            <a:pPr marL="0" indent="0">
+            <a:pPr indent="0" marL="0">
               <a:buNone/>
             </a:pPr>
             <a:r>
@@ -6968,7 +7197,7 @@
           <a:bodyPr wrap="square" lIns="0" tIns="0" rIns="0" bIns="0" rtlCol="0" anchor="ctr"/>
           <a:lstStyle/>
           <a:p>
-            <a:pPr marL="0" indent="0">
+            <a:pPr indent="0" marL="0">
               <a:buNone/>
             </a:pPr>
             <a:r>
@@ -7008,7 +7237,7 @@
           <a:bodyPr wrap="square" lIns="0" tIns="0" rIns="0" bIns="0" rtlCol="0" anchor="ctr"/>
           <a:lstStyle/>
           <a:p>
-            <a:pPr marL="0" indent="0" algn="ctr">
+            <a:pPr algn="ctr" indent="0" marL="0">
               <a:buNone/>
             </a:pPr>
             <a:r>
@@ -7044,7 +7273,7 @@
           <a:bodyPr wrap="square" lIns="0" tIns="0" rIns="0" bIns="0" rtlCol="0" anchor="ctr"/>
           <a:lstStyle/>
           <a:p>
-            <a:pPr marL="0" indent="0">
+            <a:pPr indent="0" marL="0">
               <a:buNone/>
             </a:pPr>
             <a:r>
@@ -7061,7 +7290,7 @@
       </p:sp>
       <p:sp>
         <p:nvSpPr>
-          <p:cNvPr id="27" name="Slide Number Placeholder 0"/>
+          <p:cNvPr id="25" name="Slide Number Placeholder 0"/>
           <p:cNvSpPr>
             <a:spLocks noGrp="1"/>
           </p:cNvSpPr>
@@ -7079,7 +7308,7 @@
           </a:prstGeom>
           <a:extLst>
             <a:ext uri="{C572A759-6A51-4108-AA02-DFA0A04FC94B}">
-              <ma14:wrappingTextBoxFlag xmlns:ma14="http://schemas.microsoft.com/office/mac/drawingml/2011/main" xmlns="" val="0"/>
+              <ma14:wrappingTextBoxFlag xmlns:ma14="http://schemas.microsoft.com/office/mac/drawingml/2011/main" val="0"/>
             </a:ext>
           </a:extLst>
         </p:spPr>
@@ -7097,7 +7326,7 @@
           <a:p>
             <a:pPr algn="r"/>
             <a:fld id="{F7021451-1387-4CA6-816F-3879F97B5CBC}" type="slidenum">
-              <a:rPr lang="en-US" b="0"/>
+              <a:rPr b="0" lang="en-US"/>
               <a:t>4</a:t>
             </a:fld>
             <a:endParaRPr lang="en-US"/>
@@ -7132,11 +7361,9 @@
       <p:sp>
         <p:nvSpPr>
           <p:cNvPr id="2" name="Text 0"/>
-          <p:cNvSpPr>
-            <a:spLocks noGrp="1"/>
-          </p:cNvSpPr>
+          <p:cNvSpPr/>
           <p:nvPr>
-            <p:ph type="title" idx="100" hasCustomPrompt="1"/>
+            <p:ph idx="100" type="title" hasCustomPrompt="1"/>
           </p:nvPr>
         </p:nvSpPr>
         <p:spPr>
@@ -7154,7 +7381,7 @@
           <a:bodyPr wrap="square" rtlCol="0" anchor="ctr"/>
           <a:lstStyle/>
           <a:p>
-            <a:pPr marL="0" indent="0" algn="l">
+            <a:pPr algn="l" indent="0" marL="0">
               <a:buNone/>
             </a:pPr>
             <a:r>
@@ -7171,14 +7398,14 @@
       </p:sp>
       <p:pic>
         <p:nvPicPr>
-          <p:cNvPr id="3" name="aws-diagram" descr="C:\Projects\KGCR_Cloud_Project_2026\architecture\AWS_Architecture.png"/>
+          <p:cNvPr id="3" name="aws-diagram" descr="C:\Projects\KGCR_Cloud_Project_2026\architecture\AWS_Architecture.png">    </p:cNvPr>
           <p:cNvPicPr>
             <a:picLocks noChangeAspect="1"/>
           </p:cNvPicPr>
           <p:nvPr/>
         </p:nvPicPr>
         <p:blipFill>
-          <a:blip r:embed="rId3"/>
+          <a:blip r:embed="rId1"/>
           <a:stretch>
             <a:fillRect/>
           </a:stretch>
@@ -7218,7 +7445,7 @@
           <a:bodyPr wrap="square" lIns="0" tIns="0" rIns="0" bIns="0" rtlCol="0" anchor="ctr"/>
           <a:lstStyle/>
           <a:p>
-            <a:pPr marL="0" indent="0" algn="ctr">
+            <a:pPr algn="ctr" indent="0" marL="0">
               <a:buNone/>
             </a:pPr>
             <a:r>
@@ -7329,7 +7556,7 @@
           </a:prstGeom>
           <a:extLst>
             <a:ext uri="{C572A759-6A51-4108-AA02-DFA0A04FC94B}">
-              <ma14:wrappingTextBoxFlag xmlns:ma14="http://schemas.microsoft.com/office/mac/drawingml/2011/main" xmlns="" val="0"/>
+              <ma14:wrappingTextBoxFlag xmlns:ma14="http://schemas.microsoft.com/office/mac/drawingml/2011/main" val="0"/>
             </a:ext>
           </a:extLst>
         </p:spPr>
@@ -7347,7 +7574,7 @@
           <a:p>
             <a:pPr algn="r"/>
             <a:fld id="{F7021451-1387-4CA6-816F-3879F97B5CBC}" type="slidenum">
-              <a:rPr lang="en-US" b="0"/>
+              <a:rPr b="0" lang="en-US"/>
               <a:t>5</a:t>
             </a:fld>
             <a:endParaRPr lang="en-US"/>
@@ -7382,11 +7609,9 @@
       <p:sp>
         <p:nvSpPr>
           <p:cNvPr id="2" name="Text 0"/>
-          <p:cNvSpPr>
-            <a:spLocks noGrp="1"/>
-          </p:cNvSpPr>
+          <p:cNvSpPr/>
           <p:nvPr>
-            <p:ph type="title" idx="100" hasCustomPrompt="1"/>
+            <p:ph idx="100" type="title" hasCustomPrompt="1"/>
           </p:nvPr>
         </p:nvSpPr>
         <p:spPr>
@@ -7404,7 +7629,7 @@
           <a:bodyPr wrap="square" rtlCol="0" anchor="ctr"/>
           <a:lstStyle/>
           <a:p>
-            <a:pPr marL="0" indent="0" algn="l">
+            <a:pPr algn="l" indent="0" marL="0">
               <a:buNone/>
             </a:pPr>
             <a:r>
@@ -7421,14 +7646,14 @@
       </p:sp>
       <p:pic>
         <p:nvPicPr>
-          <p:cNvPr id="3" name="system-diagram" descr="C:\Projects\KGCR_Cloud_Project_2026\architecture\System_Architecture.png"/>
+          <p:cNvPr id="3" name="system-diagram" descr="C:\Projects\KGCR_Cloud_Project_2026\architecture\System_Architecture.png">    </p:cNvPr>
           <p:cNvPicPr>
             <a:picLocks noChangeAspect="1"/>
           </p:cNvPicPr>
           <p:nvPr/>
         </p:nvPicPr>
         <p:blipFill>
-          <a:blip r:embed="rId3"/>
+          <a:blip r:embed="rId1"/>
           <a:stretch>
             <a:fillRect/>
           </a:stretch>
@@ -7539,7 +7764,7 @@
           </a:prstGeom>
           <a:extLst>
             <a:ext uri="{C572A759-6A51-4108-AA02-DFA0A04FC94B}">
-              <ma14:wrappingTextBoxFlag xmlns:ma14="http://schemas.microsoft.com/office/mac/drawingml/2011/main" xmlns="" val="0"/>
+              <ma14:wrappingTextBoxFlag xmlns:ma14="http://schemas.microsoft.com/office/mac/drawingml/2011/main" val="0"/>
             </a:ext>
           </a:extLst>
         </p:spPr>
@@ -7557,7 +7782,7 @@
           <a:p>
             <a:pPr algn="r"/>
             <a:fld id="{F7021451-1387-4CA6-816F-3879F97B5CBC}" type="slidenum">
-              <a:rPr lang="en-US" b="0"/>
+              <a:rPr b="0" lang="en-US"/>
               <a:t>6</a:t>
             </a:fld>
             <a:endParaRPr lang="en-US"/>
@@ -7592,11 +7817,9 @@
       <p:sp>
         <p:nvSpPr>
           <p:cNvPr id="2" name="Text 0"/>
-          <p:cNvSpPr>
-            <a:spLocks noGrp="1"/>
-          </p:cNvSpPr>
+          <p:cNvSpPr/>
           <p:nvPr>
-            <p:ph type="title" idx="100" hasCustomPrompt="1"/>
+            <p:ph idx="100" type="title" hasCustomPrompt="1"/>
           </p:nvPr>
         </p:nvSpPr>
         <p:spPr>
@@ -7614,7 +7837,7 @@
           <a:bodyPr wrap="square" rtlCol="0" anchor="ctr"/>
           <a:lstStyle/>
           <a:p>
-            <a:pPr marL="0" indent="0" algn="l">
+            <a:pPr algn="l" indent="0" marL="0">
               <a:buNone/>
             </a:pPr>
             <a:r>
@@ -7650,7 +7873,7 @@
           <a:bodyPr wrap="square" lIns="0" tIns="0" rIns="0" bIns="0" rtlCol="0" anchor="ctr"/>
           <a:lstStyle/>
           <a:p>
-            <a:pPr marL="0" indent="0">
+            <a:pPr indent="0" marL="0">
               <a:buNone/>
             </a:pPr>
             <a:r>
@@ -7689,7 +7912,7 @@
           <a:bodyPr wrap="square" lIns="0" tIns="0" rIns="0" bIns="0" rtlCol="0" anchor="t"/>
           <a:lstStyle/>
           <a:p>
-            <a:pPr marL="0" indent="0">
+            <a:pPr indent="0" marL="0">
               <a:buNone/>
             </a:pPr>
             <a:r>
@@ -7725,7 +7948,7 @@
           <a:bodyPr wrap="square" lIns="0" tIns="0" rIns="0" bIns="0" rtlCol="0" anchor="ctr"/>
           <a:lstStyle/>
           <a:p>
-            <a:pPr marL="0" indent="0">
+            <a:pPr indent="0" marL="0">
               <a:buNone/>
             </a:pPr>
             <a:r>
@@ -7764,7 +7987,7 @@
           <a:bodyPr wrap="square" lIns="0" tIns="0" rIns="0" bIns="0" rtlCol="0" anchor="t"/>
           <a:lstStyle/>
           <a:p>
-            <a:pPr marL="0" indent="0">
+            <a:pPr indent="0" marL="0">
               <a:buNone/>
             </a:pPr>
             <a:r>
@@ -7800,7 +8023,7 @@
           <a:bodyPr wrap="square" lIns="0" tIns="0" rIns="0" bIns="0" rtlCol="0" anchor="ctr"/>
           <a:lstStyle/>
           <a:p>
-            <a:pPr marL="0" indent="0">
+            <a:pPr indent="0" marL="0">
               <a:buNone/>
             </a:pPr>
             <a:r>
@@ -7839,7 +8062,7 @@
           <a:bodyPr wrap="square" lIns="0" tIns="0" rIns="0" bIns="0" rtlCol="0" anchor="t"/>
           <a:lstStyle/>
           <a:p>
-            <a:pPr marL="0" indent="0">
+            <a:pPr indent="0" marL="0">
               <a:buNone/>
             </a:pPr>
             <a:r>
@@ -7875,7 +8098,7 @@
           <a:bodyPr wrap="square" lIns="0" tIns="0" rIns="0" bIns="0" rtlCol="0" anchor="ctr"/>
           <a:lstStyle/>
           <a:p>
-            <a:pPr marL="0" indent="0">
+            <a:pPr indent="0" marL="0">
               <a:buNone/>
             </a:pPr>
             <a:r>
@@ -7914,7 +8137,7 @@
           <a:bodyPr wrap="square" lIns="0" tIns="0" rIns="0" bIns="0" rtlCol="0" anchor="t"/>
           <a:lstStyle/>
           <a:p>
-            <a:pPr marL="0" indent="0">
+            <a:pPr indent="0" marL="0">
               <a:buNone/>
             </a:pPr>
             <a:r>
@@ -8050,7 +8273,7 @@
           </a:prstGeom>
           <a:extLst>
             <a:ext uri="{C572A759-6A51-4108-AA02-DFA0A04FC94B}">
-              <ma14:wrappingTextBoxFlag xmlns:ma14="http://schemas.microsoft.com/office/mac/drawingml/2011/main" xmlns="" val="0"/>
+              <ma14:wrappingTextBoxFlag xmlns:ma14="http://schemas.microsoft.com/office/mac/drawingml/2011/main" val="0"/>
             </a:ext>
           </a:extLst>
         </p:spPr>
@@ -8068,7 +8291,7 @@
           <a:p>
             <a:pPr algn="r"/>
             <a:fld id="{F7021451-1387-4CA6-816F-3879F97B5CBC}" type="slidenum">
-              <a:rPr lang="en-US" b="0"/>
+              <a:rPr b="0" lang="en-US"/>
               <a:t>7</a:t>
             </a:fld>
             <a:endParaRPr lang="en-US"/>
@@ -8103,11 +8326,9 @@
       <p:sp>
         <p:nvSpPr>
           <p:cNvPr id="2" name="Text 0"/>
-          <p:cNvSpPr>
-            <a:spLocks noGrp="1"/>
-          </p:cNvSpPr>
+          <p:cNvSpPr/>
           <p:nvPr>
-            <p:ph type="title" idx="100" hasCustomPrompt="1"/>
+            <p:ph idx="100" type="title" hasCustomPrompt="1"/>
           </p:nvPr>
         </p:nvSpPr>
         <p:spPr>
@@ -8125,7 +8346,7 @@
           <a:bodyPr wrap="square" rtlCol="0" anchor="ctr"/>
           <a:lstStyle/>
           <a:p>
-            <a:pPr marL="0" indent="0" algn="l">
+            <a:pPr algn="l" indent="0" marL="0">
               <a:buNone/>
             </a:pPr>
             <a:r>
@@ -8186,7 +8407,7 @@
           <a:bodyPr wrap="square" lIns="0" tIns="0" rIns="0" bIns="0" rtlCol="0" anchor="ctr"/>
           <a:lstStyle/>
           <a:p>
-            <a:pPr marL="0" indent="0">
+            <a:pPr indent="0" marL="0">
               <a:buNone/>
             </a:pPr>
             <a:r>
@@ -8225,7 +8446,7 @@
           <a:bodyPr wrap="square" lIns="0" tIns="0" rIns="0" bIns="0" rtlCol="0" anchor="t"/>
           <a:lstStyle/>
           <a:p>
-            <a:pPr marL="0" indent="0">
+            <a:pPr indent="0" marL="0">
               <a:buNone/>
             </a:pPr>
             <a:r>
@@ -8265,7 +8486,7 @@
           <a:bodyPr wrap="square" lIns="0" tIns="0" rIns="0" bIns="0" rtlCol="0" anchor="ctr"/>
           <a:lstStyle/>
           <a:p>
-            <a:pPr marL="0" indent="0" algn="ctr">
+            <a:pPr algn="ctr" indent="0" marL="0">
               <a:buNone/>
             </a:pPr>
             <a:r>
@@ -8326,7 +8547,7 @@
           <a:bodyPr wrap="square" lIns="0" tIns="0" rIns="0" bIns="0" rtlCol="0" anchor="ctr"/>
           <a:lstStyle/>
           <a:p>
-            <a:pPr marL="0" indent="0">
+            <a:pPr indent="0" marL="0">
               <a:buNone/>
             </a:pPr>
             <a:r>
@@ -8365,7 +8586,7 @@
           <a:bodyPr wrap="square" lIns="0" tIns="0" rIns="0" bIns="0" rtlCol="0" anchor="t"/>
           <a:lstStyle/>
           <a:p>
-            <a:pPr marL="0" indent="0">
+            <a:pPr indent="0" marL="0">
               <a:buNone/>
             </a:pPr>
             <a:r>
@@ -8405,7 +8626,7 @@
           <a:bodyPr wrap="square" lIns="0" tIns="0" rIns="0" bIns="0" rtlCol="0" anchor="ctr"/>
           <a:lstStyle/>
           <a:p>
-            <a:pPr marL="0" indent="0" algn="ctr">
+            <a:pPr algn="ctr" indent="0" marL="0">
               <a:buNone/>
             </a:pPr>
             <a:r>
@@ -8466,7 +8687,7 @@
           <a:bodyPr wrap="square" lIns="0" tIns="0" rIns="0" bIns="0" rtlCol="0" anchor="ctr"/>
           <a:lstStyle/>
           <a:p>
-            <a:pPr marL="0" indent="0">
+            <a:pPr indent="0" marL="0">
               <a:buNone/>
             </a:pPr>
             <a:r>
@@ -8505,7 +8726,7 @@
           <a:bodyPr wrap="square" lIns="0" tIns="0" rIns="0" bIns="0" rtlCol="0" anchor="t"/>
           <a:lstStyle/>
           <a:p>
-            <a:pPr marL="0" indent="0">
+            <a:pPr indent="0" marL="0">
               <a:buNone/>
             </a:pPr>
             <a:r>
@@ -8545,7 +8766,7 @@
           <a:bodyPr wrap="square" lIns="0" tIns="0" rIns="0" bIns="0" rtlCol="0" anchor="ctr"/>
           <a:lstStyle/>
           <a:p>
-            <a:pPr marL="0" indent="0" algn="ctr">
+            <a:pPr algn="ctr" indent="0" marL="0">
               <a:buNone/>
             </a:pPr>
             <a:r>
@@ -8606,7 +8827,7 @@
           <a:bodyPr wrap="square" lIns="0" tIns="0" rIns="0" bIns="0" rtlCol="0" anchor="ctr"/>
           <a:lstStyle/>
           <a:p>
-            <a:pPr marL="0" indent="0">
+            <a:pPr indent="0" marL="0">
               <a:buNone/>
             </a:pPr>
             <a:r>
@@ -8645,7 +8866,7 @@
           <a:bodyPr wrap="square" lIns="0" tIns="0" rIns="0" bIns="0" rtlCol="0" anchor="t"/>
           <a:lstStyle/>
           <a:p>
-            <a:pPr marL="0" indent="0">
+            <a:pPr indent="0" marL="0">
               <a:buNone/>
             </a:pPr>
             <a:r>
@@ -8685,7 +8906,7 @@
           <a:bodyPr wrap="square" lIns="0" tIns="0" rIns="0" bIns="0" rtlCol="0" anchor="ctr"/>
           <a:lstStyle/>
           <a:p>
-            <a:pPr marL="0" indent="0" algn="ctr">
+            <a:pPr algn="ctr" indent="0" marL="0">
               <a:buNone/>
             </a:pPr>
             <a:r>
@@ -8746,7 +8967,7 @@
           <a:bodyPr wrap="square" lIns="0" tIns="0" rIns="0" bIns="0" rtlCol="0" anchor="ctr"/>
           <a:lstStyle/>
           <a:p>
-            <a:pPr marL="0" indent="0">
+            <a:pPr indent="0" marL="0">
               <a:buNone/>
             </a:pPr>
             <a:r>
@@ -8785,7 +9006,7 @@
           <a:bodyPr wrap="square" lIns="0" tIns="0" rIns="0" bIns="0" rtlCol="0" anchor="t"/>
           <a:lstStyle/>
           <a:p>
-            <a:pPr marL="0" indent="0">
+            <a:pPr indent="0" marL="0">
               <a:buNone/>
             </a:pPr>
             <a:r>
@@ -8802,7 +9023,7 @@
       </p:sp>
       <p:sp>
         <p:nvSpPr>
-          <p:cNvPr id="22" name="chip-rules"/>
+          <p:cNvPr id="22" name="chip-runs"/>
           <p:cNvSpPr txBox="1"/>
           <p:nvPr/>
         </p:nvSpPr>
@@ -8817,7 +9038,7 @@
             </a:avLst>
           </a:prstGeom>
           <a:solidFill>
-            <a:schemeClr val="accent2"/>
+            <a:schemeClr val="accent1"/>
           </a:solidFill>
           <a:ln/>
         </p:spPr>
@@ -8825,7 +9046,7 @@
           <a:bodyPr wrap="square" lIns="0" tIns="0" rIns="0" bIns="0" rtlCol="0" anchor="ctr"/>
           <a:lstStyle/>
           <a:p>
-            <a:pPr marL="0" indent="0" algn="ctr">
+            <a:pPr algn="ctr" indent="0" marL="0">
               <a:buNone/>
             </a:pPr>
             <a:r>
@@ -8834,7 +9055,7 @@
                   <a:schemeClr val="bg1"/>
                 </a:solidFill>
               </a:rPr>
-              <a:t>Rule floor only</a:t>
+              <a:t>Runs today</a:t>
             </a:r>
             <a:endParaRPr lang="en-US" sz="1100" dirty="0"/>
           </a:p>
@@ -8886,7 +9107,7 @@
           <a:bodyPr wrap="square" lIns="0" tIns="0" rIns="0" bIns="0" rtlCol="0" anchor="ctr"/>
           <a:lstStyle/>
           <a:p>
-            <a:pPr marL="0" indent="0">
+            <a:pPr indent="0" marL="0">
               <a:buNone/>
             </a:pPr>
             <a:r>
@@ -8925,7 +9146,7 @@
           <a:bodyPr wrap="square" lIns="0" tIns="0" rIns="0" bIns="0" rtlCol="0" anchor="t"/>
           <a:lstStyle/>
           <a:p>
-            <a:pPr marL="0" indent="0">
+            <a:pPr indent="0" marL="0">
               <a:buNone/>
             </a:pPr>
             <a:r>
@@ -8965,7 +9186,7 @@
           <a:bodyPr wrap="square" lIns="0" tIns="0" rIns="0" bIns="0" rtlCol="0" anchor="ctr"/>
           <a:lstStyle/>
           <a:p>
-            <a:pPr marL="0" indent="0" algn="ctr">
+            <a:pPr algn="ctr" indent="0" marL="0">
               <a:buNone/>
             </a:pPr>
             <a:r>
@@ -9003,7 +9224,7 @@
           <a:bodyPr wrap="square" lIns="152400" tIns="152400" rIns="152400" bIns="152400" rtlCol="0" anchor="ctr"/>
           <a:lstStyle/>
           <a:p>
-            <a:pPr marL="0" indent="0">
+            <a:pPr indent="0" marL="0">
               <a:buNone/>
             </a:pPr>
             <a:r>
@@ -9073,7 +9294,7 @@
                   <a:schemeClr val="tx1"/>
                 </a:solidFill>
               </a:rPr>
-              <a:t>155 tests; ruff, ruff format, mypy (strict) and pytest all pass with PYTHONHASHSEED=0.</a:t>
+              <a:t>156 tests; ruff, ruff format, mypy (strict) and pytest all pass with PYTHONHASHSEED=0.</a:t>
             </a:r>
             <a:endParaRPr lang="en-US" sz="1500" dirty="0"/>
           </a:p>
@@ -9091,7 +9312,7 @@
                   <a:schemeClr val="tx1"/>
                 </a:solidFill>
               </a:rPr>
-              <a:t>The advisor's LLM path is built and tested offline; its live run waits on an API key.</a:t>
+              <a:t>The advisor's LLM path ran live once (16 recorded calls); sycophancy gate passed on 3 valid trials.</a:t>
             </a:r>
             <a:endParaRPr lang="en-US" sz="1500" dirty="0"/>
           </a:p>
@@ -9099,7 +9320,7 @@
       </p:sp>
       <p:sp>
         <p:nvSpPr>
-          <p:cNvPr id="29" name="Slide Number Placeholder 0"/>
+          <p:cNvPr id="25" name="Slide Number Placeholder 0"/>
           <p:cNvSpPr>
             <a:spLocks noGrp="1"/>
           </p:cNvSpPr>
@@ -9117,7 +9338,7 @@
           </a:prstGeom>
           <a:extLst>
             <a:ext uri="{C572A759-6A51-4108-AA02-DFA0A04FC94B}">
-              <ma14:wrappingTextBoxFlag xmlns:ma14="http://schemas.microsoft.com/office/mac/drawingml/2011/main" xmlns="" val="0"/>
+              <ma14:wrappingTextBoxFlag xmlns:ma14="http://schemas.microsoft.com/office/mac/drawingml/2011/main" val="0"/>
             </a:ext>
           </a:extLst>
         </p:spPr>
@@ -9135,7 +9356,7 @@
           <a:p>
             <a:pPr algn="r"/>
             <a:fld id="{F7021451-1387-4CA6-816F-3879F97B5CBC}" type="slidenum">
-              <a:rPr lang="en-US" b="0"/>
+              <a:rPr b="0" lang="en-US"/>
               <a:t>8</a:t>
             </a:fld>
             <a:endParaRPr lang="en-US"/>
@@ -9170,11 +9391,9 @@
       <p:sp>
         <p:nvSpPr>
           <p:cNvPr id="2" name="Text 0"/>
-          <p:cNvSpPr>
-            <a:spLocks noGrp="1"/>
-          </p:cNvSpPr>
+          <p:cNvSpPr/>
           <p:nvPr>
-            <p:ph type="title" idx="100" hasCustomPrompt="1"/>
+            <p:ph idx="100" type="title" hasCustomPrompt="1"/>
           </p:nvPr>
         </p:nvSpPr>
         <p:spPr>
@@ -9192,7 +9411,7 @@
           <a:bodyPr wrap="square" rtlCol="0" anchor="ctr"/>
           <a:lstStyle/>
           <a:p>
-            <a:pPr marL="0" indent="0" algn="l">
+            <a:pPr algn="l" indent="0" marL="0">
               <a:buNone/>
             </a:pPr>
             <a:r>
@@ -9209,7 +9428,7 @@
       </p:sp>
       <p:graphicFrame>
         <p:nvGraphicFramePr>
-          <p:cNvPr id="3" name="Chart 0"/>
+          <p:cNvPr id="3" name="Chart 0" descr=""/>
           <p:cNvGraphicFramePr/>
           <p:nvPr/>
         </p:nvGraphicFramePr>
@@ -9217,9 +9436,9 @@
           <a:off x="548640" y="1280160"/>
           <a:ext cx="6766560" cy="4846320"/>
         </p:xfrm>
-        <a:graphic>
+        <a:graphic xmlns:a="http://schemas.openxmlformats.org/drawingml/2006/main">
           <a:graphicData uri="http://schemas.openxmlformats.org/drawingml/2006/chart">
-            <c:chart xmlns:c="http://schemas.openxmlformats.org/drawingml/2006/chart" xmlns:r="http://schemas.openxmlformats.org/officeDocument/2006/relationships" r:id="rId3"/>
+            <c:chart xmlns:c="http://schemas.openxmlformats.org/drawingml/2006/chart" r:id="rId1"/>
           </a:graphicData>
         </a:graphic>
       </p:graphicFrame>
@@ -9319,7 +9538,7 @@
           </a:prstGeom>
           <a:extLst>
             <a:ext uri="{C572A759-6A51-4108-AA02-DFA0A04FC94B}">
-              <ma14:wrappingTextBoxFlag xmlns:ma14="http://schemas.microsoft.com/office/mac/drawingml/2011/main" xmlns="" val="0"/>
+              <ma14:wrappingTextBoxFlag xmlns:ma14="http://schemas.microsoft.com/office/mac/drawingml/2011/main" val="0"/>
             </a:ext>
           </a:extLst>
         </p:spPr>
@@ -9337,7 +9556,7 @@
           <a:p>
             <a:pPr algn="r"/>
             <a:fld id="{F7021451-1387-4CA6-816F-3879F97B5CBC}" type="slidenum">
-              <a:rPr lang="en-US" b="0"/>
+              <a:rPr b="0" lang="en-US"/>
               <a:t>9</a:t>
             </a:fld>
             <a:endParaRPr lang="en-US"/>
@@ -9645,299 +9864,4 @@
     </a:ext>
   </a:extLst>
 </a:theme>
-</file>
-
-<file path=ppt/theme/theme2.xml><?xml version="1.0" encoding="utf-8"?>
-<a:theme xmlns:a="http://schemas.openxmlformats.org/drawingml/2006/main" name="Office Theme">
-  <a:themeElements>
-    <a:clrScheme name="Office">
-      <a:dk1>
-        <a:sysClr val="windowText" lastClr="000000"/>
-      </a:dk1>
-      <a:lt1>
-        <a:sysClr val="window" lastClr="FFFFFF"/>
-      </a:lt1>
-      <a:dk2>
-        <a:srgbClr val="44546A"/>
-      </a:dk2>
-      <a:lt2>
-        <a:srgbClr val="E7E6E6"/>
-      </a:lt2>
-      <a:accent1>
-        <a:srgbClr val="4472C4"/>
-      </a:accent1>
-      <a:accent2>
-        <a:srgbClr val="ED7D31"/>
-      </a:accent2>
-      <a:accent3>
-        <a:srgbClr val="A5A5A5"/>
-      </a:accent3>
-      <a:accent4>
-        <a:srgbClr val="FFC000"/>
-      </a:accent4>
-      <a:accent5>
-        <a:srgbClr val="5B9BD5"/>
-      </a:accent5>
-      <a:accent6>
-        <a:srgbClr val="70AD47"/>
-      </a:accent6>
-      <a:hlink>
-        <a:srgbClr val="0563C1"/>
-      </a:hlink>
-      <a:folHlink>
-        <a:srgbClr val="954F72"/>
-      </a:folHlink>
-    </a:clrScheme>
-    <a:fontScheme name="Office">
-      <a:majorFont>
-        <a:latin typeface="Calibri Light" panose="020F0302020204030204"/>
-        <a:ea typeface=""/>
-        <a:cs typeface=""/>
-        <a:font script="Jpan" typeface="游ゴシック Light"/>
-        <a:font script="Hang" typeface="맑은 고딕"/>
-        <a:font script="Hans" typeface="等线 Light"/>
-        <a:font script="Hant" typeface="新細明體"/>
-        <a:font script="Arab" typeface="Times New Roman"/>
-        <a:font script="Hebr" typeface="Times New Roman"/>
-        <a:font script="Thai" typeface="Angsana New"/>
-        <a:font script="Ethi" typeface="Nyala"/>
-        <a:font script="Beng" typeface="Vrinda"/>
-        <a:font script="Gujr" typeface="Shruti"/>
-        <a:font script="Khmr" typeface="MoolBoran"/>
-        <a:font script="Knda" typeface="Tunga"/>
-        <a:font script="Guru" typeface="Raavi"/>
-        <a:font script="Cans" typeface="Euphemia"/>
-        <a:font script="Cher" typeface="Plantagenet Cherokee"/>
-        <a:font script="Yiii" typeface="Microsoft Yi Baiti"/>
-        <a:font script="Tibt" typeface="Microsoft Himalaya"/>
-        <a:font script="Thaa" typeface="MV Boli"/>
-        <a:font script="Deva" typeface="Mangal"/>
-        <a:font script="Telu" typeface="Gautami"/>
-        <a:font script="Taml" typeface="Latha"/>
-        <a:font script="Syrc" typeface="Estrangelo Edessa"/>
-        <a:font script="Orya" typeface="Kalinga"/>
-        <a:font script="Mlym" typeface="Kartika"/>
-        <a:font script="Laoo" typeface="DokChampa"/>
-        <a:font script="Sinh" typeface="Iskoola Pota"/>
-        <a:font script="Mong" typeface="Mongolian Baiti"/>
-        <a:font script="Viet" typeface="Times New Roman"/>
-        <a:font script="Uigh" typeface="Microsoft Uighur"/>
-        <a:font script="Geor" typeface="Sylfaen"/>
-        <a:font script="Armn" typeface="Arial"/>
-        <a:font script="Bugi" typeface="Leelawadee UI"/>
-        <a:font script="Bopo" typeface="Microsoft JhengHei"/>
-        <a:font script="Java" typeface="Javanese Text"/>
-        <a:font script="Lisu" typeface="Segoe UI"/>
-        <a:font script="Mymr" typeface="Myanmar Text"/>
-        <a:font script="Nkoo" typeface="Ebrima"/>
-        <a:font script="Olck" typeface="Nirmala UI"/>
-        <a:font script="Osma" typeface="Ebrima"/>
-        <a:font script="Phag" typeface="Phagspa"/>
-        <a:font script="Syrn" typeface="Estrangelo Edessa"/>
-        <a:font script="Syrj" typeface="Estrangelo Edessa"/>
-        <a:font script="Syre" typeface="Estrangelo Edessa"/>
-        <a:font script="Sora" typeface="Nirmala UI"/>
-        <a:font script="Tale" typeface="Microsoft Tai Le"/>
-        <a:font script="Talu" typeface="Microsoft New Tai Lue"/>
-        <a:font script="Tfng" typeface="Ebrima"/>
-      </a:majorFont>
-      <a:minorFont>
-        <a:latin typeface="Calibri" panose="020F0502020204030204"/>
-        <a:ea typeface=""/>
-        <a:cs typeface=""/>
-        <a:font script="Jpan" typeface="游ゴシック"/>
-        <a:font script="Hang" typeface="맑은 고딕"/>
-        <a:font script="Hans" typeface="等线"/>
-        <a:font script="Hant" typeface="新細明體"/>
-        <a:font script="Arab" typeface="Arial"/>
-        <a:font script="Hebr" typeface="Arial"/>
-        <a:font script="Thai" typeface="Cordia New"/>
-        <a:font script="Ethi" typeface="Nyala"/>
-        <a:font script="Beng" typeface="Vrinda"/>
-        <a:font script="Gujr" typeface="Shruti"/>
-        <a:font script="Khmr" typeface="DaunPenh"/>
-        <a:font script="Knda" typeface="Tunga"/>
-        <a:font script="Guru" typeface="Raavi"/>
-        <a:font script="Cans" typeface="Euphemia"/>
-        <a:font script="Cher" typeface="Plantagenet Cherokee"/>
-        <a:font script="Yiii" typeface="Microsoft Yi Baiti"/>
-        <a:font script="Tibt" typeface="Microsoft Himalaya"/>
-        <a:font script="Thaa" typeface="MV Boli"/>
-        <a:font script="Deva" typeface="Mangal"/>
-        <a:font script="Telu" typeface="Gautami"/>
-        <a:font script="Taml" typeface="Latha"/>
-        <a:font script="Syrc" typeface="Estrangelo Edessa"/>
-        <a:font script="Orya" typeface="Kalinga"/>
-        <a:font script="Mlym" typeface="Kartika"/>
-        <a:font script="Laoo" typeface="DokChampa"/>
-        <a:font script="Sinh" typeface="Iskoola Pota"/>
-        <a:font script="Mong" typeface="Mongolian Baiti"/>
-        <a:font script="Viet" typeface="Arial"/>
-        <a:font script="Uigh" typeface="Microsoft Uighur"/>
-        <a:font script="Geor" typeface="Sylfaen"/>
-        <a:font script="Armn" typeface="Arial"/>
-        <a:font script="Bugi" typeface="Leelawadee UI"/>
-        <a:font script="Bopo" typeface="Microsoft JhengHei"/>
-        <a:font script="Java" typeface="Javanese Text"/>
-        <a:font script="Lisu" typeface="Segoe UI"/>
-        <a:font script="Mymr" typeface="Myanmar Text"/>
-        <a:font script="Nkoo" typeface="Ebrima"/>
-        <a:font script="Olck" typeface="Nirmala UI"/>
-        <a:font script="Osma" typeface="Ebrima"/>
-        <a:font script="Phag" typeface="Phagspa"/>
-        <a:font script="Syrn" typeface="Estrangelo Edessa"/>
-        <a:font script="Syrj" typeface="Estrangelo Edessa"/>
-        <a:font script="Syre" typeface="Estrangelo Edessa"/>
-        <a:font script="Sora" typeface="Nirmala UI"/>
-        <a:font script="Tale" typeface="Microsoft Tai Le"/>
-        <a:font script="Talu" typeface="Microsoft New Tai Lue"/>
-        <a:font script="Tfng" typeface="Ebrima"/>
-      </a:minorFont>
-    </a:fontScheme>
-    <a:fmtScheme name="Office">
-      <a:fillStyleLst>
-        <a:solidFill>
-          <a:schemeClr val="phClr"/>
-        </a:solidFill>
-        <a:gradFill rotWithShape="1">
-          <a:gsLst>
-            <a:gs pos="0">
-              <a:schemeClr val="phClr">
-                <a:lumMod val="110000"/>
-                <a:satMod val="105000"/>
-                <a:tint val="67000"/>
-              </a:schemeClr>
-            </a:gs>
-            <a:gs pos="50000">
-              <a:schemeClr val="phClr">
-                <a:lumMod val="105000"/>
-                <a:satMod val="103000"/>
-                <a:tint val="73000"/>
-              </a:schemeClr>
-            </a:gs>
-            <a:gs pos="100000">
-              <a:schemeClr val="phClr">
-                <a:lumMod val="105000"/>
-                <a:satMod val="109000"/>
-                <a:tint val="81000"/>
-              </a:schemeClr>
-            </a:gs>
-          </a:gsLst>
-          <a:lin ang="5400000" scaled="0"/>
-        </a:gradFill>
-        <a:gradFill rotWithShape="1">
-          <a:gsLst>
-            <a:gs pos="0">
-              <a:schemeClr val="phClr">
-                <a:satMod val="103000"/>
-                <a:lumMod val="102000"/>
-                <a:tint val="94000"/>
-              </a:schemeClr>
-            </a:gs>
-            <a:gs pos="50000">
-              <a:schemeClr val="phClr">
-                <a:satMod val="110000"/>
-                <a:lumMod val="100000"/>
-                <a:shade val="100000"/>
-              </a:schemeClr>
-            </a:gs>
-            <a:gs pos="100000">
-              <a:schemeClr val="phClr">
-                <a:lumMod val="99000"/>
-                <a:satMod val="120000"/>
-                <a:shade val="78000"/>
-              </a:schemeClr>
-            </a:gs>
-          </a:gsLst>
-          <a:lin ang="5400000" scaled="0"/>
-        </a:gradFill>
-      </a:fillStyleLst>
-      <a:lnStyleLst>
-        <a:ln w="6350" cap="flat" cmpd="sng" algn="ctr">
-          <a:solidFill>
-            <a:schemeClr val="phClr"/>
-          </a:solidFill>
-          <a:prstDash val="solid"/>
-          <a:miter lim="800000"/>
-        </a:ln>
-        <a:ln w="12700" cap="flat" cmpd="sng" algn="ctr">
-          <a:solidFill>
-            <a:schemeClr val="phClr"/>
-          </a:solidFill>
-          <a:prstDash val="solid"/>
-          <a:miter lim="800000"/>
-        </a:ln>
-        <a:ln w="19050" cap="flat" cmpd="sng" algn="ctr">
-          <a:solidFill>
-            <a:schemeClr val="phClr"/>
-          </a:solidFill>
-          <a:prstDash val="solid"/>
-          <a:miter lim="800000"/>
-        </a:ln>
-      </a:lnStyleLst>
-      <a:effectStyleLst>
-        <a:effectStyle>
-          <a:effectLst/>
-        </a:effectStyle>
-        <a:effectStyle>
-          <a:effectLst/>
-        </a:effectStyle>
-        <a:effectStyle>
-          <a:effectLst>
-            <a:outerShdw blurRad="57150" dist="19050" dir="5400000" algn="ctr" rotWithShape="0">
-              <a:srgbClr val="000000">
-                <a:alpha val="63000"/>
-              </a:srgbClr>
-            </a:outerShdw>
-          </a:effectLst>
-        </a:effectStyle>
-      </a:effectStyleLst>
-      <a:bgFillStyleLst>
-        <a:solidFill>
-          <a:schemeClr val="phClr"/>
-        </a:solidFill>
-        <a:solidFill>
-          <a:schemeClr val="phClr">
-            <a:tint val="95000"/>
-            <a:satMod val="170000"/>
-          </a:schemeClr>
-        </a:solidFill>
-        <a:gradFill rotWithShape="1">
-          <a:gsLst>
-            <a:gs pos="0">
-              <a:schemeClr val="phClr">
-                <a:tint val="93000"/>
-                <a:satMod val="150000"/>
-                <a:shade val="98000"/>
-                <a:lumMod val="102000"/>
-              </a:schemeClr>
-            </a:gs>
-            <a:gs pos="50000">
-              <a:schemeClr val="phClr">
-                <a:tint val="98000"/>
-                <a:satMod val="130000"/>
-                <a:shade val="90000"/>
-                <a:lumMod val="103000"/>
-              </a:schemeClr>
-            </a:gs>
-            <a:gs pos="100000">
-              <a:schemeClr val="phClr">
-                <a:shade val="63000"/>
-                <a:satMod val="120000"/>
-              </a:schemeClr>
-            </a:gs>
-          </a:gsLst>
-          <a:lin ang="5400000" scaled="0"/>
-        </a:gradFill>
-      </a:bgFillStyleLst>
-    </a:fmtScheme>
-  </a:themeElements>
-  <a:objectDefaults/>
-  <a:extraClrSchemeLst/>
-  <a:extLst>
-    <a:ext uri="{05A4C25C-085E-4340-85A3-A5531E510DB2}">
-      <thm15:themeFamily xmlns:thm15="http://schemas.microsoft.com/office/thememl/2012/main" name="Office Theme" id="{62F939B6-93AF-4DB8-9C6B-D6C7DFDC589F}" vid="{4A3C46E8-61CC-4603-A589-7422A47A8E4A}"/>
-    </a:ext>
-  </a:extLst>
-</a:theme>
 </file>
</xml_diff>